<commit_message>
Use China calendar and regenerate June replay and presentation
</commit_message>
<xml_diff>
--- a/downloads/energy-campus-v3.2.pptx
+++ b/downloads/energy-campus-v3.2.pptx
@@ -2,22 +2,22 @@
 <file path=ppt/presentation.xml><?xml version="1.0" encoding="utf-8"?>
 <p:presentation xmlns:p="http://schemas.openxmlformats.org/presentationml/2006/main">
   <p:sldMasterIdLst>
-    <p:sldMasterId xmlns:r="http://schemas.openxmlformats.org/officeDocument/2006/relationships" id="2147483648" r:id="R5ba0d2bb49c6486f"/>
+    <p:sldMasterId xmlns:r="http://schemas.openxmlformats.org/officeDocument/2006/relationships" id="2147483648" r:id="R3f5fa770473e4c6b"/>
   </p:sldMasterIdLst>
   <p:notesMasterIdLst>
-    <p:notesMasterId xmlns:r="http://schemas.openxmlformats.org/officeDocument/2006/relationships" r:id="R1c22e8b41b2649ab"/>
+    <p:notesMasterId xmlns:r="http://schemas.openxmlformats.org/officeDocument/2006/relationships" r:id="R04635323602f4034"/>
   </p:notesMasterIdLst>
   <p:sldIdLst>
-    <p:sldId xmlns:r="http://schemas.openxmlformats.org/officeDocument/2006/relationships" id="256" r:id="R7cc00256fd59480d"/>
-    <p:sldId xmlns:r="http://schemas.openxmlformats.org/officeDocument/2006/relationships" id="257" r:id="Ree547a9e34424ab7"/>
-    <p:sldId xmlns:r="http://schemas.openxmlformats.org/officeDocument/2006/relationships" id="258" r:id="R7b6fe50f4fe7469a"/>
-    <p:sldId xmlns:r="http://schemas.openxmlformats.org/officeDocument/2006/relationships" id="259" r:id="R165e4c6f3cb24503"/>
-    <p:sldId xmlns:r="http://schemas.openxmlformats.org/officeDocument/2006/relationships" id="260" r:id="R9c61af31db79405b"/>
-    <p:sldId xmlns:r="http://schemas.openxmlformats.org/officeDocument/2006/relationships" id="261" r:id="Rc1042118e6c447de"/>
-    <p:sldId xmlns:r="http://schemas.openxmlformats.org/officeDocument/2006/relationships" id="262" r:id="R8d8b5c34d14b4446"/>
-    <p:sldId xmlns:r="http://schemas.openxmlformats.org/officeDocument/2006/relationships" id="263" r:id="R0b463ea38fe1416f"/>
-    <p:sldId xmlns:r="http://schemas.openxmlformats.org/officeDocument/2006/relationships" id="264" r:id="R4295455c3d1d4653"/>
-    <p:sldId xmlns:r="http://schemas.openxmlformats.org/officeDocument/2006/relationships" id="265" r:id="R62235dafaf0c47c9"/>
+    <p:sldId xmlns:r="http://schemas.openxmlformats.org/officeDocument/2006/relationships" id="256" r:id="R0a0ab0bfa8ba4400"/>
+    <p:sldId xmlns:r="http://schemas.openxmlformats.org/officeDocument/2006/relationships" id="257" r:id="R1551432448b54ef6"/>
+    <p:sldId xmlns:r="http://schemas.openxmlformats.org/officeDocument/2006/relationships" id="258" r:id="R0f246effaf47465b"/>
+    <p:sldId xmlns:r="http://schemas.openxmlformats.org/officeDocument/2006/relationships" id="259" r:id="Rca78d74019544a29"/>
+    <p:sldId xmlns:r="http://schemas.openxmlformats.org/officeDocument/2006/relationships" id="260" r:id="R136691f3480b4990"/>
+    <p:sldId xmlns:r="http://schemas.openxmlformats.org/officeDocument/2006/relationships" id="261" r:id="R76ad8bafd13a47e5"/>
+    <p:sldId xmlns:r="http://schemas.openxmlformats.org/officeDocument/2006/relationships" id="262" r:id="Ref6de3c7b2514141"/>
+    <p:sldId xmlns:r="http://schemas.openxmlformats.org/officeDocument/2006/relationships" id="263" r:id="Rb9c08efcd0e5488e"/>
+    <p:sldId xmlns:r="http://schemas.openxmlformats.org/officeDocument/2006/relationships" id="264" r:id="R1c7d1c3469d9470a"/>
+    <p:sldId xmlns:r="http://schemas.openxmlformats.org/officeDocument/2006/relationships" id="265" r:id="R6a276c7df31948f0"/>
   </p:sldIdLst>
   <p:sldSz cx="12192000" cy="6858000"/>
   <p:notesSz cx="6858000" cy="9144000"/>
@@ -461,7 +461,7 @@
           </a:p>
           <a:p xmlns:a="http://schemas.openxmlformats.org/drawingml/2006/main">
             <a:r>
-              <a:t>results/v32/jobs/6623649e55247c05-summary.json SHA256 1e4a8b5e0169ca8e3eac4be40202cd3fdf160a5057a680fe0adb28a7e2d128db</a:t>
+              <a:t>results/v32/jobs/310912a4ad924de6-summary.json SHA256 7274d16c5508057ac956a9056930a3b4b4e9fab4f664c1c707be827a50ca8ac1</a:t>
             </a:r>
           </a:p>
           <a:p xmlns:a="http://schemas.openxmlformats.org/drawingml/2006/main">
@@ -476,7 +476,7 @@
           </a:p>
           <a:p xmlns:a="http://schemas.openxmlformats.org/drawingml/2006/main">
             <a:r>
-              <a:t>SimBench https://simbench.de/en/download/datasets/ ODbL1.0 / DbCL1.0。原始2016曲线映射到2026场景，非实测。公开回放 https://jinyh.github.io/energy-campus/ 。月度示范与72小时RSI研究分别记账。</a:t>
+              <a:t>SimBench https://simbench.de/en/download/datasets/ ODbL1.0 / DbCL1.0。德国原始2016曲线按连续时段映射到中国时区2026仿真场景，非中国园区实测。公开回放 https://jinyh.github.io/energy-campus/ 。月度示范与72小时RSI研究分别记账。</a:t>
             </a:r>
           </a:p>
         </p:txBody>
@@ -556,7 +556,7 @@
           </a:p>
           <a:p xmlns:a="http://schemas.openxmlformats.org/drawingml/2006/main">
             <a:r>
-              <a:t>results/v32/jobs/6623649e55247c05-summary.json SHA256 1e4a8b5e0169ca8e3eac4be40202cd3fdf160a5057a680fe0adb28a7e2d128db</a:t>
+              <a:t>results/v32/jobs/310912a4ad924de6-summary.json SHA256 7274d16c5508057ac956a9056930a3b4b4e9fab4f664c1c707be827a50ca8ac1</a:t>
             </a:r>
           </a:p>
           <a:p xmlns:a="http://schemas.openxmlformats.org/drawingml/2006/main">
@@ -571,7 +571,7 @@
           </a:p>
           <a:p xmlns:a="http://schemas.openxmlformats.org/drawingml/2006/main">
             <a:r>
-              <a:t>SimBench https://simbench.de/en/download/datasets/ ODbL1.0 / DbCL1.0。原始2016曲线映射到2026场景，非实测。公开回放 https://jinyh.github.io/energy-campus/ 。月度示范与72小时RSI研究分别记账。</a:t>
+              <a:t>SimBench https://simbench.de/en/download/datasets/ ODbL1.0 / DbCL1.0。德国原始2016曲线按连续时段映射到中国时区2026仿真场景，非中国园区实测。公开回放 https://jinyh.github.io/energy-campus/ 。月度示范与72小时RSI研究分别记账。</a:t>
             </a:r>
           </a:p>
         </p:txBody>
@@ -651,7 +651,7 @@
           </a:p>
           <a:p xmlns:a="http://schemas.openxmlformats.org/drawingml/2006/main">
             <a:r>
-              <a:t>results/v32/jobs/6623649e55247c05-summary.json SHA256 1e4a8b5e0169ca8e3eac4be40202cd3fdf160a5057a680fe0adb28a7e2d128db</a:t>
+              <a:t>results/v32/jobs/310912a4ad924de6-summary.json SHA256 7274d16c5508057ac956a9056930a3b4b4e9fab4f664c1c707be827a50ca8ac1</a:t>
             </a:r>
           </a:p>
           <a:p xmlns:a="http://schemas.openxmlformats.org/drawingml/2006/main">
@@ -666,7 +666,7 @@
           </a:p>
           <a:p xmlns:a="http://schemas.openxmlformats.org/drawingml/2006/main">
             <a:r>
-              <a:t>SimBench https://simbench.de/en/download/datasets/ ODbL1.0 / DbCL1.0。原始2016曲线映射到2026场景，非实测。公开回放 https://jinyh.github.io/energy-campus/ 。月度示范与72小时RSI研究分别记账。</a:t>
+              <a:t>SimBench https://simbench.de/en/download/datasets/ ODbL1.0 / DbCL1.0。德国原始2016曲线按连续时段映射到中国时区2026仿真场景，非中国园区实测。公开回放 https://jinyh.github.io/energy-campus/ 。月度示范与72小时RSI研究分别记账。</a:t>
             </a:r>
           </a:p>
         </p:txBody>
@@ -746,7 +746,7 @@
           </a:p>
           <a:p xmlns:a="http://schemas.openxmlformats.org/drawingml/2006/main">
             <a:r>
-              <a:t>results/v32/jobs/6623649e55247c05-summary.json SHA256 1e4a8b5e0169ca8e3eac4be40202cd3fdf160a5057a680fe0adb28a7e2d128db</a:t>
+              <a:t>results/v32/jobs/310912a4ad924de6-summary.json SHA256 7274d16c5508057ac956a9056930a3b4b4e9fab4f664c1c707be827a50ca8ac1</a:t>
             </a:r>
           </a:p>
           <a:p xmlns:a="http://schemas.openxmlformats.org/drawingml/2006/main">
@@ -761,7 +761,7 @@
           </a:p>
           <a:p xmlns:a="http://schemas.openxmlformats.org/drawingml/2006/main">
             <a:r>
-              <a:t>SimBench https://simbench.de/en/download/datasets/ ODbL1.0 / DbCL1.0。原始2016曲线映射到2026场景，非实测。公开回放 https://jinyh.github.io/energy-campus/ 。月度示范与72小时RSI研究分别记账。</a:t>
+              <a:t>SimBench https://simbench.de/en/download/datasets/ ODbL1.0 / DbCL1.0。德国原始2016曲线按连续时段映射到中国时区2026仿真场景，非中国园区实测。公开回放 https://jinyh.github.io/energy-campus/ 。月度示范与72小时RSI研究分别记账。</a:t>
             </a:r>
           </a:p>
         </p:txBody>
@@ -841,7 +841,7 @@
           </a:p>
           <a:p xmlns:a="http://schemas.openxmlformats.org/drawingml/2006/main">
             <a:r>
-              <a:t>results/v32/jobs/6623649e55247c05-summary.json SHA256 1e4a8b5e0169ca8e3eac4be40202cd3fdf160a5057a680fe0adb28a7e2d128db</a:t>
+              <a:t>results/v32/jobs/310912a4ad924de6-summary.json SHA256 7274d16c5508057ac956a9056930a3b4b4e9fab4f664c1c707be827a50ca8ac1</a:t>
             </a:r>
           </a:p>
           <a:p xmlns:a="http://schemas.openxmlformats.org/drawingml/2006/main">
@@ -856,7 +856,7 @@
           </a:p>
           <a:p xmlns:a="http://schemas.openxmlformats.org/drawingml/2006/main">
             <a:r>
-              <a:t>SimBench https://simbench.de/en/download/datasets/ ODbL1.0 / DbCL1.0。原始2016曲线映射到2026场景，非实测。公开回放 https://jinyh.github.io/energy-campus/ 。月度示范与72小时RSI研究分别记账。</a:t>
+              <a:t>SimBench https://simbench.de/en/download/datasets/ ODbL1.0 / DbCL1.0。德国原始2016曲线按连续时段映射到中国时区2026仿真场景，非中国园区实测。公开回放 https://jinyh.github.io/energy-campus/ 。月度示范与72小时RSI研究分别记账。</a:t>
             </a:r>
           </a:p>
         </p:txBody>
@@ -936,7 +936,7 @@
           </a:p>
           <a:p xmlns:a="http://schemas.openxmlformats.org/drawingml/2006/main">
             <a:r>
-              <a:t>results/v32/jobs/6623649e55247c05-summary.json SHA256 1e4a8b5e0169ca8e3eac4be40202cd3fdf160a5057a680fe0adb28a7e2d128db</a:t>
+              <a:t>results/v32/jobs/310912a4ad924de6-summary.json SHA256 7274d16c5508057ac956a9056930a3b4b4e9fab4f664c1c707be827a50ca8ac1</a:t>
             </a:r>
           </a:p>
           <a:p xmlns:a="http://schemas.openxmlformats.org/drawingml/2006/main">
@@ -951,7 +951,7 @@
           </a:p>
           <a:p xmlns:a="http://schemas.openxmlformats.org/drawingml/2006/main">
             <a:r>
-              <a:t>SimBench https://simbench.de/en/download/datasets/ ODbL1.0 / DbCL1.0。原始2016曲线映射到2026场景，非实测。公开回放 https://jinyh.github.io/energy-campus/ 。月度示范与72小时RSI研究分别记账。</a:t>
+              <a:t>SimBench https://simbench.de/en/download/datasets/ ODbL1.0 / DbCL1.0。德国原始2016曲线按连续时段映射到中国时区2026仿真场景，非中国园区实测。公开回放 https://jinyh.github.io/energy-campus/ 。月度示范与72小时RSI研究分别记账。</a:t>
             </a:r>
           </a:p>
         </p:txBody>
@@ -1031,7 +1031,7 @@
           </a:p>
           <a:p xmlns:a="http://schemas.openxmlformats.org/drawingml/2006/main">
             <a:r>
-              <a:t>results/v32/jobs/6623649e55247c05-summary.json SHA256 1e4a8b5e0169ca8e3eac4be40202cd3fdf160a5057a680fe0adb28a7e2d128db</a:t>
+              <a:t>results/v32/jobs/310912a4ad924de6-summary.json SHA256 7274d16c5508057ac956a9056930a3b4b4e9fab4f664c1c707be827a50ca8ac1</a:t>
             </a:r>
           </a:p>
           <a:p xmlns:a="http://schemas.openxmlformats.org/drawingml/2006/main">
@@ -1046,7 +1046,7 @@
           </a:p>
           <a:p xmlns:a="http://schemas.openxmlformats.org/drawingml/2006/main">
             <a:r>
-              <a:t>SimBench https://simbench.de/en/download/datasets/ ODbL1.0 / DbCL1.0。原始2016曲线映射到2026场景，非实测。公开回放 https://jinyh.github.io/energy-campus/ 。月度示范与72小时RSI研究分别记账。</a:t>
+              <a:t>SimBench https://simbench.de/en/download/datasets/ ODbL1.0 / DbCL1.0。德国原始2016曲线按连续时段映射到中国时区2026仿真场景，非中国园区实测。公开回放 https://jinyh.github.io/energy-campus/ 。月度示范与72小时RSI研究分别记账。</a:t>
             </a:r>
           </a:p>
         </p:txBody>
@@ -1126,7 +1126,7 @@
           </a:p>
           <a:p xmlns:a="http://schemas.openxmlformats.org/drawingml/2006/main">
             <a:r>
-              <a:t>results/v32/jobs/6623649e55247c05-summary.json SHA256 1e4a8b5e0169ca8e3eac4be40202cd3fdf160a5057a680fe0adb28a7e2d128db</a:t>
+              <a:t>results/v32/jobs/310912a4ad924de6-summary.json SHA256 7274d16c5508057ac956a9056930a3b4b4e9fab4f664c1c707be827a50ca8ac1</a:t>
             </a:r>
           </a:p>
           <a:p xmlns:a="http://schemas.openxmlformats.org/drawingml/2006/main">
@@ -1141,7 +1141,7 @@
           </a:p>
           <a:p xmlns:a="http://schemas.openxmlformats.org/drawingml/2006/main">
             <a:r>
-              <a:t>SimBench https://simbench.de/en/download/datasets/ ODbL1.0 / DbCL1.0。原始2016曲线映射到2026场景，非实测。公开回放 https://jinyh.github.io/energy-campus/ 。月度示范与72小时RSI研究分别记账。</a:t>
+              <a:t>SimBench https://simbench.de/en/download/datasets/ ODbL1.0 / DbCL1.0。德国原始2016曲线按连续时段映射到中国时区2026仿真场景，非中国园区实测。公开回放 https://jinyh.github.io/energy-campus/ 。月度示范与72小时RSI研究分别记账。</a:t>
             </a:r>
           </a:p>
         </p:txBody>
@@ -1221,7 +1221,7 @@
           </a:p>
           <a:p xmlns:a="http://schemas.openxmlformats.org/drawingml/2006/main">
             <a:r>
-              <a:t>results/v32/jobs/6623649e55247c05-summary.json SHA256 1e4a8b5e0169ca8e3eac4be40202cd3fdf160a5057a680fe0adb28a7e2d128db</a:t>
+              <a:t>results/v32/jobs/310912a4ad924de6-summary.json SHA256 7274d16c5508057ac956a9056930a3b4b4e9fab4f664c1c707be827a50ca8ac1</a:t>
             </a:r>
           </a:p>
           <a:p xmlns:a="http://schemas.openxmlformats.org/drawingml/2006/main">
@@ -1236,7 +1236,7 @@
           </a:p>
           <a:p xmlns:a="http://schemas.openxmlformats.org/drawingml/2006/main">
             <a:r>
-              <a:t>SimBench https://simbench.de/en/download/datasets/ ODbL1.0 / DbCL1.0。原始2016曲线映射到2026场景，非实测。公开回放 https://jinyh.github.io/energy-campus/ 。月度示范与72小时RSI研究分别记账。</a:t>
+              <a:t>SimBench https://simbench.de/en/download/datasets/ ODbL1.0 / DbCL1.0。德国原始2016曲线按连续时段映射到中国时区2026仿真场景，非中国园区实测。公开回放 https://jinyh.github.io/energy-campus/ 。月度示范与72小时RSI研究分别记账。</a:t>
             </a:r>
           </a:p>
         </p:txBody>
@@ -1316,7 +1316,7 @@
           </a:p>
           <a:p xmlns:a="http://schemas.openxmlformats.org/drawingml/2006/main">
             <a:r>
-              <a:t>results/v32/jobs/6623649e55247c05-summary.json SHA256 1e4a8b5e0169ca8e3eac4be40202cd3fdf160a5057a680fe0adb28a7e2d128db</a:t>
+              <a:t>results/v32/jobs/310912a4ad924de6-summary.json SHA256 7274d16c5508057ac956a9056930a3b4b4e9fab4f664c1c707be827a50ca8ac1</a:t>
             </a:r>
           </a:p>
           <a:p xmlns:a="http://schemas.openxmlformats.org/drawingml/2006/main">
@@ -1331,7 +1331,7 @@
           </a:p>
           <a:p xmlns:a="http://schemas.openxmlformats.org/drawingml/2006/main">
             <a:r>
-              <a:t>SimBench https://simbench.de/en/download/datasets/ ODbL1.0 / DbCL1.0。原始2016曲线映射到2026场景，非实测。公开回放 https://jinyh.github.io/energy-campus/ 。月度示范与72小时RSI研究分别记账。</a:t>
+              <a:t>SimBench https://simbench.de/en/download/datasets/ ODbL1.0 / DbCL1.0。德国原始2016曲线按连续时段映射到中国时区2026仿真场景，非中国园区实测。公开回放 https://jinyh.github.io/energy-campus/ 。月度示范与72小时RSI研究分别记账。</a:t>
             </a:r>
           </a:p>
         </p:txBody>
@@ -1399,7 +1399,7 @@
   </p:cSld>
   <p:clrMap bg1="lt1" tx1="dk1" bg2="lt2" tx2="dk2" accent1="accent1" accent2="accent2" accent3="accent3" accent4="accent4" accent5="accent5" accent6="accent6" hlink="hlink" folHlink="folHlink"/>
   <p:sldLayoutIdLst>
-    <p:sldLayoutId xmlns:r="http://schemas.openxmlformats.org/officeDocument/2006/relationships" id="2147483649" r:id="R69e3cbd7930b4c85"/>
+    <p:sldLayoutId xmlns:r="http://schemas.openxmlformats.org/officeDocument/2006/relationships" id="2147483649" r:id="R37977c17f9654495"/>
   </p:sldLayoutIdLst>
   <p:txStyles>
     <p:titleStyle>
@@ -1950,7 +1950,7 @@
           <p:cNvPr id="10" name="">
             <a:extLst xmlns:a="http://schemas.openxmlformats.org/drawingml/2006/main">
               <a:ext uri="{FF2B5EF4-FFF2-40B4-BE49-F238E27FC236}">
-                <a16:creationId xmlns:a16="http://schemas.microsoft.com/office/drawing/2014/main" id="{CC577FD4-3D1E-4E8D-82B2-8BB6759AAE7B}"/>
+                <a16:creationId xmlns:a16="http://schemas.microsoft.com/office/drawing/2014/main" id="{6FAB16E6-B35F-42D1-97D8-FAC519314CF7}"/>
               </a:ext>
             </a:extLst>
           </p:cNvPr>
@@ -2007,7 +2007,7 @@
           <p:cNvPr id="2" name="">
             <a:extLst xmlns:a="http://schemas.openxmlformats.org/drawingml/2006/main">
               <a:ext uri="{FF2B5EF4-FFF2-40B4-BE49-F238E27FC236}">
-                <a16:creationId xmlns:a16="http://schemas.microsoft.com/office/drawing/2014/main" id="{5100903D-BA61-4D24-B0E4-502CEE0121CE}"/>
+                <a16:creationId xmlns:a16="http://schemas.microsoft.com/office/drawing/2014/main" id="{89200A78-D99B-4F2F-BB81-E68A00811D5F}"/>
               </a:ext>
             </a:extLst>
           </p:cNvPr>
@@ -2064,7 +2064,7 @@
           <p:cNvPr id="3" name="">
             <a:extLst xmlns:a="http://schemas.openxmlformats.org/drawingml/2006/main">
               <a:ext uri="{FF2B5EF4-FFF2-40B4-BE49-F238E27FC236}">
-                <a16:creationId xmlns:a16="http://schemas.microsoft.com/office/drawing/2014/main" id="{00D01AD9-82EB-44DC-9B30-476A03983EF0}"/>
+                <a16:creationId xmlns:a16="http://schemas.microsoft.com/office/drawing/2014/main" id="{03ADDE1F-457B-45E8-8ECC-D1FCC2DEA446}"/>
               </a:ext>
             </a:extLst>
           </p:cNvPr>
@@ -2094,7 +2094,7 @@
           <p:cNvPr id="4" name="">
             <a:extLst xmlns:a="http://schemas.openxmlformats.org/drawingml/2006/main">
               <a:ext uri="{FF2B5EF4-FFF2-40B4-BE49-F238E27FC236}">
-                <a16:creationId xmlns:a16="http://schemas.microsoft.com/office/drawing/2014/main" id="{9FE6044B-005B-4C40-94D7-C655350752C4}"/>
+                <a16:creationId xmlns:a16="http://schemas.microsoft.com/office/drawing/2014/main" id="{FC6BECF2-CEB5-444A-A07F-1CD29BBFD41E}"/>
               </a:ext>
             </a:extLst>
           </p:cNvPr>
@@ -2151,7 +2151,7 @@
           <p:cNvPr id="5" name="">
             <a:extLst xmlns:a="http://schemas.openxmlformats.org/drawingml/2006/main">
               <a:ext uri="{FF2B5EF4-FFF2-40B4-BE49-F238E27FC236}">
-                <a16:creationId xmlns:a16="http://schemas.microsoft.com/office/drawing/2014/main" id="{8E4CA84E-4C1B-4F36-959E-2AAB58161DD5}"/>
+                <a16:creationId xmlns:a16="http://schemas.microsoft.com/office/drawing/2014/main" id="{30F801E1-00E7-43F7-BDA0-BF9E893EA0C3}"/>
               </a:ext>
             </a:extLst>
           </p:cNvPr>
@@ -2208,7 +2208,7 @@
           <p:cNvPr id="6" name="">
             <a:extLst xmlns:a="http://schemas.openxmlformats.org/drawingml/2006/main">
               <a:ext uri="{FF2B5EF4-FFF2-40B4-BE49-F238E27FC236}">
-                <a16:creationId xmlns:a16="http://schemas.microsoft.com/office/drawing/2014/main" id="{04E9FBDC-D65D-458E-A0BC-B201798FBC89}"/>
+                <a16:creationId xmlns:a16="http://schemas.microsoft.com/office/drawing/2014/main" id="{AE306A13-90D7-491F-87FA-D5B2A2EF556C}"/>
               </a:ext>
             </a:extLst>
           </p:cNvPr>
@@ -2265,7 +2265,7 @@
           <p:cNvPr id="7" name="">
             <a:extLst xmlns:a="http://schemas.openxmlformats.org/drawingml/2006/main">
               <a:ext uri="{FF2B5EF4-FFF2-40B4-BE49-F238E27FC236}">
-                <a16:creationId xmlns:a16="http://schemas.microsoft.com/office/drawing/2014/main" id="{FA412B07-1FC1-4B75-A873-0C3D87A402E3}"/>
+                <a16:creationId xmlns:a16="http://schemas.microsoft.com/office/drawing/2014/main" id="{07EDAF15-BE45-417B-BC16-20D42EEA9E86}"/>
               </a:ext>
             </a:extLst>
           </p:cNvPr>
@@ -2312,7 +2312,7 @@
                 <a:ea typeface="Hiragino Sans GB"/>
                 <a:cs typeface="Hiragino Sans GB"/>
               </a:rPr>
-              <a:t>基于 SimBench 2016 年历史曲线；RSI 优势待验证</a:t>
+              <a:t>北京时间 UTC+08:00 · SimBench 德国历史曲线 · RSI 优势待验证</a:t>
             </a:r>
           </a:p>
         </p:txBody>
@@ -2322,7 +2322,7 @@
           <p:cNvPr id="8" name="">
             <a:extLst xmlns:a="http://schemas.openxmlformats.org/drawingml/2006/main">
               <a:ext uri="{FF2B5EF4-FFF2-40B4-BE49-F238E27FC236}">
-                <a16:creationId xmlns:a16="http://schemas.microsoft.com/office/drawing/2014/main" id="{73A5B71D-BBE0-4782-881A-9066AE17886A}"/>
+                <a16:creationId xmlns:a16="http://schemas.microsoft.com/office/drawing/2014/main" id="{0C2831B2-926C-46AE-992A-095DD6BB9CC7}"/>
               </a:ext>
             </a:extLst>
           </p:cNvPr>
@@ -2379,7 +2379,7 @@
           <p:cNvPr id="9" name="">
             <a:extLst xmlns:a="http://schemas.openxmlformats.org/drawingml/2006/main">
               <a:ext uri="{FF2B5EF4-FFF2-40B4-BE49-F238E27FC236}">
-                <a16:creationId xmlns:a16="http://schemas.microsoft.com/office/drawing/2014/main" id="{F5406DDE-27A3-4D1F-A530-57C5E6EB2E0F}"/>
+                <a16:creationId xmlns:a16="http://schemas.microsoft.com/office/drawing/2014/main" id="{4E0F35AA-5ED6-440D-834F-0C05A583B6EB}"/>
               </a:ext>
             </a:extLst>
           </p:cNvPr>
@@ -2434,7 +2434,7 @@
     </p:spTree>
     <p:extLst>
       <p:ext uri="{BB962C8B-B14F-4D97-AF65-F5344CB8AC3E}">
-        <p14:creationId xmlns:p14="http://schemas.microsoft.com/office/powerpoint/2010/main" val="114962447"/>
+        <p14:creationId xmlns:p14="http://schemas.microsoft.com/office/powerpoint/2010/main" val="2130466238"/>
       </p:ext>
     </p:extLst>
   </p:cSld>
@@ -2465,7 +2465,7 @@
           <p:cNvPr id="8" name="">
             <a:extLst xmlns:a="http://schemas.openxmlformats.org/drawingml/2006/main">
               <a:ext uri="{FF2B5EF4-FFF2-40B4-BE49-F238E27FC236}">
-                <a16:creationId xmlns:a16="http://schemas.microsoft.com/office/drawing/2014/main" id="{950EF750-F9FF-4FE9-B96C-E441BD1D82BA}"/>
+                <a16:creationId xmlns:a16="http://schemas.microsoft.com/office/drawing/2014/main" id="{FA3A0715-4DD2-44B7-84CC-DE605BB5DFB7}"/>
               </a:ext>
             </a:extLst>
           </p:cNvPr>
@@ -2522,7 +2522,7 @@
           <p:cNvPr id="2" name="">
             <a:extLst xmlns:a="http://schemas.openxmlformats.org/drawingml/2006/main">
               <a:ext uri="{FF2B5EF4-FFF2-40B4-BE49-F238E27FC236}">
-                <a16:creationId xmlns:a16="http://schemas.microsoft.com/office/drawing/2014/main" id="{50B302C2-747C-495B-AF47-A95F79852D3F}"/>
+                <a16:creationId xmlns:a16="http://schemas.microsoft.com/office/drawing/2014/main" id="{95CF7467-852D-41D6-9936-DA2C91E9719E}"/>
               </a:ext>
             </a:extLst>
           </p:cNvPr>
@@ -2579,7 +2579,7 @@
           <p:cNvPr id="3" name="">
             <a:extLst xmlns:a="http://schemas.openxmlformats.org/drawingml/2006/main">
               <a:ext uri="{FF2B5EF4-FFF2-40B4-BE49-F238E27FC236}">
-                <a16:creationId xmlns:a16="http://schemas.microsoft.com/office/drawing/2014/main" id="{541F75EF-B1A2-44FC-80B1-C8D664EC9E3C}"/>
+                <a16:creationId xmlns:a16="http://schemas.microsoft.com/office/drawing/2014/main" id="{6A48B518-4D27-4D9E-94C4-160CEF993DC5}"/>
               </a:ext>
             </a:extLst>
           </p:cNvPr>
@@ -2613,13 +2613,13 @@
           <p:nvPr/>
         </p:nvPicPr>
         <p:blipFill>
-          <a:blip xmlns:r="http://schemas.openxmlformats.org/officeDocument/2006/relationships" xmlns:a="http://schemas.openxmlformats.org/drawingml/2006/main" r:embed="Rc73ed6c20b794ea4"/>
+          <a:blip xmlns:r="http://schemas.openxmlformats.org/officeDocument/2006/relationships" xmlns:a="http://schemas.openxmlformats.org/drawingml/2006/main" r:embed="R1a6c540e70364577"/>
           <a:stretch xmlns:a="http://schemas.openxmlformats.org/drawingml/2006/main"/>
         </p:blipFill>
         <p:spPr>
           <a:xfrm xmlns:a="http://schemas.openxmlformats.org/drawingml/2006/main">
-            <a:off x="2497667" y="1647825"/>
-            <a:ext cx="7196667" cy="4048125"/>
+            <a:off x="2495910" y="1647825"/>
+            <a:ext cx="7200181" cy="4048125"/>
           </a:xfrm>
           <a:prstGeom xmlns:a="http://schemas.openxmlformats.org/drawingml/2006/main" prst="rect">
             <a:avLst/>
@@ -2631,7 +2631,7 @@
           <p:cNvPr id="5" name="">
             <a:extLst xmlns:a="http://schemas.openxmlformats.org/drawingml/2006/main">
               <a:ext uri="{FF2B5EF4-FFF2-40B4-BE49-F238E27FC236}">
-                <a16:creationId xmlns:a16="http://schemas.microsoft.com/office/drawing/2014/main" id="{FBABCCB9-98AC-470F-9F75-A6D7B3DC4775}"/>
+                <a16:creationId xmlns:a16="http://schemas.microsoft.com/office/drawing/2014/main" id="{A4E97DC5-1E73-404E-9614-9CB5ACEB4A36}"/>
               </a:ext>
             </a:extLst>
           </p:cNvPr>
@@ -2688,7 +2688,7 @@
           <p:cNvPr id="6" name="">
             <a:extLst xmlns:a="http://schemas.openxmlformats.org/drawingml/2006/main">
               <a:ext uri="{FF2B5EF4-FFF2-40B4-BE49-F238E27FC236}">
-                <a16:creationId xmlns:a16="http://schemas.microsoft.com/office/drawing/2014/main" id="{F6073B1D-A081-4531-A660-E3407A11BD69}"/>
+                <a16:creationId xmlns:a16="http://schemas.microsoft.com/office/drawing/2014/main" id="{2D700125-ECB7-466F-92DD-8B5BE6B67769}"/>
               </a:ext>
             </a:extLst>
           </p:cNvPr>
@@ -2745,7 +2745,7 @@
           <p:cNvPr id="7" name="">
             <a:extLst xmlns:a="http://schemas.openxmlformats.org/drawingml/2006/main">
               <a:ext uri="{FF2B5EF4-FFF2-40B4-BE49-F238E27FC236}">
-                <a16:creationId xmlns:a16="http://schemas.microsoft.com/office/drawing/2014/main" id="{397EFAF0-7FAE-49CE-A181-5D1A1245B444}"/>
+                <a16:creationId xmlns:a16="http://schemas.microsoft.com/office/drawing/2014/main" id="{6A2DA870-3A74-481E-AF60-A38E9F35F875}"/>
               </a:ext>
             </a:extLst>
           </p:cNvPr>
@@ -2800,7 +2800,7 @@
     </p:spTree>
     <p:extLst>
       <p:ext uri="{BB962C8B-B14F-4D97-AF65-F5344CB8AC3E}">
-        <p14:creationId xmlns:p14="http://schemas.microsoft.com/office/powerpoint/2010/main" val="1641978735"/>
+        <p14:creationId xmlns:p14="http://schemas.microsoft.com/office/powerpoint/2010/main" val="63532293"/>
       </p:ext>
     </p:extLst>
   </p:cSld>
@@ -2831,7 +2831,7 @@
           <p:cNvPr id="8" name="">
             <a:extLst xmlns:a="http://schemas.openxmlformats.org/drawingml/2006/main">
               <a:ext uri="{FF2B5EF4-FFF2-40B4-BE49-F238E27FC236}">
-                <a16:creationId xmlns:a16="http://schemas.microsoft.com/office/drawing/2014/main" id="{CDCF0396-FC32-4AE3-BF57-0927589C61A8}"/>
+                <a16:creationId xmlns:a16="http://schemas.microsoft.com/office/drawing/2014/main" id="{E24C8DE7-FF24-4836-91A3-E827F0D2067C}"/>
               </a:ext>
             </a:extLst>
           </p:cNvPr>
@@ -2888,7 +2888,7 @@
           <p:cNvPr id="2" name="">
             <a:extLst xmlns:a="http://schemas.openxmlformats.org/drawingml/2006/main">
               <a:ext uri="{FF2B5EF4-FFF2-40B4-BE49-F238E27FC236}">
-                <a16:creationId xmlns:a16="http://schemas.microsoft.com/office/drawing/2014/main" id="{63CF9514-FBC5-48F4-8AE7-F473019DF17F}"/>
+                <a16:creationId xmlns:a16="http://schemas.microsoft.com/office/drawing/2014/main" id="{FF2E91F5-B43E-40B1-B637-40228B94A389}"/>
               </a:ext>
             </a:extLst>
           </p:cNvPr>
@@ -2945,7 +2945,7 @@
           <p:cNvPr id="3" name="">
             <a:extLst xmlns:a="http://schemas.openxmlformats.org/drawingml/2006/main">
               <a:ext uri="{FF2B5EF4-FFF2-40B4-BE49-F238E27FC236}">
-                <a16:creationId xmlns:a16="http://schemas.microsoft.com/office/drawing/2014/main" id="{896B3534-FED4-4323-83A2-1125D43C9399}"/>
+                <a16:creationId xmlns:a16="http://schemas.microsoft.com/office/drawing/2014/main" id="{83314C91-2D7E-498C-BEB5-56B0C98DDC51}"/>
               </a:ext>
             </a:extLst>
           </p:cNvPr>
@@ -2979,13 +2979,13 @@
           <p:nvPr/>
         </p:nvPicPr>
         <p:blipFill>
-          <a:blip xmlns:r="http://schemas.openxmlformats.org/officeDocument/2006/relationships" xmlns:a="http://schemas.openxmlformats.org/drawingml/2006/main" r:embed="R88637f9dbfd841c4"/>
+          <a:blip xmlns:r="http://schemas.openxmlformats.org/officeDocument/2006/relationships" xmlns:a="http://schemas.openxmlformats.org/drawingml/2006/main" r:embed="R2081866906294fed"/>
           <a:stretch xmlns:a="http://schemas.openxmlformats.org/drawingml/2006/main"/>
         </p:blipFill>
         <p:spPr>
           <a:xfrm xmlns:a="http://schemas.openxmlformats.org/drawingml/2006/main">
-            <a:off x="2497667" y="1647825"/>
-            <a:ext cx="7196667" cy="4048125"/>
+            <a:off x="2495910" y="1647825"/>
+            <a:ext cx="7200181" cy="4048125"/>
           </a:xfrm>
           <a:prstGeom xmlns:a="http://schemas.openxmlformats.org/drawingml/2006/main" prst="rect">
             <a:avLst/>
@@ -2997,7 +2997,7 @@
           <p:cNvPr id="5" name="">
             <a:extLst xmlns:a="http://schemas.openxmlformats.org/drawingml/2006/main">
               <a:ext uri="{FF2B5EF4-FFF2-40B4-BE49-F238E27FC236}">
-                <a16:creationId xmlns:a16="http://schemas.microsoft.com/office/drawing/2014/main" id="{0CE5FC9C-431E-4064-A00C-DCFB1C4072EE}"/>
+                <a16:creationId xmlns:a16="http://schemas.microsoft.com/office/drawing/2014/main" id="{2172051E-E332-403B-98C6-E6570C3A853E}"/>
               </a:ext>
             </a:extLst>
           </p:cNvPr>
@@ -3054,7 +3054,7 @@
           <p:cNvPr id="6" name="">
             <a:extLst xmlns:a="http://schemas.openxmlformats.org/drawingml/2006/main">
               <a:ext uri="{FF2B5EF4-FFF2-40B4-BE49-F238E27FC236}">
-                <a16:creationId xmlns:a16="http://schemas.microsoft.com/office/drawing/2014/main" id="{DF6B1180-5920-4AF3-994B-1279F22AC051}"/>
+                <a16:creationId xmlns:a16="http://schemas.microsoft.com/office/drawing/2014/main" id="{CFA15197-5FF9-44C6-A2DE-528BAC6061CB}"/>
               </a:ext>
             </a:extLst>
           </p:cNvPr>
@@ -3111,7 +3111,7 @@
           <p:cNvPr id="7" name="">
             <a:extLst xmlns:a="http://schemas.openxmlformats.org/drawingml/2006/main">
               <a:ext uri="{FF2B5EF4-FFF2-40B4-BE49-F238E27FC236}">
-                <a16:creationId xmlns:a16="http://schemas.microsoft.com/office/drawing/2014/main" id="{79EE9CE2-0C45-45C7-B978-7C664E869D74}"/>
+                <a16:creationId xmlns:a16="http://schemas.microsoft.com/office/drawing/2014/main" id="{A0538160-CE8C-4C49-8ECD-ADF6D4E27FF4}"/>
               </a:ext>
             </a:extLst>
           </p:cNvPr>
@@ -3166,7 +3166,7 @@
     </p:spTree>
     <p:extLst>
       <p:ext uri="{BB962C8B-B14F-4D97-AF65-F5344CB8AC3E}">
-        <p14:creationId xmlns:p14="http://schemas.microsoft.com/office/powerpoint/2010/main" val="1516997080"/>
+        <p14:creationId xmlns:p14="http://schemas.microsoft.com/office/powerpoint/2010/main" val="1494143419"/>
       </p:ext>
     </p:extLst>
   </p:cSld>
@@ -3197,7 +3197,7 @@
           <p:cNvPr id="8" name="">
             <a:extLst xmlns:a="http://schemas.openxmlformats.org/drawingml/2006/main">
               <a:ext uri="{FF2B5EF4-FFF2-40B4-BE49-F238E27FC236}">
-                <a16:creationId xmlns:a16="http://schemas.microsoft.com/office/drawing/2014/main" id="{5A61B7D1-5B40-4163-9966-6E8D3FCF0047}"/>
+                <a16:creationId xmlns:a16="http://schemas.microsoft.com/office/drawing/2014/main" id="{08B01845-76EF-47BD-8526-5F4A1CE77715}"/>
               </a:ext>
             </a:extLst>
           </p:cNvPr>
@@ -3254,7 +3254,7 @@
           <p:cNvPr id="2" name="">
             <a:extLst xmlns:a="http://schemas.openxmlformats.org/drawingml/2006/main">
               <a:ext uri="{FF2B5EF4-FFF2-40B4-BE49-F238E27FC236}">
-                <a16:creationId xmlns:a16="http://schemas.microsoft.com/office/drawing/2014/main" id="{24FC4216-3BEC-4F9B-BBF5-78E84C266B45}"/>
+                <a16:creationId xmlns:a16="http://schemas.microsoft.com/office/drawing/2014/main" id="{3DEC15E0-B232-4617-A946-45002B21B0E7}"/>
               </a:ext>
             </a:extLst>
           </p:cNvPr>
@@ -3311,7 +3311,7 @@
           <p:cNvPr id="3" name="">
             <a:extLst xmlns:a="http://schemas.openxmlformats.org/drawingml/2006/main">
               <a:ext uri="{FF2B5EF4-FFF2-40B4-BE49-F238E27FC236}">
-                <a16:creationId xmlns:a16="http://schemas.microsoft.com/office/drawing/2014/main" id="{8FF38FD6-0479-4D24-B62A-25FC6E5FB3D8}"/>
+                <a16:creationId xmlns:a16="http://schemas.microsoft.com/office/drawing/2014/main" id="{827853FE-F4CD-44BA-9BD1-3BCB1EE7CC8F}"/>
               </a:ext>
             </a:extLst>
           </p:cNvPr>
@@ -3451,7 +3451,7 @@
                           <a:ea typeface="Hiragino Sans GB"/>
                           <a:cs typeface="Hiragino Sans GB"/>
                         </a:rPr>
-                        <a:t>2026 年 6 月；2,880 × 15 分钟；Europe/Berlin</a:t>
+                        <a:t>2026 年 6 月；2,880 × 15 分钟；北京时间 UTC+08:00</a:t>
                       </a:r>
                     </a:p>
                   </a:txBody>
@@ -3741,7 +3741,7 @@
           <p:cNvPr id="5" name="">
             <a:extLst xmlns:a="http://schemas.openxmlformats.org/drawingml/2006/main">
               <a:ext uri="{FF2B5EF4-FFF2-40B4-BE49-F238E27FC236}">
-                <a16:creationId xmlns:a16="http://schemas.microsoft.com/office/drawing/2014/main" id="{C0A814EF-2B02-44C9-9BBB-572575E511A5}"/>
+                <a16:creationId xmlns:a16="http://schemas.microsoft.com/office/drawing/2014/main" id="{9D4F397D-CA35-4759-A90D-3E7F4113C838}"/>
               </a:ext>
             </a:extLst>
           </p:cNvPr>
@@ -3798,7 +3798,7 @@
           <p:cNvPr id="6" name="">
             <a:extLst xmlns:a="http://schemas.openxmlformats.org/drawingml/2006/main">
               <a:ext uri="{FF2B5EF4-FFF2-40B4-BE49-F238E27FC236}">
-                <a16:creationId xmlns:a16="http://schemas.microsoft.com/office/drawing/2014/main" id="{1606BF03-32E9-4E84-9A84-2DB28238A4BF}"/>
+                <a16:creationId xmlns:a16="http://schemas.microsoft.com/office/drawing/2014/main" id="{C9B49941-EAE1-45D4-ADB5-FD1C3E2A3B3A}"/>
               </a:ext>
             </a:extLst>
           </p:cNvPr>
@@ -3855,7 +3855,7 @@
           <p:cNvPr id="7" name="">
             <a:extLst xmlns:a="http://schemas.openxmlformats.org/drawingml/2006/main">
               <a:ext uri="{FF2B5EF4-FFF2-40B4-BE49-F238E27FC236}">
-                <a16:creationId xmlns:a16="http://schemas.microsoft.com/office/drawing/2014/main" id="{C0F179A2-C9BC-4A8B-84C3-0E40A130135F}"/>
+                <a16:creationId xmlns:a16="http://schemas.microsoft.com/office/drawing/2014/main" id="{53E2EAAB-7FF0-4478-9D64-29AF8CCF3193}"/>
               </a:ext>
             </a:extLst>
           </p:cNvPr>
@@ -3910,7 +3910,7 @@
     </p:spTree>
     <p:extLst>
       <p:ext uri="{BB962C8B-B14F-4D97-AF65-F5344CB8AC3E}">
-        <p14:creationId xmlns:p14="http://schemas.microsoft.com/office/powerpoint/2010/main" val="1855307619"/>
+        <p14:creationId xmlns:p14="http://schemas.microsoft.com/office/powerpoint/2010/main" val="965790780"/>
       </p:ext>
     </p:extLst>
   </p:cSld>
@@ -3941,7 +3941,7 @@
           <p:cNvPr id="10" name="">
             <a:extLst xmlns:a="http://schemas.openxmlformats.org/drawingml/2006/main">
               <a:ext uri="{FF2B5EF4-FFF2-40B4-BE49-F238E27FC236}">
-                <a16:creationId xmlns:a16="http://schemas.microsoft.com/office/drawing/2014/main" id="{EF2A8F49-7687-4E87-AF9C-817935F38CC6}"/>
+                <a16:creationId xmlns:a16="http://schemas.microsoft.com/office/drawing/2014/main" id="{D799F32D-20C3-4583-AB3F-6C355E623DC4}"/>
               </a:ext>
             </a:extLst>
           </p:cNvPr>
@@ -3998,7 +3998,7 @@
           <p:cNvPr id="2" name="">
             <a:extLst xmlns:a="http://schemas.openxmlformats.org/drawingml/2006/main">
               <a:ext uri="{FF2B5EF4-FFF2-40B4-BE49-F238E27FC236}">
-                <a16:creationId xmlns:a16="http://schemas.microsoft.com/office/drawing/2014/main" id="{81B0406D-C3C1-4751-8E19-670EAC46960D}"/>
+                <a16:creationId xmlns:a16="http://schemas.microsoft.com/office/drawing/2014/main" id="{341C2809-78DB-48A0-AC5D-1C1C07DD8D5C}"/>
               </a:ext>
             </a:extLst>
           </p:cNvPr>
@@ -4055,7 +4055,7 @@
           <p:cNvPr id="3" name="">
             <a:extLst xmlns:a="http://schemas.openxmlformats.org/drawingml/2006/main">
               <a:ext uri="{FF2B5EF4-FFF2-40B4-BE49-F238E27FC236}">
-                <a16:creationId xmlns:a16="http://schemas.microsoft.com/office/drawing/2014/main" id="{CF68A92E-7336-411F-AA05-4D6930608DA7}"/>
+                <a16:creationId xmlns:a16="http://schemas.microsoft.com/office/drawing/2014/main" id="{C534F623-B3BE-4098-8634-CD44AE4CD0FC}"/>
               </a:ext>
             </a:extLst>
           </p:cNvPr>
@@ -4638,7 +4638,7 @@
           <p:cNvPr id="5" name="">
             <a:extLst xmlns:a="http://schemas.openxmlformats.org/drawingml/2006/main">
               <a:ext uri="{FF2B5EF4-FFF2-40B4-BE49-F238E27FC236}">
-                <a16:creationId xmlns:a16="http://schemas.microsoft.com/office/drawing/2014/main" id="{B7DBA95C-272E-4F61-8388-FE70B7F33D73}"/>
+                <a16:creationId xmlns:a16="http://schemas.microsoft.com/office/drawing/2014/main" id="{37162E2E-CDAB-4F09-B406-6C275B85BEC3}"/>
               </a:ext>
             </a:extLst>
           </p:cNvPr>
@@ -4695,7 +4695,7 @@
           <p:cNvPr id="6" name="">
             <a:extLst xmlns:a="http://schemas.openxmlformats.org/drawingml/2006/main">
               <a:ext uri="{FF2B5EF4-FFF2-40B4-BE49-F238E27FC236}">
-                <a16:creationId xmlns:a16="http://schemas.microsoft.com/office/drawing/2014/main" id="{974C2A46-F935-4157-B5AF-8DA973315784}"/>
+                <a16:creationId xmlns:a16="http://schemas.microsoft.com/office/drawing/2014/main" id="{0D10B86B-4BDC-4723-B10F-63FFE6BDAC1C}"/>
               </a:ext>
             </a:extLst>
           </p:cNvPr>
@@ -4742,7 +4742,7 @@
                 <a:ea typeface="Hiragino Sans GB"/>
                 <a:cs typeface="Hiragino Sans GB"/>
               </a:rPr>
-              <a:t>少付购电费 488.73 − 少收上网收入 9.61 + 少计折损 1.00</a:t>
+              <a:t>购电费差额 488.73 + 上网收入变化 -9.61</a:t>
             </a:r>
           </a:p>
           <a:p xmlns:a="http://schemas.openxmlformats.org/drawingml/2006/main">
@@ -4765,7 +4765,7 @@
                 <a:ea typeface="Hiragino Sans GB"/>
                 <a:cs typeface="Hiragino Sans GB"/>
               </a:rPr>
-              <a:t>= 全月净节省 480.12 元</a:t>
+              <a:t>+ 折损差额 1.00 = 全月节省 480.12 元</a:t>
             </a:r>
           </a:p>
         </p:txBody>
@@ -4775,7 +4775,7 @@
           <p:cNvPr id="7" name="">
             <a:extLst xmlns:a="http://schemas.openxmlformats.org/drawingml/2006/main">
               <a:ext uri="{FF2B5EF4-FFF2-40B4-BE49-F238E27FC236}">
-                <a16:creationId xmlns:a16="http://schemas.microsoft.com/office/drawing/2014/main" id="{990BF185-11AD-46EC-825C-A98953F33183}"/>
+                <a16:creationId xmlns:a16="http://schemas.microsoft.com/office/drawing/2014/main" id="{56E11176-2613-4BCA-9178-C9D5D18D2E9B}"/>
               </a:ext>
             </a:extLst>
           </p:cNvPr>
@@ -4832,7 +4832,7 @@
           <p:cNvPr id="8" name="">
             <a:extLst xmlns:a="http://schemas.openxmlformats.org/drawingml/2006/main">
               <a:ext uri="{FF2B5EF4-FFF2-40B4-BE49-F238E27FC236}">
-                <a16:creationId xmlns:a16="http://schemas.microsoft.com/office/drawing/2014/main" id="{2C94B17A-902F-415E-BCDB-ED0483FE197C}"/>
+                <a16:creationId xmlns:a16="http://schemas.microsoft.com/office/drawing/2014/main" id="{595D7ECF-A001-473B-8CC3-8BDC7C7C81C8}"/>
               </a:ext>
             </a:extLst>
           </p:cNvPr>
@@ -4889,7 +4889,7 @@
           <p:cNvPr id="9" name="">
             <a:extLst xmlns:a="http://schemas.openxmlformats.org/drawingml/2006/main">
               <a:ext uri="{FF2B5EF4-FFF2-40B4-BE49-F238E27FC236}">
-                <a16:creationId xmlns:a16="http://schemas.microsoft.com/office/drawing/2014/main" id="{3568C6F4-58B8-4FEC-9438-AEAB960559D6}"/>
+                <a16:creationId xmlns:a16="http://schemas.microsoft.com/office/drawing/2014/main" id="{8FFB46E6-0F69-4201-AC01-5FFDCE4150DF}"/>
               </a:ext>
             </a:extLst>
           </p:cNvPr>
@@ -4944,7 +4944,7 @@
     </p:spTree>
     <p:extLst>
       <p:ext uri="{BB962C8B-B14F-4D97-AF65-F5344CB8AC3E}">
-        <p14:creationId xmlns:p14="http://schemas.microsoft.com/office/powerpoint/2010/main" val="1277158641"/>
+        <p14:creationId xmlns:p14="http://schemas.microsoft.com/office/powerpoint/2010/main" val="409985265"/>
       </p:ext>
     </p:extLst>
   </p:cSld>
@@ -4975,7 +4975,7 @@
           <p:cNvPr id="9" name="">
             <a:extLst xmlns:a="http://schemas.openxmlformats.org/drawingml/2006/main">
               <a:ext uri="{FF2B5EF4-FFF2-40B4-BE49-F238E27FC236}">
-                <a16:creationId xmlns:a16="http://schemas.microsoft.com/office/drawing/2014/main" id="{3BFE0EBA-F478-4E24-BE2B-3E84B107B5DF}"/>
+                <a16:creationId xmlns:a16="http://schemas.microsoft.com/office/drawing/2014/main" id="{AC1377F3-CFE7-4F7F-B66D-55553C193665}"/>
               </a:ext>
             </a:extLst>
           </p:cNvPr>
@@ -5032,7 +5032,7 @@
           <p:cNvPr id="2" name="">
             <a:extLst xmlns:a="http://schemas.openxmlformats.org/drawingml/2006/main">
               <a:ext uri="{FF2B5EF4-FFF2-40B4-BE49-F238E27FC236}">
-                <a16:creationId xmlns:a16="http://schemas.microsoft.com/office/drawing/2014/main" id="{9E57FCE0-514A-4C3A-B5A6-E7F597BAF779}"/>
+                <a16:creationId xmlns:a16="http://schemas.microsoft.com/office/drawing/2014/main" id="{AE2E2720-48EF-424E-BCF6-16EFD51E44B8}"/>
               </a:ext>
             </a:extLst>
           </p:cNvPr>
@@ -5089,7 +5089,7 @@
           <p:cNvPr id="3" name="">
             <a:extLst xmlns:a="http://schemas.openxmlformats.org/drawingml/2006/main">
               <a:ext uri="{FF2B5EF4-FFF2-40B4-BE49-F238E27FC236}">
-                <a16:creationId xmlns:a16="http://schemas.microsoft.com/office/drawing/2014/main" id="{9160392F-CE71-479F-B89D-DD58FC49D2B4}"/>
+                <a16:creationId xmlns:a16="http://schemas.microsoft.com/office/drawing/2014/main" id="{A87F2FEF-CF69-4E09-BCBF-51E80A61C85F}"/>
               </a:ext>
             </a:extLst>
           </p:cNvPr>
@@ -5151,7 +5151,7 @@
                           <a:ea typeface="Hiragino Sans GB"/>
                           <a:cs typeface="Hiragino Sans GB"/>
                         </a:rPr>
-                        <a:t>6 月 1 日 08:30</a:t>
+                        <a:t>06-01 08:30</a:t>
                       </a:r>
                     </a:p>
                   </a:txBody>
@@ -5567,7 +5567,7 @@
           <p:cNvPr id="5" name="">
             <a:extLst xmlns:a="http://schemas.openxmlformats.org/drawingml/2006/main">
               <a:ext uri="{FF2B5EF4-FFF2-40B4-BE49-F238E27FC236}">
-                <a16:creationId xmlns:a16="http://schemas.microsoft.com/office/drawing/2014/main" id="{B9371D48-D098-481D-9D82-134540B2056F}"/>
+                <a16:creationId xmlns:a16="http://schemas.microsoft.com/office/drawing/2014/main" id="{CE2F5C3D-E7C2-4A0B-ADB6-05C149CBC3CD}"/>
               </a:ext>
             </a:extLst>
           </p:cNvPr>
@@ -5624,7 +5624,7 @@
           <p:cNvPr id="6" name="">
             <a:extLst xmlns:a="http://schemas.openxmlformats.org/drawingml/2006/main">
               <a:ext uri="{FF2B5EF4-FFF2-40B4-BE49-F238E27FC236}">
-                <a16:creationId xmlns:a16="http://schemas.microsoft.com/office/drawing/2014/main" id="{25B8752D-1F9F-4CBB-8BDD-22C26297B681}"/>
+                <a16:creationId xmlns:a16="http://schemas.microsoft.com/office/drawing/2014/main" id="{26F5BEC3-396D-4465-B1BB-F2308EF465AB}"/>
               </a:ext>
             </a:extLst>
           </p:cNvPr>
@@ -5704,7 +5704,7 @@
           <p:cNvPr id="7" name="">
             <a:extLst xmlns:a="http://schemas.openxmlformats.org/drawingml/2006/main">
               <a:ext uri="{FF2B5EF4-FFF2-40B4-BE49-F238E27FC236}">
-                <a16:creationId xmlns:a16="http://schemas.microsoft.com/office/drawing/2014/main" id="{5C860847-AE29-4DB2-9672-8645FE1D546D}"/>
+                <a16:creationId xmlns:a16="http://schemas.microsoft.com/office/drawing/2014/main" id="{D245423A-CC07-41ED-9DE8-9737A7F7CB5E}"/>
               </a:ext>
             </a:extLst>
           </p:cNvPr>
@@ -5761,7 +5761,7 @@
           <p:cNvPr id="8" name="">
             <a:extLst xmlns:a="http://schemas.openxmlformats.org/drawingml/2006/main">
               <a:ext uri="{FF2B5EF4-FFF2-40B4-BE49-F238E27FC236}">
-                <a16:creationId xmlns:a16="http://schemas.microsoft.com/office/drawing/2014/main" id="{E01D874B-4170-42B1-917A-207523549A8B}"/>
+                <a16:creationId xmlns:a16="http://schemas.microsoft.com/office/drawing/2014/main" id="{BDF2A45F-1898-4099-BE4A-01051806A736}"/>
               </a:ext>
             </a:extLst>
           </p:cNvPr>
@@ -5816,7 +5816,7 @@
     </p:spTree>
     <p:extLst>
       <p:ext uri="{BB962C8B-B14F-4D97-AF65-F5344CB8AC3E}">
-        <p14:creationId xmlns:p14="http://schemas.microsoft.com/office/powerpoint/2010/main" val="324396643"/>
+        <p14:creationId xmlns:p14="http://schemas.microsoft.com/office/powerpoint/2010/main" val="1352039394"/>
       </p:ext>
     </p:extLst>
   </p:cSld>
@@ -5847,7 +5847,7 @@
           <p:cNvPr id="9" name="">
             <a:extLst xmlns:a="http://schemas.openxmlformats.org/drawingml/2006/main">
               <a:ext uri="{FF2B5EF4-FFF2-40B4-BE49-F238E27FC236}">
-                <a16:creationId xmlns:a16="http://schemas.microsoft.com/office/drawing/2014/main" id="{51157DED-F79B-4409-B8A9-EFCA2D51303A}"/>
+                <a16:creationId xmlns:a16="http://schemas.microsoft.com/office/drawing/2014/main" id="{8BE00A22-79E4-430A-A34A-FB544665FD8E}"/>
               </a:ext>
             </a:extLst>
           </p:cNvPr>
@@ -5904,7 +5904,7 @@
           <p:cNvPr id="2" name="">
             <a:extLst xmlns:a="http://schemas.openxmlformats.org/drawingml/2006/main">
               <a:ext uri="{FF2B5EF4-FFF2-40B4-BE49-F238E27FC236}">
-                <a16:creationId xmlns:a16="http://schemas.microsoft.com/office/drawing/2014/main" id="{D07905FD-F6D0-4AFD-A62C-498B607002C3}"/>
+                <a16:creationId xmlns:a16="http://schemas.microsoft.com/office/drawing/2014/main" id="{242085BA-42A6-4B90-BFE3-7FC7CE0A5865}"/>
               </a:ext>
             </a:extLst>
           </p:cNvPr>
@@ -5961,7 +5961,7 @@
           <p:cNvPr id="3" name="">
             <a:extLst xmlns:a="http://schemas.openxmlformats.org/drawingml/2006/main">
               <a:ext uri="{FF2B5EF4-FFF2-40B4-BE49-F238E27FC236}">
-                <a16:creationId xmlns:a16="http://schemas.microsoft.com/office/drawing/2014/main" id="{09012EDE-AD80-4F1B-8C56-91854E2D4476}"/>
+                <a16:creationId xmlns:a16="http://schemas.microsoft.com/office/drawing/2014/main" id="{BF306949-9E98-4E79-B9B3-2E6B43AEFC8A}"/>
               </a:ext>
             </a:extLst>
           </p:cNvPr>
@@ -6414,7 +6414,7 @@
           <p:cNvPr id="5" name="">
             <a:extLst xmlns:a="http://schemas.openxmlformats.org/drawingml/2006/main">
               <a:ext uri="{FF2B5EF4-FFF2-40B4-BE49-F238E27FC236}">
-                <a16:creationId xmlns:a16="http://schemas.microsoft.com/office/drawing/2014/main" id="{BD27ABAC-32DA-4124-A592-836E7D9D113F}"/>
+                <a16:creationId xmlns:a16="http://schemas.microsoft.com/office/drawing/2014/main" id="{67FABEB7-9348-48EE-B348-BDAD4DB40607}"/>
               </a:ext>
             </a:extLst>
           </p:cNvPr>
@@ -6471,7 +6471,7 @@
           <p:cNvPr id="6" name="">
             <a:extLst xmlns:a="http://schemas.openxmlformats.org/drawingml/2006/main">
               <a:ext uri="{FF2B5EF4-FFF2-40B4-BE49-F238E27FC236}">
-                <a16:creationId xmlns:a16="http://schemas.microsoft.com/office/drawing/2014/main" id="{58FE915A-5D4F-4BDC-B299-50F25BF0749E}"/>
+                <a16:creationId xmlns:a16="http://schemas.microsoft.com/office/drawing/2014/main" id="{34758C04-7868-45F7-9C64-13AEC9474CCA}"/>
               </a:ext>
             </a:extLst>
           </p:cNvPr>
@@ -6528,7 +6528,7 @@
           <p:cNvPr id="7" name="">
             <a:extLst xmlns:a="http://schemas.openxmlformats.org/drawingml/2006/main">
               <a:ext uri="{FF2B5EF4-FFF2-40B4-BE49-F238E27FC236}">
-                <a16:creationId xmlns:a16="http://schemas.microsoft.com/office/drawing/2014/main" id="{7FB9D8C5-667F-4853-AF6B-983F7122A980}"/>
+                <a16:creationId xmlns:a16="http://schemas.microsoft.com/office/drawing/2014/main" id="{1A16FC0B-3D93-404D-9E63-46736327AEDB}"/>
               </a:ext>
             </a:extLst>
           </p:cNvPr>
@@ -6585,7 +6585,7 @@
           <p:cNvPr id="8" name="">
             <a:extLst xmlns:a="http://schemas.openxmlformats.org/drawingml/2006/main">
               <a:ext uri="{FF2B5EF4-FFF2-40B4-BE49-F238E27FC236}">
-                <a16:creationId xmlns:a16="http://schemas.microsoft.com/office/drawing/2014/main" id="{3C52E473-486D-4BA8-9C58-202F6BAA0DBF}"/>
+                <a16:creationId xmlns:a16="http://schemas.microsoft.com/office/drawing/2014/main" id="{8DC801BF-0513-432E-8520-BBAE7D0797AB}"/>
               </a:ext>
             </a:extLst>
           </p:cNvPr>
@@ -6640,7 +6640,7 @@
     </p:spTree>
     <p:extLst>
       <p:ext uri="{BB962C8B-B14F-4D97-AF65-F5344CB8AC3E}">
-        <p14:creationId xmlns:p14="http://schemas.microsoft.com/office/powerpoint/2010/main" val="331266457"/>
+        <p14:creationId xmlns:p14="http://schemas.microsoft.com/office/powerpoint/2010/main" val="1097204754"/>
       </p:ext>
     </p:extLst>
   </p:cSld>
@@ -6671,7 +6671,7 @@
           <p:cNvPr id="9" name="">
             <a:extLst xmlns:a="http://schemas.openxmlformats.org/drawingml/2006/main">
               <a:ext uri="{FF2B5EF4-FFF2-40B4-BE49-F238E27FC236}">
-                <a16:creationId xmlns:a16="http://schemas.microsoft.com/office/drawing/2014/main" id="{845155A1-A296-4AD7-B13E-032A550BA341}"/>
+                <a16:creationId xmlns:a16="http://schemas.microsoft.com/office/drawing/2014/main" id="{8325FF98-8831-435F-8B9A-1D952E1B4D28}"/>
               </a:ext>
             </a:extLst>
           </p:cNvPr>
@@ -6728,7 +6728,7 @@
           <p:cNvPr id="2" name="">
             <a:extLst xmlns:a="http://schemas.openxmlformats.org/drawingml/2006/main">
               <a:ext uri="{FF2B5EF4-FFF2-40B4-BE49-F238E27FC236}">
-                <a16:creationId xmlns:a16="http://schemas.microsoft.com/office/drawing/2014/main" id="{BF3B9521-9C09-4C1B-A687-F0C4E70F5488}"/>
+                <a16:creationId xmlns:a16="http://schemas.microsoft.com/office/drawing/2014/main" id="{13D11989-B5AF-4872-BE23-4B029BCA236B}"/>
               </a:ext>
             </a:extLst>
           </p:cNvPr>
@@ -6785,7 +6785,7 @@
           <p:cNvPr id="3" name="">
             <a:extLst xmlns:a="http://schemas.openxmlformats.org/drawingml/2006/main">
               <a:ext uri="{FF2B5EF4-FFF2-40B4-BE49-F238E27FC236}">
-                <a16:creationId xmlns:a16="http://schemas.microsoft.com/office/drawing/2014/main" id="{E8D88381-B0D0-4E7C-919C-4EB4E38D2AB5}"/>
+                <a16:creationId xmlns:a16="http://schemas.microsoft.com/office/drawing/2014/main" id="{53EF598B-24F7-4B88-BAC9-83FB52863DB4}"/>
               </a:ext>
             </a:extLst>
           </p:cNvPr>
@@ -7318,7 +7318,7 @@
           <p:cNvPr id="5" name="">
             <a:extLst xmlns:a="http://schemas.openxmlformats.org/drawingml/2006/main">
               <a:ext uri="{FF2B5EF4-FFF2-40B4-BE49-F238E27FC236}">
-                <a16:creationId xmlns:a16="http://schemas.microsoft.com/office/drawing/2014/main" id="{6E34F549-5815-4384-9101-F82B01C55AE0}"/>
+                <a16:creationId xmlns:a16="http://schemas.microsoft.com/office/drawing/2014/main" id="{84D20E67-C233-4AB7-A11D-DA0D8C318799}"/>
               </a:ext>
             </a:extLst>
           </p:cNvPr>
@@ -7375,7 +7375,7 @@
           <p:cNvPr id="6" name="">
             <a:extLst xmlns:a="http://schemas.openxmlformats.org/drawingml/2006/main">
               <a:ext uri="{FF2B5EF4-FFF2-40B4-BE49-F238E27FC236}">
-                <a16:creationId xmlns:a16="http://schemas.microsoft.com/office/drawing/2014/main" id="{2A6AA825-98CF-439B-A487-171A75A5850C}"/>
+                <a16:creationId xmlns:a16="http://schemas.microsoft.com/office/drawing/2014/main" id="{1DB8D08E-9A60-40AA-852F-418F4FCF4F25}"/>
               </a:ext>
             </a:extLst>
           </p:cNvPr>
@@ -7432,7 +7432,7 @@
           <p:cNvPr id="7" name="">
             <a:extLst xmlns:a="http://schemas.openxmlformats.org/drawingml/2006/main">
               <a:ext uri="{FF2B5EF4-FFF2-40B4-BE49-F238E27FC236}">
-                <a16:creationId xmlns:a16="http://schemas.microsoft.com/office/drawing/2014/main" id="{1BE1D0F0-3056-4B42-9A3A-E095B473E165}"/>
+                <a16:creationId xmlns:a16="http://schemas.microsoft.com/office/drawing/2014/main" id="{B29B1B20-1937-46B5-B9A5-9AC2F0D9E6D0}"/>
               </a:ext>
             </a:extLst>
           </p:cNvPr>
@@ -7489,7 +7489,7 @@
           <p:cNvPr id="8" name="">
             <a:extLst xmlns:a="http://schemas.openxmlformats.org/drawingml/2006/main">
               <a:ext uri="{FF2B5EF4-FFF2-40B4-BE49-F238E27FC236}">
-                <a16:creationId xmlns:a16="http://schemas.microsoft.com/office/drawing/2014/main" id="{85AD9AC1-08A1-47D2-BFA6-4086A0479869}"/>
+                <a16:creationId xmlns:a16="http://schemas.microsoft.com/office/drawing/2014/main" id="{F7FB5CD1-CA6D-4547-9931-3C96CD18046C}"/>
               </a:ext>
             </a:extLst>
           </p:cNvPr>
@@ -7544,7 +7544,7 @@
     </p:spTree>
     <p:extLst>
       <p:ext uri="{BB962C8B-B14F-4D97-AF65-F5344CB8AC3E}">
-        <p14:creationId xmlns:p14="http://schemas.microsoft.com/office/powerpoint/2010/main" val="991801975"/>
+        <p14:creationId xmlns:p14="http://schemas.microsoft.com/office/powerpoint/2010/main" val="850980166"/>
       </p:ext>
     </p:extLst>
   </p:cSld>
@@ -7575,7 +7575,7 @@
           <p:cNvPr id="11" name="">
             <a:extLst xmlns:a="http://schemas.openxmlformats.org/drawingml/2006/main">
               <a:ext uri="{FF2B5EF4-FFF2-40B4-BE49-F238E27FC236}">
-                <a16:creationId xmlns:a16="http://schemas.microsoft.com/office/drawing/2014/main" id="{ED41263B-D34C-4B1F-A29A-6B1C42DE5355}"/>
+                <a16:creationId xmlns:a16="http://schemas.microsoft.com/office/drawing/2014/main" id="{35D1A29A-919D-4088-816E-BD70F044AA2A}"/>
               </a:ext>
             </a:extLst>
           </p:cNvPr>
@@ -7632,7 +7632,7 @@
           <p:cNvPr id="2" name="">
             <a:extLst xmlns:a="http://schemas.openxmlformats.org/drawingml/2006/main">
               <a:ext uri="{FF2B5EF4-FFF2-40B4-BE49-F238E27FC236}">
-                <a16:creationId xmlns:a16="http://schemas.microsoft.com/office/drawing/2014/main" id="{0FCC74C8-4FC4-4557-BFF2-95C38D9B417C}"/>
+                <a16:creationId xmlns:a16="http://schemas.microsoft.com/office/drawing/2014/main" id="{8FEC2326-7025-4B75-8AFC-EACFCADDD640}"/>
               </a:ext>
             </a:extLst>
           </p:cNvPr>
@@ -7689,7 +7689,7 @@
           <p:cNvPr id="3" name="">
             <a:extLst xmlns:a="http://schemas.openxmlformats.org/drawingml/2006/main">
               <a:ext uri="{FF2B5EF4-FFF2-40B4-BE49-F238E27FC236}">
-                <a16:creationId xmlns:a16="http://schemas.microsoft.com/office/drawing/2014/main" id="{0FCB5600-B7E2-45F2-9B9C-B53BEC9EA774}"/>
+                <a16:creationId xmlns:a16="http://schemas.microsoft.com/office/drawing/2014/main" id="{3602E2F9-9DB7-4FDA-9FF3-1C95AA575C96}"/>
               </a:ext>
             </a:extLst>
           </p:cNvPr>
@@ -7719,7 +7719,7 @@
           <p:cNvPr id="4" name="">
             <a:extLst xmlns:a="http://schemas.openxmlformats.org/drawingml/2006/main">
               <a:ext uri="{FF2B5EF4-FFF2-40B4-BE49-F238E27FC236}">
-                <a16:creationId xmlns:a16="http://schemas.microsoft.com/office/drawing/2014/main" id="{749B8A3B-FD59-4710-A38F-1FB1330E9BC2}"/>
+                <a16:creationId xmlns:a16="http://schemas.microsoft.com/office/drawing/2014/main" id="{B29AD099-2733-4D3C-AC44-021ABFF87CE8}"/>
               </a:ext>
             </a:extLst>
           </p:cNvPr>
@@ -7776,7 +7776,7 @@
           <p:cNvPr id="5" name="">
             <a:extLst xmlns:a="http://schemas.openxmlformats.org/drawingml/2006/main">
               <a:ext uri="{FF2B5EF4-FFF2-40B4-BE49-F238E27FC236}">
-                <a16:creationId xmlns:a16="http://schemas.microsoft.com/office/drawing/2014/main" id="{A4BB1641-FE8B-452A-9EA3-E092C1D3C67B}"/>
+                <a16:creationId xmlns:a16="http://schemas.microsoft.com/office/drawing/2014/main" id="{AE8291EE-4405-4C8B-917E-F5076A996B6B}"/>
               </a:ext>
             </a:extLst>
           </p:cNvPr>
@@ -7833,7 +7833,7 @@
           <p:cNvPr id="6" name="">
             <a:extLst xmlns:a="http://schemas.openxmlformats.org/drawingml/2006/main">
               <a:ext uri="{FF2B5EF4-FFF2-40B4-BE49-F238E27FC236}">
-                <a16:creationId xmlns:a16="http://schemas.microsoft.com/office/drawing/2014/main" id="{15E26C98-9236-4DDB-A712-D2DB5089C979}"/>
+                <a16:creationId xmlns:a16="http://schemas.microsoft.com/office/drawing/2014/main" id="{ED9F6553-A0DE-4383-963B-906AB33BDD57}"/>
               </a:ext>
             </a:extLst>
           </p:cNvPr>
@@ -7863,7 +7863,7 @@
           <p:cNvPr id="7" name="">
             <a:extLst xmlns:a="http://schemas.openxmlformats.org/drawingml/2006/main">
               <a:ext uri="{FF2B5EF4-FFF2-40B4-BE49-F238E27FC236}">
-                <a16:creationId xmlns:a16="http://schemas.microsoft.com/office/drawing/2014/main" id="{3AC68932-F3D0-4BDC-BA7A-7907AB49F5F1}"/>
+                <a16:creationId xmlns:a16="http://schemas.microsoft.com/office/drawing/2014/main" id="{4D8AE52C-B5B1-4708-B5B7-8BC33D026F5E}"/>
               </a:ext>
             </a:extLst>
           </p:cNvPr>
@@ -7920,7 +7920,7 @@
           <p:cNvPr id="8" name="">
             <a:extLst xmlns:a="http://schemas.openxmlformats.org/drawingml/2006/main">
               <a:ext uri="{FF2B5EF4-FFF2-40B4-BE49-F238E27FC236}">
-                <a16:creationId xmlns:a16="http://schemas.microsoft.com/office/drawing/2014/main" id="{E4AC1582-57EC-42E9-B8A4-9F49B5C1D02D}"/>
+                <a16:creationId xmlns:a16="http://schemas.microsoft.com/office/drawing/2014/main" id="{B1DED99A-9474-407F-9EA4-C4E03CAA8E61}"/>
               </a:ext>
             </a:extLst>
           </p:cNvPr>
@@ -8000,7 +8000,7 @@
           <p:cNvPr id="9" name="">
             <a:extLst xmlns:a="http://schemas.openxmlformats.org/drawingml/2006/main">
               <a:ext uri="{FF2B5EF4-FFF2-40B4-BE49-F238E27FC236}">
-                <a16:creationId xmlns:a16="http://schemas.microsoft.com/office/drawing/2014/main" id="{8B06D6D6-4EE6-4431-AF00-FEC9009EE34C}"/>
+                <a16:creationId xmlns:a16="http://schemas.microsoft.com/office/drawing/2014/main" id="{34B88E22-6D78-495C-8186-BCD446B2ACE9}"/>
               </a:ext>
             </a:extLst>
           </p:cNvPr>
@@ -8057,7 +8057,7 @@
           <p:cNvPr id="10" name="">
             <a:extLst xmlns:a="http://schemas.openxmlformats.org/drawingml/2006/main">
               <a:ext uri="{FF2B5EF4-FFF2-40B4-BE49-F238E27FC236}">
-                <a16:creationId xmlns:a16="http://schemas.microsoft.com/office/drawing/2014/main" id="{D8AE8DE3-F112-4E6B-872F-B32956C48394}"/>
+                <a16:creationId xmlns:a16="http://schemas.microsoft.com/office/drawing/2014/main" id="{517AECE2-16BD-4080-A17A-9C3CDB316D14}"/>
               </a:ext>
             </a:extLst>
           </p:cNvPr>
@@ -8112,7 +8112,7 @@
     </p:spTree>
     <p:extLst>
       <p:ext uri="{BB962C8B-B14F-4D97-AF65-F5344CB8AC3E}">
-        <p14:creationId xmlns:p14="http://schemas.microsoft.com/office/powerpoint/2010/main" val="1436933369"/>
+        <p14:creationId xmlns:p14="http://schemas.microsoft.com/office/powerpoint/2010/main" val="712163763"/>
       </p:ext>
     </p:extLst>
   </p:cSld>
@@ -8143,7 +8143,7 @@
           <p:cNvPr id="9" name="">
             <a:extLst xmlns:a="http://schemas.openxmlformats.org/drawingml/2006/main">
               <a:ext uri="{FF2B5EF4-FFF2-40B4-BE49-F238E27FC236}">
-                <a16:creationId xmlns:a16="http://schemas.microsoft.com/office/drawing/2014/main" id="{2F22DDCE-1BC3-42CD-90A6-9448E6EAF38B}"/>
+                <a16:creationId xmlns:a16="http://schemas.microsoft.com/office/drawing/2014/main" id="{FF275000-A233-4849-BF32-F8CBDCAAEC05}"/>
               </a:ext>
             </a:extLst>
           </p:cNvPr>
@@ -8200,7 +8200,7 @@
           <p:cNvPr id="2" name="">
             <a:extLst xmlns:a="http://schemas.openxmlformats.org/drawingml/2006/main">
               <a:ext uri="{FF2B5EF4-FFF2-40B4-BE49-F238E27FC236}">
-                <a16:creationId xmlns:a16="http://schemas.microsoft.com/office/drawing/2014/main" id="{5190F36A-4FFB-4D2F-BB27-B9607031EFE8}"/>
+                <a16:creationId xmlns:a16="http://schemas.microsoft.com/office/drawing/2014/main" id="{741D2FE3-1BB1-4A13-983E-0C1038EDD1AB}"/>
               </a:ext>
             </a:extLst>
           </p:cNvPr>
@@ -8257,7 +8257,7 @@
           <p:cNvPr id="3" name="">
             <a:extLst xmlns:a="http://schemas.openxmlformats.org/drawingml/2006/main">
               <a:ext uri="{FF2B5EF4-FFF2-40B4-BE49-F238E27FC236}">
-                <a16:creationId xmlns:a16="http://schemas.microsoft.com/office/drawing/2014/main" id="{EE36B10A-3CE9-4E4D-9568-E4AE7CFF42A9}"/>
+                <a16:creationId xmlns:a16="http://schemas.microsoft.com/office/drawing/2014/main" id="{EBC4E112-A703-40BB-B21A-3AD1E48BFB36}"/>
               </a:ext>
             </a:extLst>
           </p:cNvPr>
@@ -8947,7 +8947,7 @@
           <p:cNvPr id="5" name="">
             <a:extLst xmlns:a="http://schemas.openxmlformats.org/drawingml/2006/main">
               <a:ext uri="{FF2B5EF4-FFF2-40B4-BE49-F238E27FC236}">
-                <a16:creationId xmlns:a16="http://schemas.microsoft.com/office/drawing/2014/main" id="{10E2FA5B-7E64-4F60-9ACE-D9EC0627EF79}"/>
+                <a16:creationId xmlns:a16="http://schemas.microsoft.com/office/drawing/2014/main" id="{A0C26634-BBC2-4E71-A4C2-50E34DFF330E}"/>
               </a:ext>
             </a:extLst>
           </p:cNvPr>
@@ -9004,7 +9004,7 @@
           <p:cNvPr id="6" name="">
             <a:extLst xmlns:a="http://schemas.openxmlformats.org/drawingml/2006/main">
               <a:ext uri="{FF2B5EF4-FFF2-40B4-BE49-F238E27FC236}">
-                <a16:creationId xmlns:a16="http://schemas.microsoft.com/office/drawing/2014/main" id="{8B68A0B0-0D22-4089-9A11-0157C3790090}"/>
+                <a16:creationId xmlns:a16="http://schemas.microsoft.com/office/drawing/2014/main" id="{4D9BC7AE-AE67-4C0D-A2AD-72A24F7FD61F}"/>
               </a:ext>
             </a:extLst>
           </p:cNvPr>
@@ -9084,7 +9084,7 @@
           <p:cNvPr id="7" name="">
             <a:extLst xmlns:a="http://schemas.openxmlformats.org/drawingml/2006/main">
               <a:ext uri="{FF2B5EF4-FFF2-40B4-BE49-F238E27FC236}">
-                <a16:creationId xmlns:a16="http://schemas.microsoft.com/office/drawing/2014/main" id="{E9DE3EA9-B9AE-4E83-A165-1C71D24FF2EA}"/>
+                <a16:creationId xmlns:a16="http://schemas.microsoft.com/office/drawing/2014/main" id="{03416080-3F68-477B-8FB9-2CE016482A67}"/>
               </a:ext>
             </a:extLst>
           </p:cNvPr>
@@ -9141,7 +9141,7 @@
           <p:cNvPr id="8" name="">
             <a:extLst xmlns:a="http://schemas.openxmlformats.org/drawingml/2006/main">
               <a:ext uri="{FF2B5EF4-FFF2-40B4-BE49-F238E27FC236}">
-                <a16:creationId xmlns:a16="http://schemas.microsoft.com/office/drawing/2014/main" id="{09CD7FED-163E-44B1-ABA2-F61EB092D028}"/>
+                <a16:creationId xmlns:a16="http://schemas.microsoft.com/office/drawing/2014/main" id="{88712F42-5320-468C-AB52-CFAB9D77FA43}"/>
               </a:ext>
             </a:extLst>
           </p:cNvPr>
@@ -9196,7 +9196,7 @@
     </p:spTree>
     <p:extLst>
       <p:ext uri="{BB962C8B-B14F-4D97-AF65-F5344CB8AC3E}">
-        <p14:creationId xmlns:p14="http://schemas.microsoft.com/office/powerpoint/2010/main" val="204373445"/>
+        <p14:creationId xmlns:p14="http://schemas.microsoft.com/office/powerpoint/2010/main" val="729240935"/>
       </p:ext>
     </p:extLst>
   </p:cSld>

</xml_diff>

<commit_message>
Add executed monthly forecast correction comparison and causal evidence replay
</commit_message>
<xml_diff>
--- a/downloads/energy-campus-v3.2.pptx
+++ b/downloads/energy-campus-v3.2.pptx
@@ -2,22 +2,24 @@
 <file path=ppt/presentation.xml><?xml version="1.0" encoding="utf-8"?>
 <p:presentation xmlns:p="http://schemas.openxmlformats.org/presentationml/2006/main">
   <p:sldMasterIdLst>
-    <p:sldMasterId xmlns:r="http://schemas.openxmlformats.org/officeDocument/2006/relationships" id="2147483648" r:id="R3f5fa770473e4c6b"/>
+    <p:sldMasterId xmlns:r="http://schemas.openxmlformats.org/officeDocument/2006/relationships" id="2147483648" r:id="R237280c3b5cd4a60"/>
   </p:sldMasterIdLst>
   <p:notesMasterIdLst>
-    <p:notesMasterId xmlns:r="http://schemas.openxmlformats.org/officeDocument/2006/relationships" r:id="R04635323602f4034"/>
+    <p:notesMasterId xmlns:r="http://schemas.openxmlformats.org/officeDocument/2006/relationships" r:id="R99325263fbe341b0"/>
   </p:notesMasterIdLst>
   <p:sldIdLst>
-    <p:sldId xmlns:r="http://schemas.openxmlformats.org/officeDocument/2006/relationships" id="256" r:id="R0a0ab0bfa8ba4400"/>
-    <p:sldId xmlns:r="http://schemas.openxmlformats.org/officeDocument/2006/relationships" id="257" r:id="R1551432448b54ef6"/>
-    <p:sldId xmlns:r="http://schemas.openxmlformats.org/officeDocument/2006/relationships" id="258" r:id="R0f246effaf47465b"/>
-    <p:sldId xmlns:r="http://schemas.openxmlformats.org/officeDocument/2006/relationships" id="259" r:id="Rca78d74019544a29"/>
-    <p:sldId xmlns:r="http://schemas.openxmlformats.org/officeDocument/2006/relationships" id="260" r:id="R136691f3480b4990"/>
-    <p:sldId xmlns:r="http://schemas.openxmlformats.org/officeDocument/2006/relationships" id="261" r:id="R76ad8bafd13a47e5"/>
-    <p:sldId xmlns:r="http://schemas.openxmlformats.org/officeDocument/2006/relationships" id="262" r:id="Ref6de3c7b2514141"/>
-    <p:sldId xmlns:r="http://schemas.openxmlformats.org/officeDocument/2006/relationships" id="263" r:id="Rb9c08efcd0e5488e"/>
-    <p:sldId xmlns:r="http://schemas.openxmlformats.org/officeDocument/2006/relationships" id="264" r:id="R1c7d1c3469d9470a"/>
-    <p:sldId xmlns:r="http://schemas.openxmlformats.org/officeDocument/2006/relationships" id="265" r:id="R6a276c7df31948f0"/>
+    <p:sldId xmlns:r="http://schemas.openxmlformats.org/officeDocument/2006/relationships" id="256" r:id="R738b9d631faf49d4"/>
+    <p:sldId xmlns:r="http://schemas.openxmlformats.org/officeDocument/2006/relationships" id="257" r:id="R6532a3d8a00847d6"/>
+    <p:sldId xmlns:r="http://schemas.openxmlformats.org/officeDocument/2006/relationships" id="258" r:id="Re8d7d4ad1c4a48d5"/>
+    <p:sldId xmlns:r="http://schemas.openxmlformats.org/officeDocument/2006/relationships" id="259" r:id="Ra90c56c4b2c940f9"/>
+    <p:sldId xmlns:r="http://schemas.openxmlformats.org/officeDocument/2006/relationships" id="260" r:id="R4ea356e576bb4abc"/>
+    <p:sldId xmlns:r="http://schemas.openxmlformats.org/officeDocument/2006/relationships" id="261" r:id="R2650ae6b93c545f1"/>
+    <p:sldId xmlns:r="http://schemas.openxmlformats.org/officeDocument/2006/relationships" id="262" r:id="R745522b112d840b9"/>
+    <p:sldId xmlns:r="http://schemas.openxmlformats.org/officeDocument/2006/relationships" id="263" r:id="R34bf5b91d14a40f0"/>
+    <p:sldId xmlns:r="http://schemas.openxmlformats.org/officeDocument/2006/relationships" id="264" r:id="Ra4e03142ff3745b1"/>
+    <p:sldId xmlns:r="http://schemas.openxmlformats.org/officeDocument/2006/relationships" id="265" r:id="R6506680e0f324c22"/>
+    <p:sldId xmlns:r="http://schemas.openxmlformats.org/officeDocument/2006/relationships" id="266" r:id="R536b7328967f4e20"/>
+    <p:sldId xmlns:r="http://schemas.openxmlformats.org/officeDocument/2006/relationships" id="267" r:id="Rdb6ea84bd6ef4d27"/>
   </p:sldIdLst>
   <p:sldSz cx="12192000" cy="6858000"/>
   <p:notesSz cx="6858000" cy="9144000"/>
@@ -476,6 +478,16 @@
           </a:p>
           <a:p xmlns:a="http://schemas.openxmlformats.org/drawingml/2006/main">
             <a:r>
+              <a:t>validation/persistent-shift-2026-06/comparison.json SHA256 d0355b0a660d75381dff7411a389b5181e8db3cfeabf30041909fd2981934048</a:t>
+            </a:r>
+          </a:p>
+          <a:p xmlns:a="http://schemas.openxmlformats.org/drawingml/2006/main">
+            <a:r>
+              <a:t>validation/persistent-shift-2026-06/acceptance.json SHA256 15705a3d9d58348b60a50a314c33c90e3e76f6416449d81d72aa157e10b8535a</a:t>
+            </a:r>
+          </a:p>
+          <a:p xmlns:a="http://schemas.openxmlformats.org/drawingml/2006/main">
+            <a:r>
               <a:t>SimBench https://simbench.de/en/download/datasets/ ODbL1.0 / DbCL1.0。德国原始2016曲线按连续时段映射到中国时区2026仿真场景，非中国园区实测。公开回放 https://jinyh.github.io/energy-campus/ 。月度示范与72小时RSI研究分别记账。</a:t>
             </a:r>
           </a:p>
@@ -546,6 +558,216 @@
           <a:lstStyle xmlns:a="http://schemas.openxmlformats.org/drawingml/2006/main"/>
           <a:p xmlns:a="http://schemas.openxmlformats.org/drawingml/2006/main">
             <a:r>
+              <a:t>证据字段：persistent-shift acceptance / forecast_diagnostics / perturbation</a:t>
+            </a:r>
+          </a:p>
+          <a:p xmlns:a="http://schemas.openxmlformats.org/drawingml/2006/main">
+            <a:r>
+              <a:t>原第2日扰动和原72小时研究保持不变。诊断只使用目标时刻严格早于当前决策的样本。</a:t>
+            </a:r>
+          </a:p>
+          <a:p xmlns:a="http://schemas.openxmlformats.org/drawingml/2006/main">
+            <a:r>
+              <a:t>results/v32/jobs/310912a4ad924de6-summary.json SHA256 7274d16c5508057ac956a9056930a3b4b4e9fab4f664c1c707be827a50ca8ac1</a:t>
+            </a:r>
+          </a:p>
+          <a:p xmlns:a="http://schemas.openxmlformats.org/drawingml/2006/main">
+            <a:r>
+              <a:t>results/v32/improvements/4de87f7924b021d8/result.json SHA256 3d7e1bfbabeb55fd41f0c0696eaaca947950262e877b83d133505920d06671f3</a:t>
+            </a:r>
+          </a:p>
+          <a:p xmlns:a="http://schemas.openxmlformats.org/drawingml/2006/main">
+            <a:r>
+              <a:t>results/v32/opportunity/7a6aa4e97c225bc8/result.json SHA256 1af53221b4745a51325ccf8e66133f1253ae2db7cd50b9ea681c18658d39c008</a:t>
+            </a:r>
+          </a:p>
+          <a:p xmlns:a="http://schemas.openxmlformats.org/drawingml/2006/main">
+            <a:r>
+              <a:t>validation/persistent-shift-2026-06/comparison.json SHA256 d0355b0a660d75381dff7411a389b5181e8db3cfeabf30041909fd2981934048</a:t>
+            </a:r>
+          </a:p>
+          <a:p xmlns:a="http://schemas.openxmlformats.org/drawingml/2006/main">
+            <a:r>
+              <a:t>validation/persistent-shift-2026-06/acceptance.json SHA256 15705a3d9d58348b60a50a314c33c90e3e76f6416449d81d72aa157e10b8535a</a:t>
+            </a:r>
+          </a:p>
+          <a:p xmlns:a="http://schemas.openxmlformats.org/drawingml/2006/main">
+            <a:r>
+              <a:t>SimBench https://simbench.de/en/download/datasets/ ODbL1.0 / DbCL1.0。德国原始2016曲线按连续时段映射到中国时区2026仿真场景，非中国园区实测。公开回放 https://jinyh.github.io/energy-campus/ 。月度示范与72小时RSI研究分别记账。</a:t>
+            </a:r>
+          </a:p>
+        </p:txBody>
+      </p:sp>
+      <p:sp>
+        <p:nvSpPr>
+          <p:cNvPr id="4" name="Slide Number Placeholder 3"/>
+          <p:cNvSpPr>
+            <a:spLocks xmlns:a="http://schemas.openxmlformats.org/drawingml/2006/main" noGrp="1"/>
+          </p:cNvSpPr>
+          <p:nvPr>
+            <p:ph type="sldNum" idx="5"/>
+          </p:nvPr>
+        </p:nvSpPr>
+        <p:spPr/>
+        <p:txBody>
+          <a:bodyPr xmlns:a="http://schemas.openxmlformats.org/drawingml/2006/main"/>
+          <a:lstStyle xmlns:a="http://schemas.openxmlformats.org/drawingml/2006/main"/>
+          <a:p xmlns:a="http://schemas.openxmlformats.org/drawingml/2006/main"/>
+        </p:txBody>
+      </p:sp>
+    </p:spTree>
+  </p:cSld>
+  <p:clrMapOvr>
+    <a:masterClrMapping xmlns:a="http://schemas.openxmlformats.org/drawingml/2006/main"/>
+  </p:clrMapOvr>
+</p:notes>
+</file>
+
+<file path=ppt/notesSlides/notesSlide11.xml><?xml version="1.0" encoding="utf-8"?>
+<p:notes xmlns:p="http://schemas.openxmlformats.org/presentationml/2006/main">
+  <p:cSld>
+    <p:spTree>
+      <p:nvGrpSpPr>
+        <p:cNvPr id="1" name=""/>
+        <p:cNvGrpSpPr/>
+        <p:nvPr/>
+      </p:nvGrpSpPr>
+      <p:grpSpPr>
+        <a:xfrm xmlns:a="http://schemas.openxmlformats.org/drawingml/2006/main"/>
+      </p:grpSpPr>
+      <p:sp>
+        <p:nvSpPr>
+          <p:cNvPr id="2" name="Slide Image Placeholder 1"/>
+          <p:cNvSpPr>
+            <a:spLocks xmlns:a="http://schemas.openxmlformats.org/drawingml/2006/main" noGrp="1"/>
+          </p:cNvSpPr>
+          <p:nvPr>
+            <p:ph type="sldImg" idx="0"/>
+          </p:nvPr>
+        </p:nvSpPr>
+        <p:spPr/>
+      </p:sp>
+      <p:sp>
+        <p:nvSpPr>
+          <p:cNvPr id="3" name="Notes Placeholder 2"/>
+          <p:cNvSpPr>
+            <a:spLocks xmlns:a="http://schemas.openxmlformats.org/drawingml/2006/main" noGrp="1"/>
+          </p:cNvSpPr>
+          <p:nvPr>
+            <p:ph type="body" idx="1"/>
+          </p:nvPr>
+        </p:nvSpPr>
+        <p:spPr/>
+        <p:txBody>
+          <a:bodyPr xmlns:a="http://schemas.openxmlformats.org/drawingml/2006/main"/>
+          <a:lstStyle xmlns:a="http://schemas.openxmlformats.org/drawingml/2006/main"/>
+          <a:p xmlns:a="http://schemas.openxmlformats.org/drawingml/2006/main">
+            <a:r>
+              <a:t>证据字段：persistent-shift comparison / business_query_ledger</a:t>
+            </a:r>
+          </a:p>
+          <a:p xmlns:a="http://schemas.openxmlformats.org/drawingml/2006/main">
+            <a:r>
+              <a:t>这组对照不包含F/G程序晋升或跨轮继承，不能归因为RSI。成本差仅在双方均合格时报告。</a:t>
+            </a:r>
+          </a:p>
+          <a:p xmlns:a="http://schemas.openxmlformats.org/drawingml/2006/main">
+            <a:r>
+              <a:t>results/v32/jobs/310912a4ad924de6-summary.json SHA256 7274d16c5508057ac956a9056930a3b4b4e9fab4f664c1c707be827a50ca8ac1</a:t>
+            </a:r>
+          </a:p>
+          <a:p xmlns:a="http://schemas.openxmlformats.org/drawingml/2006/main">
+            <a:r>
+              <a:t>results/v32/improvements/4de87f7924b021d8/result.json SHA256 3d7e1bfbabeb55fd41f0c0696eaaca947950262e877b83d133505920d06671f3</a:t>
+            </a:r>
+          </a:p>
+          <a:p xmlns:a="http://schemas.openxmlformats.org/drawingml/2006/main">
+            <a:r>
+              <a:t>results/v32/opportunity/7a6aa4e97c225bc8/result.json SHA256 1af53221b4745a51325ccf8e66133f1253ae2db7cd50b9ea681c18658d39c008</a:t>
+            </a:r>
+          </a:p>
+          <a:p xmlns:a="http://schemas.openxmlformats.org/drawingml/2006/main">
+            <a:r>
+              <a:t>validation/persistent-shift-2026-06/comparison.json SHA256 d0355b0a660d75381dff7411a389b5181e8db3cfeabf30041909fd2981934048</a:t>
+            </a:r>
+          </a:p>
+          <a:p xmlns:a="http://schemas.openxmlformats.org/drawingml/2006/main">
+            <a:r>
+              <a:t>validation/persistent-shift-2026-06/acceptance.json SHA256 15705a3d9d58348b60a50a314c33c90e3e76f6416449d81d72aa157e10b8535a</a:t>
+            </a:r>
+          </a:p>
+          <a:p xmlns:a="http://schemas.openxmlformats.org/drawingml/2006/main">
+            <a:r>
+              <a:t>SimBench https://simbench.de/en/download/datasets/ ODbL1.0 / DbCL1.0。德国原始2016曲线按连续时段映射到中国时区2026仿真场景，非中国园区实测。公开回放 https://jinyh.github.io/energy-campus/ 。月度示范与72小时RSI研究分别记账。</a:t>
+            </a:r>
+          </a:p>
+        </p:txBody>
+      </p:sp>
+      <p:sp>
+        <p:nvSpPr>
+          <p:cNvPr id="4" name="Slide Number Placeholder 3"/>
+          <p:cNvSpPr>
+            <a:spLocks xmlns:a="http://schemas.openxmlformats.org/drawingml/2006/main" noGrp="1"/>
+          </p:cNvSpPr>
+          <p:nvPr>
+            <p:ph type="sldNum" idx="5"/>
+          </p:nvPr>
+        </p:nvSpPr>
+        <p:spPr/>
+        <p:txBody>
+          <a:bodyPr xmlns:a="http://schemas.openxmlformats.org/drawingml/2006/main"/>
+          <a:lstStyle xmlns:a="http://schemas.openxmlformats.org/drawingml/2006/main"/>
+          <a:p xmlns:a="http://schemas.openxmlformats.org/drawingml/2006/main"/>
+        </p:txBody>
+      </p:sp>
+    </p:spTree>
+  </p:cSld>
+  <p:clrMapOvr>
+    <a:masterClrMapping xmlns:a="http://schemas.openxmlformats.org/drawingml/2006/main"/>
+  </p:clrMapOvr>
+</p:notes>
+</file>
+
+<file path=ppt/notesSlides/notesSlide12.xml><?xml version="1.0" encoding="utf-8"?>
+<p:notes xmlns:p="http://schemas.openxmlformats.org/presentationml/2006/main">
+  <p:cSld>
+    <p:spTree>
+      <p:nvGrpSpPr>
+        <p:cNvPr id="1" name=""/>
+        <p:cNvGrpSpPr/>
+        <p:nvPr/>
+      </p:nvGrpSpPr>
+      <p:grpSpPr>
+        <a:xfrm xmlns:a="http://schemas.openxmlformats.org/drawingml/2006/main"/>
+      </p:grpSpPr>
+      <p:sp>
+        <p:nvSpPr>
+          <p:cNvPr id="2" name="Slide Image Placeholder 1"/>
+          <p:cNvSpPr>
+            <a:spLocks xmlns:a="http://schemas.openxmlformats.org/drawingml/2006/main" noGrp="1"/>
+          </p:cNvSpPr>
+          <p:nvPr>
+            <p:ph type="sldImg" idx="0"/>
+          </p:nvPr>
+        </p:nvSpPr>
+        <p:spPr/>
+      </p:sp>
+      <p:sp>
+        <p:nvSpPr>
+          <p:cNvPr id="3" name="Notes Placeholder 2"/>
+          <p:cNvSpPr>
+            <a:spLocks xmlns:a="http://schemas.openxmlformats.org/drawingml/2006/main" noGrp="1"/>
+          </p:cNvSpPr>
+          <p:nvPr>
+            <p:ph type="body" idx="1"/>
+          </p:nvPr>
+        </p:nvSpPr>
+        <p:spPr/>
+        <p:txBody>
+          <a:bodyPr xmlns:a="http://schemas.openxmlformats.org/drawingml/2006/main"/>
+          <a:lstStyle xmlns:a="http://schemas.openxmlformats.org/drawingml/2006/main"/>
+          <a:p xmlns:a="http://schemas.openxmlformats.org/drawingml/2006/main">
+            <a:r>
               <a:t>证据字段：public replay manifest / offline package</a:t>
             </a:r>
           </a:p>
@@ -567,6 +789,16 @@
           <a:p xmlns:a="http://schemas.openxmlformats.org/drawingml/2006/main">
             <a:r>
               <a:t>results/v32/opportunity/7a6aa4e97c225bc8/result.json SHA256 1af53221b4745a51325ccf8e66133f1253ae2db7cd50b9ea681c18658d39c008</a:t>
+            </a:r>
+          </a:p>
+          <a:p xmlns:a="http://schemas.openxmlformats.org/drawingml/2006/main">
+            <a:r>
+              <a:t>validation/persistent-shift-2026-06/comparison.json SHA256 d0355b0a660d75381dff7411a389b5181e8db3cfeabf30041909fd2981934048</a:t>
+            </a:r>
+          </a:p>
+          <a:p xmlns:a="http://schemas.openxmlformats.org/drawingml/2006/main">
+            <a:r>
+              <a:t>validation/persistent-shift-2026-06/acceptance.json SHA256 15705a3d9d58348b60a50a314c33c90e3e76f6416449d81d72aa157e10b8535a</a:t>
             </a:r>
           </a:p>
           <a:p xmlns:a="http://schemas.openxmlformats.org/drawingml/2006/main">
@@ -666,6 +898,16 @@
           </a:p>
           <a:p xmlns:a="http://schemas.openxmlformats.org/drawingml/2006/main">
             <a:r>
+              <a:t>validation/persistent-shift-2026-06/comparison.json SHA256 d0355b0a660d75381dff7411a389b5181e8db3cfeabf30041909fd2981934048</a:t>
+            </a:r>
+          </a:p>
+          <a:p xmlns:a="http://schemas.openxmlformats.org/drawingml/2006/main">
+            <a:r>
+              <a:t>validation/persistent-shift-2026-06/acceptance.json SHA256 15705a3d9d58348b60a50a314c33c90e3e76f6416449d81d72aa157e10b8535a</a:t>
+            </a:r>
+          </a:p>
+          <a:p xmlns:a="http://schemas.openxmlformats.org/drawingml/2006/main">
+            <a:r>
               <a:t>SimBench https://simbench.de/en/download/datasets/ ODbL1.0 / DbCL1.0。德国原始2016曲线按连续时段映射到中国时区2026仿真场景，非中国园区实测。公开回放 https://jinyh.github.io/energy-campus/ 。月度示范与72小时RSI研究分别记账。</a:t>
             </a:r>
           </a:p>
@@ -761,6 +1003,16 @@
           </a:p>
           <a:p xmlns:a="http://schemas.openxmlformats.org/drawingml/2006/main">
             <a:r>
+              <a:t>validation/persistent-shift-2026-06/comparison.json SHA256 d0355b0a660d75381dff7411a389b5181e8db3cfeabf30041909fd2981934048</a:t>
+            </a:r>
+          </a:p>
+          <a:p xmlns:a="http://schemas.openxmlformats.org/drawingml/2006/main">
+            <a:r>
+              <a:t>validation/persistent-shift-2026-06/acceptance.json SHA256 15705a3d9d58348b60a50a314c33c90e3e76f6416449d81d72aa157e10b8535a</a:t>
+            </a:r>
+          </a:p>
+          <a:p xmlns:a="http://schemas.openxmlformats.org/drawingml/2006/main">
+            <a:r>
               <a:t>SimBench https://simbench.de/en/download/datasets/ ODbL1.0 / DbCL1.0。德国原始2016曲线按连续时段映射到中国时区2026仿真场景，非中国园区实测。公开回放 https://jinyh.github.io/energy-campus/ 。月度示范与72小时RSI研究分别记账。</a:t>
             </a:r>
           </a:p>
@@ -856,6 +1108,16 @@
           </a:p>
           <a:p xmlns:a="http://schemas.openxmlformats.org/drawingml/2006/main">
             <a:r>
+              <a:t>validation/persistent-shift-2026-06/comparison.json SHA256 d0355b0a660d75381dff7411a389b5181e8db3cfeabf30041909fd2981934048</a:t>
+            </a:r>
+          </a:p>
+          <a:p xmlns:a="http://schemas.openxmlformats.org/drawingml/2006/main">
+            <a:r>
+              <a:t>validation/persistent-shift-2026-06/acceptance.json SHA256 15705a3d9d58348b60a50a314c33c90e3e76f6416449d81d72aa157e10b8535a</a:t>
+            </a:r>
+          </a:p>
+          <a:p xmlns:a="http://schemas.openxmlformats.org/drawingml/2006/main">
+            <a:r>
               <a:t>SimBench https://simbench.de/en/download/datasets/ ODbL1.0 / DbCL1.0。德国原始2016曲线按连续时段映射到中国时区2026仿真场景，非中国园区实测。公开回放 https://jinyh.github.io/energy-campus/ 。月度示范与72小时RSI研究分别记账。</a:t>
             </a:r>
           </a:p>
@@ -951,6 +1213,16 @@
           </a:p>
           <a:p xmlns:a="http://schemas.openxmlformats.org/drawingml/2006/main">
             <a:r>
+              <a:t>validation/persistent-shift-2026-06/comparison.json SHA256 d0355b0a660d75381dff7411a389b5181e8db3cfeabf30041909fd2981934048</a:t>
+            </a:r>
+          </a:p>
+          <a:p xmlns:a="http://schemas.openxmlformats.org/drawingml/2006/main">
+            <a:r>
+              <a:t>validation/persistent-shift-2026-06/acceptance.json SHA256 15705a3d9d58348b60a50a314c33c90e3e76f6416449d81d72aa157e10b8535a</a:t>
+            </a:r>
+          </a:p>
+          <a:p xmlns:a="http://schemas.openxmlformats.org/drawingml/2006/main">
+            <a:r>
               <a:t>SimBench https://simbench.de/en/download/datasets/ ODbL1.0 / DbCL1.0。德国原始2016曲线按连续时段映射到中国时区2026仿真场景，非中国园区实测。公开回放 https://jinyh.github.io/energy-campus/ 。月度示范与72小时RSI研究分别记账。</a:t>
             </a:r>
           </a:p>
@@ -1046,6 +1318,16 @@
           </a:p>
           <a:p xmlns:a="http://schemas.openxmlformats.org/drawingml/2006/main">
             <a:r>
+              <a:t>validation/persistent-shift-2026-06/comparison.json SHA256 d0355b0a660d75381dff7411a389b5181e8db3cfeabf30041909fd2981934048</a:t>
+            </a:r>
+          </a:p>
+          <a:p xmlns:a="http://schemas.openxmlformats.org/drawingml/2006/main">
+            <a:r>
+              <a:t>validation/persistent-shift-2026-06/acceptance.json SHA256 15705a3d9d58348b60a50a314c33c90e3e76f6416449d81d72aa157e10b8535a</a:t>
+            </a:r>
+          </a:p>
+          <a:p xmlns:a="http://schemas.openxmlformats.org/drawingml/2006/main">
+            <a:r>
               <a:t>SimBench https://simbench.de/en/download/datasets/ ODbL1.0 / DbCL1.0。德国原始2016曲线按连续时段映射到中国时区2026仿真场景，非中国园区实测。公开回放 https://jinyh.github.io/energy-campus/ 。月度示范与72小时RSI研究分别记账。</a:t>
             </a:r>
           </a:p>
@@ -1141,6 +1423,16 @@
           </a:p>
           <a:p xmlns:a="http://schemas.openxmlformats.org/drawingml/2006/main">
             <a:r>
+              <a:t>validation/persistent-shift-2026-06/comparison.json SHA256 d0355b0a660d75381dff7411a389b5181e8db3cfeabf30041909fd2981934048</a:t>
+            </a:r>
+          </a:p>
+          <a:p xmlns:a="http://schemas.openxmlformats.org/drawingml/2006/main">
+            <a:r>
+              <a:t>validation/persistent-shift-2026-06/acceptance.json SHA256 15705a3d9d58348b60a50a314c33c90e3e76f6416449d81d72aa157e10b8535a</a:t>
+            </a:r>
+          </a:p>
+          <a:p xmlns:a="http://schemas.openxmlformats.org/drawingml/2006/main">
+            <a:r>
               <a:t>SimBench https://simbench.de/en/download/datasets/ ODbL1.0 / DbCL1.0。德国原始2016曲线按连续时段映射到中国时区2026仿真场景，非中国园区实测。公开回放 https://jinyh.github.io/energy-campus/ 。月度示范与72小时RSI研究分别记账。</a:t>
             </a:r>
           </a:p>
@@ -1236,6 +1528,16 @@
           </a:p>
           <a:p xmlns:a="http://schemas.openxmlformats.org/drawingml/2006/main">
             <a:r>
+              <a:t>validation/persistent-shift-2026-06/comparison.json SHA256 d0355b0a660d75381dff7411a389b5181e8db3cfeabf30041909fd2981934048</a:t>
+            </a:r>
+          </a:p>
+          <a:p xmlns:a="http://schemas.openxmlformats.org/drawingml/2006/main">
+            <a:r>
+              <a:t>validation/persistent-shift-2026-06/acceptance.json SHA256 15705a3d9d58348b60a50a314c33c90e3e76f6416449d81d72aa157e10b8535a</a:t>
+            </a:r>
+          </a:p>
+          <a:p xmlns:a="http://schemas.openxmlformats.org/drawingml/2006/main">
+            <a:r>
               <a:t>SimBench https://simbench.de/en/download/datasets/ ODbL1.0 / DbCL1.0。德国原始2016曲线按连续时段映射到中国时区2026仿真场景，非中国园区实测。公开回放 https://jinyh.github.io/energy-campus/ 。月度示范与72小时RSI研究分别记账。</a:t>
             </a:r>
           </a:p>
@@ -1327,6 +1629,16 @@
           <a:p xmlns:a="http://schemas.openxmlformats.org/drawingml/2006/main">
             <a:r>
               <a:t>results/v32/opportunity/7a6aa4e97c225bc8/result.json SHA256 1af53221b4745a51325ccf8e66133f1253ae2db7cd50b9ea681c18658d39c008</a:t>
+            </a:r>
+          </a:p>
+          <a:p xmlns:a="http://schemas.openxmlformats.org/drawingml/2006/main">
+            <a:r>
+              <a:t>validation/persistent-shift-2026-06/comparison.json SHA256 d0355b0a660d75381dff7411a389b5181e8db3cfeabf30041909fd2981934048</a:t>
+            </a:r>
+          </a:p>
+          <a:p xmlns:a="http://schemas.openxmlformats.org/drawingml/2006/main">
+            <a:r>
+              <a:t>validation/persistent-shift-2026-06/acceptance.json SHA256 15705a3d9d58348b60a50a314c33c90e3e76f6416449d81d72aa157e10b8535a</a:t>
             </a:r>
           </a:p>
           <a:p xmlns:a="http://schemas.openxmlformats.org/drawingml/2006/main">
@@ -1399,7 +1711,7 @@
   </p:cSld>
   <p:clrMap bg1="lt1" tx1="dk1" bg2="lt2" tx2="dk2" accent1="accent1" accent2="accent2" accent3="accent3" accent4="accent4" accent5="accent5" accent6="accent6" hlink="hlink" folHlink="folHlink"/>
   <p:sldLayoutIdLst>
-    <p:sldLayoutId xmlns:r="http://schemas.openxmlformats.org/officeDocument/2006/relationships" id="2147483649" r:id="R37977c17f9654495"/>
+    <p:sldLayoutId xmlns:r="http://schemas.openxmlformats.org/officeDocument/2006/relationships" id="2147483649" r:id="R125a502dfd704d19"/>
   </p:sldLayoutIdLst>
   <p:txStyles>
     <p:titleStyle>
@@ -1950,7 +2262,7 @@
           <p:cNvPr id="10" name="">
             <a:extLst xmlns:a="http://schemas.openxmlformats.org/drawingml/2006/main">
               <a:ext uri="{FF2B5EF4-FFF2-40B4-BE49-F238E27FC236}">
-                <a16:creationId xmlns:a16="http://schemas.microsoft.com/office/drawing/2014/main" id="{6FAB16E6-B35F-42D1-97D8-FAC519314CF7}"/>
+                <a16:creationId xmlns:a16="http://schemas.microsoft.com/office/drawing/2014/main" id="{AD864E90-6E39-4226-876A-FA0FCD1A881E}"/>
               </a:ext>
             </a:extLst>
           </p:cNvPr>
@@ -2007,7 +2319,7 @@
           <p:cNvPr id="2" name="">
             <a:extLst xmlns:a="http://schemas.openxmlformats.org/drawingml/2006/main">
               <a:ext uri="{FF2B5EF4-FFF2-40B4-BE49-F238E27FC236}">
-                <a16:creationId xmlns:a16="http://schemas.microsoft.com/office/drawing/2014/main" id="{89200A78-D99B-4F2F-BB81-E68A00811D5F}"/>
+                <a16:creationId xmlns:a16="http://schemas.microsoft.com/office/drawing/2014/main" id="{02A6855A-3C7C-4DAA-888C-B71B844BE977}"/>
               </a:ext>
             </a:extLst>
           </p:cNvPr>
@@ -2064,7 +2376,7 @@
           <p:cNvPr id="3" name="">
             <a:extLst xmlns:a="http://schemas.openxmlformats.org/drawingml/2006/main">
               <a:ext uri="{FF2B5EF4-FFF2-40B4-BE49-F238E27FC236}">
-                <a16:creationId xmlns:a16="http://schemas.microsoft.com/office/drawing/2014/main" id="{03ADDE1F-457B-45E8-8ECC-D1FCC2DEA446}"/>
+                <a16:creationId xmlns:a16="http://schemas.microsoft.com/office/drawing/2014/main" id="{BB7F91EE-CF4F-4CC5-9123-C7A5270140DA}"/>
               </a:ext>
             </a:extLst>
           </p:cNvPr>
@@ -2094,7 +2406,7 @@
           <p:cNvPr id="4" name="">
             <a:extLst xmlns:a="http://schemas.openxmlformats.org/drawingml/2006/main">
               <a:ext uri="{FF2B5EF4-FFF2-40B4-BE49-F238E27FC236}">
-                <a16:creationId xmlns:a16="http://schemas.microsoft.com/office/drawing/2014/main" id="{FC6BECF2-CEB5-444A-A07F-1CD29BBFD41E}"/>
+                <a16:creationId xmlns:a16="http://schemas.microsoft.com/office/drawing/2014/main" id="{1FAD54F3-6919-4D6A-BBBB-69A02D483CE1}"/>
               </a:ext>
             </a:extLst>
           </p:cNvPr>
@@ -2151,7 +2463,7 @@
           <p:cNvPr id="5" name="">
             <a:extLst xmlns:a="http://schemas.openxmlformats.org/drawingml/2006/main">
               <a:ext uri="{FF2B5EF4-FFF2-40B4-BE49-F238E27FC236}">
-                <a16:creationId xmlns:a16="http://schemas.microsoft.com/office/drawing/2014/main" id="{30F801E1-00E7-43F7-BDA0-BF9E893EA0C3}"/>
+                <a16:creationId xmlns:a16="http://schemas.microsoft.com/office/drawing/2014/main" id="{27D9472E-501C-4A29-9626-68CCC9CB5321}"/>
               </a:ext>
             </a:extLst>
           </p:cNvPr>
@@ -2208,7 +2520,7 @@
           <p:cNvPr id="6" name="">
             <a:extLst xmlns:a="http://schemas.openxmlformats.org/drawingml/2006/main">
               <a:ext uri="{FF2B5EF4-FFF2-40B4-BE49-F238E27FC236}">
-                <a16:creationId xmlns:a16="http://schemas.microsoft.com/office/drawing/2014/main" id="{AE306A13-90D7-491F-87FA-D5B2A2EF556C}"/>
+                <a16:creationId xmlns:a16="http://schemas.microsoft.com/office/drawing/2014/main" id="{25DB8952-4B37-4F18-9ADF-B3B01B85FE4F}"/>
               </a:ext>
             </a:extLst>
           </p:cNvPr>
@@ -2265,7 +2577,7 @@
           <p:cNvPr id="7" name="">
             <a:extLst xmlns:a="http://schemas.openxmlformats.org/drawingml/2006/main">
               <a:ext uri="{FF2B5EF4-FFF2-40B4-BE49-F238E27FC236}">
-                <a16:creationId xmlns:a16="http://schemas.microsoft.com/office/drawing/2014/main" id="{07EDAF15-BE45-417B-BC16-20D42EEA9E86}"/>
+                <a16:creationId xmlns:a16="http://schemas.microsoft.com/office/drawing/2014/main" id="{7C75C50E-D6EE-4F4C-BE7D-28E6B878E27D}"/>
               </a:ext>
             </a:extLst>
           </p:cNvPr>
@@ -2322,7 +2634,7 @@
           <p:cNvPr id="8" name="">
             <a:extLst xmlns:a="http://schemas.openxmlformats.org/drawingml/2006/main">
               <a:ext uri="{FF2B5EF4-FFF2-40B4-BE49-F238E27FC236}">
-                <a16:creationId xmlns:a16="http://schemas.microsoft.com/office/drawing/2014/main" id="{0C2831B2-926C-46AE-992A-095DD6BB9CC7}"/>
+                <a16:creationId xmlns:a16="http://schemas.microsoft.com/office/drawing/2014/main" id="{2B720187-8556-4931-9E79-F7F6FF44B791}"/>
               </a:ext>
             </a:extLst>
           </p:cNvPr>
@@ -2379,7 +2691,7 @@
           <p:cNvPr id="9" name="">
             <a:extLst xmlns:a="http://schemas.openxmlformats.org/drawingml/2006/main">
               <a:ext uri="{FF2B5EF4-FFF2-40B4-BE49-F238E27FC236}">
-                <a16:creationId xmlns:a16="http://schemas.microsoft.com/office/drawing/2014/main" id="{4E0F35AA-5ED6-440D-834F-0C05A583B6EB}"/>
+                <a16:creationId xmlns:a16="http://schemas.microsoft.com/office/drawing/2014/main" id="{E89713E6-F046-45C1-A2F9-5D47E92B6A77}"/>
               </a:ext>
             </a:extLst>
           </p:cNvPr>
@@ -2434,7 +2746,7 @@
     </p:spTree>
     <p:extLst>
       <p:ext uri="{BB962C8B-B14F-4D97-AF65-F5344CB8AC3E}">
-        <p14:creationId xmlns:p14="http://schemas.microsoft.com/office/powerpoint/2010/main" val="2130466238"/>
+        <p14:creationId xmlns:p14="http://schemas.microsoft.com/office/powerpoint/2010/main" val="244709147"/>
       </p:ext>
     </p:extLst>
   </p:cSld>
@@ -2462,10 +2774,10 @@
       </p:grpSpPr>
       <p:sp>
         <p:nvSpPr>
-          <p:cNvPr id="8" name="">
+          <p:cNvPr id="10" name="">
             <a:extLst xmlns:a="http://schemas.openxmlformats.org/drawingml/2006/main">
               <a:ext uri="{FF2B5EF4-FFF2-40B4-BE49-F238E27FC236}">
-                <a16:creationId xmlns:a16="http://schemas.microsoft.com/office/drawing/2014/main" id="{FA3A0715-4DD2-44B7-84CC-DE605BB5DFB7}"/>
+                <a16:creationId xmlns:a16="http://schemas.microsoft.com/office/drawing/2014/main" id="{51AD00FA-EB13-40A8-A958-0C76BA32E4D0}"/>
               </a:ext>
             </a:extLst>
           </p:cNvPr>
@@ -2512,7 +2824,7 @@
                 <a:ea typeface="Hiragino Sans GB"/>
                 <a:cs typeface="Hiragino Sans GB"/>
               </a:rPr>
-              <a:t>交付</a:t>
+              <a:t>新增月度业务案例</a:t>
             </a:r>
           </a:p>
         </p:txBody>
@@ -2522,7 +2834,7 @@
           <p:cNvPr id="2" name="">
             <a:extLst xmlns:a="http://schemas.openxmlformats.org/drawingml/2006/main">
               <a:ext uri="{FF2B5EF4-FFF2-40B4-BE49-F238E27FC236}">
-                <a16:creationId xmlns:a16="http://schemas.microsoft.com/office/drawing/2014/main" id="{95CF7467-852D-41D6-9936-DA2C91E9719E}"/>
+                <a16:creationId xmlns:a16="http://schemas.microsoft.com/office/drawing/2014/main" id="{04FE5DA2-FDA8-4E8C-9C96-89C198A69E6F}"/>
               </a:ext>
             </a:extLst>
           </p:cNvPr>
@@ -2569,7 +2881,7 @@
                 <a:ea typeface="Hiragino Sans GB"/>
                 <a:cs typeface="Hiragino Sans GB"/>
               </a:rPr>
-              <a:t>在线回放与本机复算</a:t>
+              <a:t>持续供需偏移的逐时证据</a:t>
             </a:r>
           </a:p>
         </p:txBody>
@@ -2579,7 +2891,7 @@
           <p:cNvPr id="3" name="">
             <a:extLst xmlns:a="http://schemas.openxmlformats.org/drawingml/2006/main">
               <a:ext uri="{FF2B5EF4-FFF2-40B4-BE49-F238E27FC236}">
-                <a16:creationId xmlns:a16="http://schemas.microsoft.com/office/drawing/2014/main" id="{6A48B518-4D27-4D9E-94C4-160CEF993DC5}"/>
+                <a16:creationId xmlns:a16="http://schemas.microsoft.com/office/drawing/2014/main" id="{689CAB80-BD17-4F6F-8A88-F796C2D180C3}"/>
               </a:ext>
             </a:extLst>
           </p:cNvPr>
@@ -2604,6 +2916,1790 @@
           </a:ln>
         </p:spPr>
       </p:sp>
+      <p:sp>
+        <p:nvSpPr>
+          <p:cNvPr id="4" name="">
+            <a:extLst xmlns:a="http://schemas.openxmlformats.org/drawingml/2006/main">
+              <a:ext uri="{FF2B5EF4-FFF2-40B4-BE49-F238E27FC236}">
+                <a16:creationId xmlns:a16="http://schemas.microsoft.com/office/drawing/2014/main" id="{18176386-5237-4094-91D9-6FB7AC9585E1}"/>
+              </a:ext>
+            </a:extLst>
+          </p:cNvPr>
+          <p:cNvSpPr>
+            <a:spLocks xmlns:a="http://schemas.openxmlformats.org/drawingml/2006/main" noGrp="1"/>
+          </p:cNvSpPr>
+          <p:nvPr/>
+        </p:nvSpPr>
+        <p:spPr>
+          <a:xfrm xmlns:a="http://schemas.openxmlformats.org/drawingml/2006/main">
+            <a:off x="714375" y="1809750"/>
+            <a:ext cx="10572750" cy="609600"/>
+          </a:xfrm>
+          <a:prstGeom xmlns:a="http://schemas.openxmlformats.org/drawingml/2006/main" prst="rect">
+            <a:avLst/>
+          </a:prstGeom>
+          <a:noFill xmlns:a="http://schemas.openxmlformats.org/drawingml/2006/main"/>
+          <a:ln xmlns:a="http://schemas.openxmlformats.org/drawingml/2006/main" w="0">
+            <a:noFill/>
+          </a:ln>
+        </p:spPr>
+        <p:txBody>
+          <a:bodyPr xmlns:a="http://schemas.openxmlformats.org/drawingml/2006/main" wrap="square" lIns="19050" tIns="19050" rIns="19050" bIns="19050" anchor="ctr">
+            <a:normAutofit fontScale="100000"/>
+          </a:bodyPr>
+          <a:lstStyle xmlns:a="http://schemas.openxmlformats.org/drawingml/2006/main"/>
+          <a:p xmlns:a="http://schemas.openxmlformats.org/drawingml/2006/main">
+            <a:pPr algn="l">
+              <a:defRPr sz="2100" b="1">
+                <a:solidFill>
+                  <a:srgbClr val="75D5C5"/>
+                </a:solidFill>
+                <a:latin typeface="Hiragino Sans GB"/>
+                <a:ea typeface="Hiragino Sans GB"/>
+                <a:cs typeface="Hiragino Sans GB"/>
+              </a:defRPr>
+            </a:pPr>
+            <a:r>
+              <a:rPr sz="2100" b="1">
+                <a:solidFill>
+                  <a:srgbClr val="75D5C5"/>
+                </a:solidFill>
+                <a:latin typeface="Hiragino Sans GB"/>
+                <a:ea typeface="Hiragino Sans GB"/>
+                <a:cs typeface="Hiragino Sans GB"/>
+              </a:rPr>
+              <a:t>第 2 日起至月末：负荷增加 28%，17–21 时增加 40%，光伏降至 55%</a:t>
+            </a:r>
+          </a:p>
+        </p:txBody>
+      </p:sp>
+      <p:graphicFrame>
+        <p:nvGraphicFramePr>
+          <p:cNvPr id="14" name=""/>
+          <p:cNvGraphicFramePr/>
+          <p:nvPr/>
+        </p:nvGraphicFramePr>
+        <p:xfrm>
+          <a:off xmlns:a="http://schemas.openxmlformats.org/drawingml/2006/main" x="666750" y="2667000"/>
+          <a:ext xmlns:a="http://schemas.openxmlformats.org/drawingml/2006/main" cx="10858500" cy="2286000"/>
+        </p:xfrm>
+        <a:graphic xmlns:a="http://schemas.openxmlformats.org/drawingml/2006/main">
+          <a:graphicData uri="http://schemas.openxmlformats.org/drawingml/2006/table">
+            <a:tbl>
+              <a:tblPr/>
+              <a:tblGrid>
+                <a:gridCol w="3238500"/>
+                <a:gridCol w="7620000"/>
+              </a:tblGrid>
+              <a:tr h="457200">
+                <a:tc>
+                  <a:txBody>
+                    <a:bodyPr wrap="square">
+                      <a:normAutofit/>
+                    </a:bodyPr>
+                    <a:lstStyle/>
+                    <a:p>
+                      <a:r>
+                        <a:rPr sz="1725" b="1">
+                          <a:solidFill>
+                            <a:srgbClr val="FFFFFF"/>
+                          </a:solidFill>
+                          <a:latin typeface="Hiragino Sans GB"/>
+                          <a:ea typeface="Hiragino Sans GB"/>
+                          <a:cs typeface="Hiragino Sans GB"/>
+                        </a:rPr>
+                        <a:t>诊断时刻</a:t>
+                      </a:r>
+                    </a:p>
+                  </a:txBody>
+                  <a:tcPr marL="95250" marR="95250" marT="9525" marB="9525" anchor="ctr">
+                    <a:solidFill>
+                      <a:srgbClr val="28465F"/>
+                    </a:solidFill>
+                  </a:tcPr>
+                </a:tc>
+                <a:tc>
+                  <a:txBody>
+                    <a:bodyPr wrap="square">
+                      <a:normAutofit/>
+                    </a:bodyPr>
+                    <a:lstStyle/>
+                    <a:p>
+                      <a:r>
+                        <a:rPr sz="1725" b="1">
+                          <a:solidFill>
+                            <a:srgbClr val="FFFFFF"/>
+                          </a:solidFill>
+                          <a:latin typeface="Hiragino Sans GB"/>
+                          <a:ea typeface="Hiragino Sans GB"/>
+                          <a:cs typeface="Hiragino Sans GB"/>
+                        </a:rPr>
+                        <a:t>北京时间 06-02 08:00</a:t>
+                      </a:r>
+                    </a:p>
+                  </a:txBody>
+                  <a:tcPr marL="95250" marR="95250" marT="9525" marB="9525" anchor="ctr">
+                    <a:solidFill>
+                      <a:srgbClr val="28465F"/>
+                    </a:solidFill>
+                  </a:tcPr>
+                </a:tc>
+              </a:tr>
+              <a:tr h="457200">
+                <a:tc>
+                  <a:txBody>
+                    <a:bodyPr wrap="square">
+                      <a:normAutofit/>
+                    </a:bodyPr>
+                    <a:lstStyle/>
+                    <a:p>
+                      <a:r>
+                        <a:rPr sz="1725" b="0">
+                          <a:solidFill>
+                            <a:srgbClr val="E5EDF7"/>
+                          </a:solidFill>
+                          <a:latin typeface="Hiragino Sans GB"/>
+                          <a:ea typeface="Hiragino Sans GB"/>
+                          <a:cs typeface="Hiragino Sans GB"/>
+                        </a:rPr>
+                        <a:t>已揭示证据</a:t>
+                      </a:r>
+                    </a:p>
+                  </a:txBody>
+                  <a:tcPr marL="95250" marR="95250" marT="9525" marB="9525" anchor="ctr">
+                    <a:solidFill>
+                      <a:srgbClr val="14273C"/>
+                    </a:solidFill>
+                  </a:tcPr>
+                </a:tc>
+                <a:tc>
+                  <a:txBody>
+                    <a:bodyPr wrap="square">
+                      <a:normAutofit/>
+                    </a:bodyPr>
+                    <a:lstStyle/>
+                    <a:p>
+                      <a:r>
+                        <a:rPr sz="1725" b="0">
+                          <a:solidFill>
+                            <a:srgbClr val="E5EDF7"/>
+                          </a:solidFill>
+                          <a:latin typeface="Hiragino Sans GB"/>
+                          <a:ea typeface="Hiragino Sans GB"/>
+                          <a:cs typeface="Hiragino Sans GB"/>
+                        </a:rPr>
+                        <a:t>124 条一小时提前量预测，最近七天窗口</a:t>
+                      </a:r>
+                    </a:p>
+                  </a:txBody>
+                  <a:tcPr marL="95250" marR="95250" marT="9525" marB="9525" anchor="ctr">
+                    <a:solidFill>
+                      <a:srgbClr val="14273C"/>
+                    </a:solidFill>
+                  </a:tcPr>
+                </a:tc>
+              </a:tr>
+              <a:tr h="457200">
+                <a:tc>
+                  <a:txBody>
+                    <a:bodyPr wrap="square">
+                      <a:normAutofit/>
+                    </a:bodyPr>
+                    <a:lstStyle/>
+                    <a:p>
+                      <a:r>
+                        <a:rPr sz="1725" b="0">
+                          <a:solidFill>
+                            <a:srgbClr val="E5EDF7"/>
+                          </a:solidFill>
+                          <a:latin typeface="Hiragino Sans GB"/>
+                          <a:ea typeface="Hiragino Sans GB"/>
+                          <a:cs typeface="Hiragino Sans GB"/>
+                        </a:rPr>
+                        <a:t>平均残差</a:t>
+                      </a:r>
+                    </a:p>
+                  </a:txBody>
+                  <a:tcPr marL="95250" marR="95250" marT="9525" marB="9525" anchor="ctr">
+                    <a:solidFill>
+                      <a:srgbClr val="192D43"/>
+                    </a:solidFill>
+                  </a:tcPr>
+                </a:tc>
+                <a:tc>
+                  <a:txBody>
+                    <a:bodyPr wrap="square">
+                      <a:normAutofit/>
+                    </a:bodyPr>
+                    <a:lstStyle/>
+                    <a:p>
+                      <a:r>
+                        <a:rPr sz="1725" b="0">
+                          <a:solidFill>
+                            <a:srgbClr val="E5EDF7"/>
+                          </a:solidFill>
+                          <a:latin typeface="Hiragino Sans GB"/>
+                          <a:ea typeface="Hiragino Sans GB"/>
+                          <a:cs typeface="Hiragino Sans GB"/>
+                        </a:rPr>
+                        <a:t>20.23 kW，相对偏差 11.19%</a:t>
+                      </a:r>
+                    </a:p>
+                  </a:txBody>
+                  <a:tcPr marL="95250" marR="95250" marT="9525" marB="9525" anchor="ctr">
+                    <a:solidFill>
+                      <a:srgbClr val="192D43"/>
+                    </a:solidFill>
+                  </a:tcPr>
+                </a:tc>
+              </a:tr>
+              <a:tr h="457200">
+                <a:tc>
+                  <a:txBody>
+                    <a:bodyPr wrap="square">
+                      <a:normAutofit/>
+                    </a:bodyPr>
+                    <a:lstStyle/>
+                    <a:p>
+                      <a:r>
+                        <a:rPr sz="1725" b="0">
+                          <a:solidFill>
+                            <a:srgbClr val="E5EDF7"/>
+                          </a:solidFill>
+                          <a:latin typeface="Hiragino Sans GB"/>
+                          <a:ea typeface="Hiragino Sans GB"/>
+                          <a:cs typeface="Hiragino Sans GB"/>
+                        </a:rPr>
+                        <a:t>同号比例</a:t>
+                      </a:r>
+                    </a:p>
+                  </a:txBody>
+                  <a:tcPr marL="95250" marR="95250" marT="9525" marB="9525" anchor="ctr">
+                    <a:solidFill>
+                      <a:srgbClr val="14273C"/>
+                    </a:solidFill>
+                  </a:tcPr>
+                </a:tc>
+                <a:tc>
+                  <a:txBody>
+                    <a:bodyPr wrap="square">
+                      <a:normAutofit/>
+                    </a:bodyPr>
+                    <a:lstStyle/>
+                    <a:p>
+                      <a:r>
+                        <a:rPr sz="1725" b="0">
+                          <a:solidFill>
+                            <a:srgbClr val="E5EDF7"/>
+                          </a:solidFill>
+                          <a:latin typeface="Hiragino Sans GB"/>
+                          <a:ea typeface="Hiragino Sans GB"/>
+                          <a:cs typeface="Hiragino Sans GB"/>
+                        </a:rPr>
+                        <a:t>75.00%</a:t>
+                      </a:r>
+                    </a:p>
+                  </a:txBody>
+                  <a:tcPr marL="95250" marR="95250" marT="9525" marB="9525" anchor="ctr">
+                    <a:solidFill>
+                      <a:srgbClr val="14273C"/>
+                    </a:solidFill>
+                  </a:tcPr>
+                </a:tc>
+              </a:tr>
+              <a:tr h="457200">
+                <a:tc>
+                  <a:txBody>
+                    <a:bodyPr wrap="square">
+                      <a:normAutofit/>
+                    </a:bodyPr>
+                    <a:lstStyle/>
+                    <a:p>
+                      <a:r>
+                        <a:rPr sz="1725" b="0">
+                          <a:solidFill>
+                            <a:srgbClr val="E5EDF7"/>
+                          </a:solidFill>
+                          <a:latin typeface="Hiragino Sans GB"/>
+                          <a:ea typeface="Hiragino Sans GB"/>
+                          <a:cs typeface="Hiragino Sans GB"/>
+                        </a:rPr>
+                        <a:t>最新实值与发布值</a:t>
+                      </a:r>
+                    </a:p>
+                  </a:txBody>
+                  <a:tcPr marL="95250" marR="95250" marT="9525" marB="9525" anchor="ctr">
+                    <a:solidFill>
+                      <a:srgbClr val="192D43"/>
+                    </a:solidFill>
+                  </a:tcPr>
+                </a:tc>
+                <a:tc>
+                  <a:txBody>
+                    <a:bodyPr wrap="square">
+                      <a:normAutofit/>
+                    </a:bodyPr>
+                    <a:lstStyle/>
+                    <a:p>
+                      <a:r>
+                        <a:rPr sz="1725" b="0">
+                          <a:solidFill>
+                            <a:srgbClr val="E5EDF7"/>
+                          </a:solidFill>
+                          <a:latin typeface="Hiragino Sans GB"/>
+                          <a:ea typeface="Hiragino Sans GB"/>
+                          <a:cs typeface="Hiragino Sans GB"/>
+                        </a:rPr>
+                        <a:t>384.93 kW / 143.85 kW</a:t>
+                      </a:r>
+                    </a:p>
+                  </a:txBody>
+                  <a:tcPr marL="95250" marR="95250" marT="9525" marB="9525" anchor="ctr">
+                    <a:solidFill>
+                      <a:srgbClr val="192D43"/>
+                    </a:solidFill>
+                  </a:tcPr>
+                </a:tc>
+              </a:tr>
+            </a:tbl>
+          </a:graphicData>
+        </a:graphic>
+      </p:graphicFrame>
+      <p:sp>
+        <p:nvSpPr>
+          <p:cNvPr id="6" name="">
+            <a:extLst xmlns:a="http://schemas.openxmlformats.org/drawingml/2006/main">
+              <a:ext uri="{FF2B5EF4-FFF2-40B4-BE49-F238E27FC236}">
+                <a16:creationId xmlns:a16="http://schemas.microsoft.com/office/drawing/2014/main" id="{E9416B70-0704-4662-8EFE-DADFA6F750CF}"/>
+              </a:ext>
+            </a:extLst>
+          </p:cNvPr>
+          <p:cNvSpPr>
+            <a:spLocks xmlns:a="http://schemas.openxmlformats.org/drawingml/2006/main" noGrp="1"/>
+          </p:cNvSpPr>
+          <p:nvPr/>
+        </p:nvSpPr>
+        <p:spPr>
+          <a:xfrm xmlns:a="http://schemas.openxmlformats.org/drawingml/2006/main">
+            <a:off x="714375" y="5191125"/>
+            <a:ext cx="10572750" cy="523875"/>
+          </a:xfrm>
+          <a:prstGeom xmlns:a="http://schemas.openxmlformats.org/drawingml/2006/main" prst="rect">
+            <a:avLst/>
+          </a:prstGeom>
+          <a:noFill xmlns:a="http://schemas.openxmlformats.org/drawingml/2006/main"/>
+          <a:ln xmlns:a="http://schemas.openxmlformats.org/drawingml/2006/main" w="0">
+            <a:noFill/>
+          </a:ln>
+        </p:spPr>
+        <p:txBody>
+          <a:bodyPr xmlns:a="http://schemas.openxmlformats.org/drawingml/2006/main" wrap="square" lIns="19050" tIns="19050" rIns="19050" bIns="19050" anchor="ctr">
+            <a:normAutofit fontScale="100000"/>
+          </a:bodyPr>
+          <a:lstStyle xmlns:a="http://schemas.openxmlformats.org/drawingml/2006/main"/>
+          <a:p xmlns:a="http://schemas.openxmlformats.org/drawingml/2006/main">
+            <a:pPr algn="l">
+              <a:defRPr sz="2100" b="1">
+                <a:solidFill>
+                  <a:srgbClr val="E9B675"/>
+                </a:solidFill>
+                <a:latin typeface="Hiragino Sans GB"/>
+                <a:ea typeface="Hiragino Sans GB"/>
+                <a:cs typeface="Hiragino Sans GB"/>
+              </a:defRPr>
+            </a:pPr>
+            <a:r>
+              <a:rPr sz="2100" b="1">
+                <a:solidFill>
+                  <a:srgbClr val="E9B675"/>
+                </a:solidFill>
+                <a:latin typeface="Hiragino Sans GB"/>
+                <a:ea typeface="Hiragino Sans GB"/>
+                <a:cs typeface="Hiragino Sans GB"/>
+              </a:rPr>
+              <a:t>规则方案累计过载 30 分钟，修复未完全解决，判为不合格</a:t>
+            </a:r>
+          </a:p>
+        </p:txBody>
+      </p:sp>
+      <p:sp>
+        <p:nvSpPr>
+          <p:cNvPr id="7" name="">
+            <a:extLst xmlns:a="http://schemas.openxmlformats.org/drawingml/2006/main">
+              <a:ext uri="{FF2B5EF4-FFF2-40B4-BE49-F238E27FC236}">
+                <a16:creationId xmlns:a16="http://schemas.microsoft.com/office/drawing/2014/main" id="{8B6FA187-2715-4C27-8251-5FCC5D6C53E5}"/>
+              </a:ext>
+            </a:extLst>
+          </p:cNvPr>
+          <p:cNvSpPr>
+            <a:spLocks xmlns:a="http://schemas.openxmlformats.org/drawingml/2006/main" noGrp="1"/>
+          </p:cNvSpPr>
+          <p:nvPr/>
+        </p:nvSpPr>
+        <p:spPr>
+          <a:xfrm xmlns:a="http://schemas.openxmlformats.org/drawingml/2006/main">
+            <a:off x="714375" y="5857875"/>
+            <a:ext cx="10572750" cy="381000"/>
+          </a:xfrm>
+          <a:prstGeom xmlns:a="http://schemas.openxmlformats.org/drawingml/2006/main" prst="rect">
+            <a:avLst/>
+          </a:prstGeom>
+          <a:noFill xmlns:a="http://schemas.openxmlformats.org/drawingml/2006/main"/>
+          <a:ln xmlns:a="http://schemas.openxmlformats.org/drawingml/2006/main" w="0">
+            <a:noFill/>
+          </a:ln>
+        </p:spPr>
+        <p:txBody>
+          <a:bodyPr xmlns:a="http://schemas.openxmlformats.org/drawingml/2006/main" wrap="square" lIns="19050" tIns="19050" rIns="19050" bIns="19050" anchor="ctr">
+            <a:normAutofit fontScale="100000"/>
+          </a:bodyPr>
+          <a:lstStyle xmlns:a="http://schemas.openxmlformats.org/drawingml/2006/main"/>
+          <a:p xmlns:a="http://schemas.openxmlformats.org/drawingml/2006/main">
+            <a:pPr algn="l">
+              <a:defRPr sz="1725" b="0">
+                <a:solidFill>
+                  <a:srgbClr val="9BB0C9"/>
+                </a:solidFill>
+                <a:latin typeface="Hiragino Sans GB"/>
+                <a:ea typeface="Hiragino Sans GB"/>
+                <a:cs typeface="Hiragino Sans GB"/>
+              </a:defRPr>
+            </a:pPr>
+            <a:r>
+              <a:rPr sz="1725" b="0">
+                <a:solidFill>
+                  <a:srgbClr val="9BB0C9"/>
+                </a:solidFill>
+                <a:latin typeface="Hiragino Sans GB"/>
+                <a:ea typeface="Hiragino Sans GB"/>
+                <a:cs typeface="Hiragino Sans GB"/>
+              </a:rPr>
+              <a:t>偏差门槛描述预测误差，不能直接判断设备故障。当前场景不含动态降额。</a:t>
+            </a:r>
+          </a:p>
+        </p:txBody>
+      </p:sp>
+      <p:sp>
+        <p:nvSpPr>
+          <p:cNvPr id="8" name="">
+            <a:extLst xmlns:a="http://schemas.openxmlformats.org/drawingml/2006/main">
+              <a:ext uri="{FF2B5EF4-FFF2-40B4-BE49-F238E27FC236}">
+                <a16:creationId xmlns:a16="http://schemas.microsoft.com/office/drawing/2014/main" id="{564A0DE4-596C-47FB-B66E-8E18577231EF}"/>
+              </a:ext>
+            </a:extLst>
+          </p:cNvPr>
+          <p:cNvSpPr>
+            <a:spLocks xmlns:a="http://schemas.openxmlformats.org/drawingml/2006/main" noGrp="1"/>
+          </p:cNvSpPr>
+          <p:nvPr/>
+        </p:nvSpPr>
+        <p:spPr>
+          <a:xfrm xmlns:a="http://schemas.openxmlformats.org/drawingml/2006/main">
+            <a:off x="619125" y="6467475"/>
+            <a:ext cx="10096500" cy="190500"/>
+          </a:xfrm>
+          <a:prstGeom xmlns:a="http://schemas.openxmlformats.org/drawingml/2006/main" prst="rect">
+            <a:avLst/>
+          </a:prstGeom>
+          <a:noFill xmlns:a="http://schemas.openxmlformats.org/drawingml/2006/main"/>
+          <a:ln xmlns:a="http://schemas.openxmlformats.org/drawingml/2006/main" w="0">
+            <a:noFill/>
+          </a:ln>
+        </p:spPr>
+        <p:txBody>
+          <a:bodyPr xmlns:a="http://schemas.openxmlformats.org/drawingml/2006/main" wrap="square" lIns="19050" tIns="19050" rIns="19050" bIns="19050" anchor="ctr">
+            <a:normAutofit fontScale="100000"/>
+          </a:bodyPr>
+          <a:lstStyle xmlns:a="http://schemas.openxmlformats.org/drawingml/2006/main"/>
+          <a:p xmlns:a="http://schemas.openxmlformats.org/drawingml/2006/main">
+            <a:pPr algn="l">
+              <a:defRPr sz="975" b="0">
+                <a:solidFill>
+                  <a:srgbClr val="9BB0C9"/>
+                </a:solidFill>
+                <a:latin typeface="Hiragino Sans GB"/>
+                <a:ea typeface="Hiragino Sans GB"/>
+                <a:cs typeface="Hiragino Sans GB"/>
+              </a:defRPr>
+            </a:pPr>
+            <a:r>
+              <a:rPr sz="975" b="0">
+                <a:solidFill>
+                  <a:srgbClr val="9BB0C9"/>
+                </a:solidFill>
+                <a:latin typeface="Hiragino Sans GB"/>
+                <a:ea typeface="Hiragino Sans GB"/>
+                <a:cs typeface="Hiragino Sans GB"/>
+              </a:rPr>
+              <a:t>2026年6月仿真 · v3.2 · 公开基准验证</a:t>
+            </a:r>
+          </a:p>
+        </p:txBody>
+      </p:sp>
+      <p:sp>
+        <p:nvSpPr>
+          <p:cNvPr id="9" name="">
+            <a:extLst xmlns:a="http://schemas.openxmlformats.org/drawingml/2006/main">
+              <a:ext uri="{FF2B5EF4-FFF2-40B4-BE49-F238E27FC236}">
+                <a16:creationId xmlns:a16="http://schemas.microsoft.com/office/drawing/2014/main" id="{475299A1-35B3-4680-A2E1-4100C9ACD8AE}"/>
+              </a:ext>
+            </a:extLst>
+          </p:cNvPr>
+          <p:cNvSpPr>
+            <a:spLocks xmlns:a="http://schemas.openxmlformats.org/drawingml/2006/main" noGrp="1"/>
+          </p:cNvSpPr>
+          <p:nvPr/>
+        </p:nvSpPr>
+        <p:spPr>
+          <a:xfrm xmlns:a="http://schemas.openxmlformats.org/drawingml/2006/main">
+            <a:off x="11096625" y="6429375"/>
+            <a:ext cx="476250" cy="238125"/>
+          </a:xfrm>
+          <a:prstGeom xmlns:a="http://schemas.openxmlformats.org/drawingml/2006/main" prst="rect">
+            <a:avLst/>
+          </a:prstGeom>
+          <a:noFill xmlns:a="http://schemas.openxmlformats.org/drawingml/2006/main"/>
+          <a:ln xmlns:a="http://schemas.openxmlformats.org/drawingml/2006/main" w="0">
+            <a:noFill/>
+          </a:ln>
+        </p:spPr>
+        <p:txBody>
+          <a:bodyPr xmlns:a="http://schemas.openxmlformats.org/drawingml/2006/main" wrap="square" lIns="19050" tIns="19050" rIns="19050" bIns="19050" anchor="ctr">
+            <a:normAutofit fontScale="100000"/>
+          </a:bodyPr>
+          <a:lstStyle xmlns:a="http://schemas.openxmlformats.org/drawingml/2006/main"/>
+          <a:p xmlns:a="http://schemas.openxmlformats.org/drawingml/2006/main">
+            <a:pPr algn="r">
+              <a:defRPr sz="1125" b="0">
+                <a:solidFill>
+                  <a:srgbClr val="9BB0C9"/>
+                </a:solidFill>
+                <a:latin typeface="Hiragino Sans GB"/>
+                <a:ea typeface="Hiragino Sans GB"/>
+                <a:cs typeface="Hiragino Sans GB"/>
+              </a:defRPr>
+            </a:pPr>
+            <a:r>
+              <a:rPr sz="1125" b="0">
+                <a:solidFill>
+                  <a:srgbClr val="9BB0C9"/>
+                </a:solidFill>
+                <a:latin typeface="Hiragino Sans GB"/>
+                <a:ea typeface="Hiragino Sans GB"/>
+                <a:cs typeface="Hiragino Sans GB"/>
+              </a:rPr>
+              <a:t>10</a:t>
+            </a:r>
+          </a:p>
+        </p:txBody>
+      </p:sp>
+    </p:spTree>
+    <p:extLst>
+      <p:ext uri="{BB962C8B-B14F-4D97-AF65-F5344CB8AC3E}">
+        <p14:creationId xmlns:p14="http://schemas.microsoft.com/office/powerpoint/2010/main" val="713574097"/>
+      </p:ext>
+    </p:extLst>
+  </p:cSld>
+</p:sld>
+</file>
+
+<file path=ppt/slides/slide11.xml><?xml version="1.0" encoding="utf-8"?>
+<p:sld xmlns:p="http://schemas.openxmlformats.org/presentationml/2006/main">
+  <p:cSld>
+    <p:bg>
+      <p:bgPr>
+        <a:solidFill xmlns:a="http://schemas.openxmlformats.org/drawingml/2006/main">
+          <a:srgbClr val="0D192A"/>
+        </a:solidFill>
+      </p:bgPr>
+    </p:bg>
+    <p:spTree>
+      <p:nvGrpSpPr>
+        <p:cNvPr id="1" name=""/>
+        <p:cNvGrpSpPr/>
+        <p:nvPr/>
+      </p:nvGrpSpPr>
+      <p:grpSpPr>
+        <a:xfrm xmlns:a="http://schemas.openxmlformats.org/drawingml/2006/main"/>
+      </p:grpSpPr>
+      <p:sp>
+        <p:nvSpPr>
+          <p:cNvPr id="10" name="">
+            <a:extLst xmlns:a="http://schemas.openxmlformats.org/drawingml/2006/main">
+              <a:ext uri="{FF2B5EF4-FFF2-40B4-BE49-F238E27FC236}">
+                <a16:creationId xmlns:a16="http://schemas.microsoft.com/office/drawing/2014/main" id="{8FC5E31F-D58F-4879-A6D8-24C9F8A02185}"/>
+              </a:ext>
+            </a:extLst>
+          </p:cNvPr>
+          <p:cNvSpPr>
+            <a:spLocks xmlns:a="http://schemas.openxmlformats.org/drawingml/2006/main" noGrp="1"/>
+          </p:cNvSpPr>
+          <p:nvPr/>
+        </p:nvSpPr>
+        <p:spPr>
+          <a:xfrm xmlns:a="http://schemas.openxmlformats.org/drawingml/2006/main">
+            <a:off x="619125" y="295275"/>
+            <a:ext cx="10477500" cy="228600"/>
+          </a:xfrm>
+          <a:prstGeom xmlns:a="http://schemas.openxmlformats.org/drawingml/2006/main" prst="rect">
+            <a:avLst/>
+          </a:prstGeom>
+          <a:noFill xmlns:a="http://schemas.openxmlformats.org/drawingml/2006/main"/>
+          <a:ln xmlns:a="http://schemas.openxmlformats.org/drawingml/2006/main" w="0">
+            <a:noFill/>
+          </a:ln>
+        </p:spPr>
+        <p:txBody>
+          <a:bodyPr xmlns:a="http://schemas.openxmlformats.org/drawingml/2006/main" wrap="square" lIns="19050" tIns="19050" rIns="19050" bIns="19050" anchor="ctr">
+            <a:normAutofit fontScale="100000"/>
+          </a:bodyPr>
+          <a:lstStyle xmlns:a="http://schemas.openxmlformats.org/drawingml/2006/main"/>
+          <a:p xmlns:a="http://schemas.openxmlformats.org/drawingml/2006/main">
+            <a:pPr algn="l">
+              <a:defRPr sz="1125" b="0">
+                <a:solidFill>
+                  <a:srgbClr val="75D5C5"/>
+                </a:solidFill>
+                <a:latin typeface="Hiragino Sans GB"/>
+                <a:ea typeface="Hiragino Sans GB"/>
+                <a:cs typeface="Hiragino Sans GB"/>
+              </a:defRPr>
+            </a:pPr>
+            <a:r>
+              <a:rPr sz="1125" b="0">
+                <a:solidFill>
+                  <a:srgbClr val="75D5C5"/>
+                </a:solidFill>
+                <a:latin typeface="Hiragino Sans GB"/>
+                <a:ea typeface="Hiragino Sans GB"/>
+                <a:cs typeface="Hiragino Sans GB"/>
+              </a:rPr>
+              <a:t>共同工程工具</a:t>
+            </a:r>
+          </a:p>
+        </p:txBody>
+      </p:sp>
+      <p:sp>
+        <p:nvSpPr>
+          <p:cNvPr id="2" name="">
+            <a:extLst xmlns:a="http://schemas.openxmlformats.org/drawingml/2006/main">
+              <a:ext uri="{FF2B5EF4-FFF2-40B4-BE49-F238E27FC236}">
+                <a16:creationId xmlns:a16="http://schemas.microsoft.com/office/drawing/2014/main" id="{06ABD60A-E584-4C0B-A84A-4AEFE2C872EB}"/>
+              </a:ext>
+            </a:extLst>
+          </p:cNvPr>
+          <p:cNvSpPr>
+            <a:spLocks xmlns:a="http://schemas.openxmlformats.org/drawingml/2006/main" noGrp="1"/>
+          </p:cNvSpPr>
+          <p:nvPr/>
+        </p:nvSpPr>
+        <p:spPr>
+          <a:xfrm xmlns:a="http://schemas.openxmlformats.org/drawingml/2006/main">
+            <a:off x="619125" y="685800"/>
+            <a:ext cx="10906125" cy="666750"/>
+          </a:xfrm>
+          <a:prstGeom xmlns:a="http://schemas.openxmlformats.org/drawingml/2006/main" prst="rect">
+            <a:avLst/>
+          </a:prstGeom>
+          <a:noFill xmlns:a="http://schemas.openxmlformats.org/drawingml/2006/main"/>
+          <a:ln xmlns:a="http://schemas.openxmlformats.org/drawingml/2006/main" w="0">
+            <a:noFill/>
+          </a:ln>
+        </p:spPr>
+        <p:txBody>
+          <a:bodyPr xmlns:a="http://schemas.openxmlformats.org/drawingml/2006/main" wrap="square" lIns="19050" tIns="19050" rIns="19050" bIns="19050" anchor="ctr">
+            <a:normAutofit fontScale="100000"/>
+          </a:bodyPr>
+          <a:lstStyle xmlns:a="http://schemas.openxmlformats.org/drawingml/2006/main"/>
+          <a:p xmlns:a="http://schemas.openxmlformats.org/drawingml/2006/main">
+            <a:pPr algn="l">
+              <a:defRPr sz="3150" b="1">
+                <a:solidFill>
+                  <a:srgbClr val="E5EDF7"/>
+                </a:solidFill>
+                <a:latin typeface="Hiragino Sans GB"/>
+                <a:ea typeface="Hiragino Sans GB"/>
+                <a:cs typeface="Hiragino Sans GB"/>
+              </a:defRPr>
+            </a:pPr>
+            <a:r>
+              <a:rPr sz="3150" b="1">
+                <a:solidFill>
+                  <a:srgbClr val="E5EDF7"/>
+                </a:solidFill>
+                <a:latin typeface="Hiragino Sans GB"/>
+                <a:ea typeface="Hiragino Sans GB"/>
+                <a:cs typeface="Hiragino Sans GB"/>
+              </a:rPr>
+              <a:t>滚动预测校正的实际经营比较</a:t>
+            </a:r>
+          </a:p>
+        </p:txBody>
+      </p:sp>
+      <p:sp>
+        <p:nvSpPr>
+          <p:cNvPr id="3" name="">
+            <a:extLst xmlns:a="http://schemas.openxmlformats.org/drawingml/2006/main">
+              <a:ext uri="{FF2B5EF4-FFF2-40B4-BE49-F238E27FC236}">
+                <a16:creationId xmlns:a16="http://schemas.microsoft.com/office/drawing/2014/main" id="{8630C84B-C4D7-423A-948C-520E2576DC56}"/>
+              </a:ext>
+            </a:extLst>
+          </p:cNvPr>
+          <p:cNvSpPr>
+            <a:spLocks xmlns:a="http://schemas.openxmlformats.org/drawingml/2006/main" noGrp="1"/>
+          </p:cNvSpPr>
+          <p:nvPr/>
+        </p:nvSpPr>
+        <p:spPr>
+          <a:xfrm xmlns:a="http://schemas.openxmlformats.org/drawingml/2006/main">
+            <a:off x="619125" y="1419225"/>
+            <a:ext cx="10906125" cy="9525"/>
+          </a:xfrm>
+          <a:prstGeom xmlns:a="http://schemas.openxmlformats.org/drawingml/2006/main" prst="rect">
+            <a:avLst/>
+          </a:prstGeom>
+          <a:solidFill xmlns:a="http://schemas.openxmlformats.org/drawingml/2006/main">
+            <a:srgbClr val="3A526D"/>
+          </a:solidFill>
+          <a:ln xmlns:a="http://schemas.openxmlformats.org/drawingml/2006/main" w="0">
+            <a:noFill/>
+          </a:ln>
+        </p:spPr>
+      </p:sp>
+      <p:graphicFrame>
+        <p:nvGraphicFramePr>
+          <p:cNvPr id="13" name=""/>
+          <p:cNvGraphicFramePr/>
+          <p:nvPr/>
+        </p:nvGraphicFramePr>
+        <p:xfrm>
+          <a:off xmlns:a="http://schemas.openxmlformats.org/drawingml/2006/main" x="666750" y="1905000"/>
+          <a:ext xmlns:a="http://schemas.openxmlformats.org/drawingml/2006/main" cx="10858500" cy="2238375"/>
+        </p:xfrm>
+        <a:graphic xmlns:a="http://schemas.openxmlformats.org/drawingml/2006/main">
+          <a:graphicData uri="http://schemas.openxmlformats.org/drawingml/2006/table">
+            <a:tbl>
+              <a:tblPr/>
+              <a:tblGrid>
+                <a:gridCol w="2476500"/>
+                <a:gridCol w="2333625"/>
+                <a:gridCol w="2333625"/>
+                <a:gridCol w="2095500"/>
+                <a:gridCol w="1619250"/>
+              </a:tblGrid>
+              <a:tr h="559594">
+                <a:tc>
+                  <a:txBody>
+                    <a:bodyPr wrap="square">
+                      <a:normAutofit/>
+                    </a:bodyPr>
+                    <a:lstStyle/>
+                    <a:p>
+                      <a:r>
+                        <a:rPr sz="1725" b="1">
+                          <a:solidFill>
+                            <a:srgbClr val="FFFFFF"/>
+                          </a:solidFill>
+                          <a:latin typeface="Hiragino Sans GB"/>
+                          <a:ea typeface="Hiragino Sans GB"/>
+                          <a:cs typeface="Hiragino Sans GB"/>
+                        </a:rPr>
+                        <a:t>调度方案</a:t>
+                      </a:r>
+                    </a:p>
+                  </a:txBody>
+                  <a:tcPr marL="95250" marR="95250" marT="9525" marB="9525" anchor="ctr">
+                    <a:solidFill>
+                      <a:srgbClr val="28465F"/>
+                    </a:solidFill>
+                  </a:tcPr>
+                </a:tc>
+                <a:tc>
+                  <a:txBody>
+                    <a:bodyPr wrap="square">
+                      <a:normAutofit/>
+                    </a:bodyPr>
+                    <a:lstStyle/>
+                    <a:p>
+                      <a:r>
+                        <a:rPr sz="1725" b="1">
+                          <a:solidFill>
+                            <a:srgbClr val="FFFFFF"/>
+                          </a:solidFill>
+                          <a:latin typeface="Hiragino Sans GB"/>
+                          <a:ea typeface="Hiragino Sans GB"/>
+                          <a:cs typeface="Hiragino Sans GB"/>
+                        </a:rPr>
+                        <a:t>原始 / 元</a:t>
+                      </a:r>
+                    </a:p>
+                  </a:txBody>
+                  <a:tcPr marL="95250" marR="95250" marT="9525" marB="9525" anchor="ctr">
+                    <a:solidFill>
+                      <a:srgbClr val="28465F"/>
+                    </a:solidFill>
+                  </a:tcPr>
+                </a:tc>
+                <a:tc>
+                  <a:txBody>
+                    <a:bodyPr wrap="square">
+                      <a:normAutofit/>
+                    </a:bodyPr>
+                    <a:lstStyle/>
+                    <a:p>
+                      <a:r>
+                        <a:rPr sz="1725" b="1">
+                          <a:solidFill>
+                            <a:srgbClr val="FFFFFF"/>
+                          </a:solidFill>
+                          <a:latin typeface="Hiragino Sans GB"/>
+                          <a:ea typeface="Hiragino Sans GB"/>
+                          <a:cs typeface="Hiragino Sans GB"/>
+                        </a:rPr>
+                        <a:t>校正 / 元</a:t>
+                      </a:r>
+                    </a:p>
+                  </a:txBody>
+                  <a:tcPr marL="95250" marR="95250" marT="9525" marB="9525" anchor="ctr">
+                    <a:solidFill>
+                      <a:srgbClr val="28465F"/>
+                    </a:solidFill>
+                  </a:tcPr>
+                </a:tc>
+                <a:tc>
+                  <a:txBody>
+                    <a:bodyPr wrap="square">
+                      <a:normAutofit/>
+                    </a:bodyPr>
+                    <a:lstStyle/>
+                    <a:p>
+                      <a:r>
+                        <a:rPr sz="1725" b="1">
+                          <a:solidFill>
+                            <a:srgbClr val="FFFFFF"/>
+                          </a:solidFill>
+                          <a:latin typeface="Hiragino Sans GB"/>
+                          <a:ea typeface="Hiragino Sans GB"/>
+                          <a:cs typeface="Hiragino Sans GB"/>
+                        </a:rPr>
+                        <a:t>节省 / 元</a:t>
+                      </a:r>
+                    </a:p>
+                  </a:txBody>
+                  <a:tcPr marL="95250" marR="95250" marT="9525" marB="9525" anchor="ctr">
+                    <a:solidFill>
+                      <a:srgbClr val="28465F"/>
+                    </a:solidFill>
+                  </a:tcPr>
+                </a:tc>
+                <a:tc>
+                  <a:txBody>
+                    <a:bodyPr wrap="square">
+                      <a:normAutofit/>
+                    </a:bodyPr>
+                    <a:lstStyle/>
+                    <a:p>
+                      <a:r>
+                        <a:rPr sz="1725" b="1">
+                          <a:solidFill>
+                            <a:srgbClr val="FFFFFF"/>
+                          </a:solidFill>
+                          <a:latin typeface="Hiragino Sans GB"/>
+                          <a:ea typeface="Hiragino Sans GB"/>
+                          <a:cs typeface="Hiragino Sans GB"/>
+                        </a:rPr>
+                        <a:t>比例</a:t>
+                      </a:r>
+                    </a:p>
+                  </a:txBody>
+                  <a:tcPr marL="95250" marR="95250" marT="9525" marB="9525" anchor="ctr">
+                    <a:solidFill>
+                      <a:srgbClr val="28465F"/>
+                    </a:solidFill>
+                  </a:tcPr>
+                </a:tc>
+              </a:tr>
+              <a:tr h="559594">
+                <a:tc>
+                  <a:txBody>
+                    <a:bodyPr wrap="square">
+                      <a:normAutofit/>
+                    </a:bodyPr>
+                    <a:lstStyle/>
+                    <a:p>
+                      <a:r>
+                        <a:rPr sz="1725" b="0">
+                          <a:solidFill>
+                            <a:srgbClr val="E5EDF7"/>
+                          </a:solidFill>
+                          <a:latin typeface="Hiragino Sans GB"/>
+                          <a:ea typeface="Hiragino Sans GB"/>
+                          <a:cs typeface="Hiragino Sans GB"/>
+                        </a:rPr>
+                        <a:t>规则</a:t>
+                      </a:r>
+                    </a:p>
+                  </a:txBody>
+                  <a:tcPr marL="95250" marR="95250" marT="9525" marB="9525" anchor="ctr">
+                    <a:solidFill>
+                      <a:srgbClr val="14273C"/>
+                    </a:solidFill>
+                  </a:tcPr>
+                </a:tc>
+                <a:tc>
+                  <a:txBody>
+                    <a:bodyPr wrap="square">
+                      <a:normAutofit/>
+                    </a:bodyPr>
+                    <a:lstStyle/>
+                    <a:p>
+                      <a:r>
+                        <a:rPr sz="1725" b="0">
+                          <a:solidFill>
+                            <a:srgbClr val="E5EDF7"/>
+                          </a:solidFill>
+                          <a:latin typeface="Hiragino Sans GB"/>
+                          <a:ea typeface="Hiragino Sans GB"/>
+                          <a:cs typeface="Hiragino Sans GB"/>
+                        </a:rPr>
+                        <a:t>108,634.25</a:t>
+                      </a:r>
+                    </a:p>
+                  </a:txBody>
+                  <a:tcPr marL="95250" marR="95250" marT="9525" marB="9525" anchor="ctr">
+                    <a:solidFill>
+                      <a:srgbClr val="14273C"/>
+                    </a:solidFill>
+                  </a:tcPr>
+                </a:tc>
+                <a:tc>
+                  <a:txBody>
+                    <a:bodyPr wrap="square">
+                      <a:normAutofit/>
+                    </a:bodyPr>
+                    <a:lstStyle/>
+                    <a:p>
+                      <a:r>
+                        <a:rPr sz="1725" b="0">
+                          <a:solidFill>
+                            <a:srgbClr val="E5EDF7"/>
+                          </a:solidFill>
+                          <a:latin typeface="Hiragino Sans GB"/>
+                          <a:ea typeface="Hiragino Sans GB"/>
+                          <a:cs typeface="Hiragino Sans GB"/>
+                        </a:rPr>
+                        <a:t>108,634.25</a:t>
+                      </a:r>
+                    </a:p>
+                  </a:txBody>
+                  <a:tcPr marL="95250" marR="95250" marT="9525" marB="9525" anchor="ctr">
+                    <a:solidFill>
+                      <a:srgbClr val="14273C"/>
+                    </a:solidFill>
+                  </a:tcPr>
+                </a:tc>
+                <a:tc>
+                  <a:txBody>
+                    <a:bodyPr wrap="square">
+                      <a:normAutofit/>
+                    </a:bodyPr>
+                    <a:lstStyle/>
+                    <a:p>
+                      <a:r>
+                        <a:rPr sz="1725" b="0">
+                          <a:solidFill>
+                            <a:srgbClr val="E5EDF7"/>
+                          </a:solidFill>
+                          <a:latin typeface="Hiragino Sans GB"/>
+                          <a:ea typeface="Hiragino Sans GB"/>
+                          <a:cs typeface="Hiragino Sans GB"/>
+                        </a:rPr>
+                        <a:t>未同时合格</a:t>
+                      </a:r>
+                    </a:p>
+                  </a:txBody>
+                  <a:tcPr marL="95250" marR="95250" marT="9525" marB="9525" anchor="ctr">
+                    <a:solidFill>
+                      <a:srgbClr val="14273C"/>
+                    </a:solidFill>
+                  </a:tcPr>
+                </a:tc>
+                <a:tc>
+                  <a:txBody>
+                    <a:bodyPr wrap="square">
+                      <a:normAutofit/>
+                    </a:bodyPr>
+                    <a:lstStyle/>
+                    <a:p>
+                      <a:r>
+                        <a:rPr sz="1725" b="0">
+                          <a:solidFill>
+                            <a:srgbClr val="E5EDF7"/>
+                          </a:solidFill>
+                          <a:latin typeface="Hiragino Sans GB"/>
+                          <a:ea typeface="Hiragino Sans GB"/>
+                          <a:cs typeface="Hiragino Sans GB"/>
+                        </a:rPr>
+                        <a:t>不可比</a:t>
+                      </a:r>
+                    </a:p>
+                  </a:txBody>
+                  <a:tcPr marL="95250" marR="95250" marT="9525" marB="9525" anchor="ctr">
+                    <a:solidFill>
+                      <a:srgbClr val="14273C"/>
+                    </a:solidFill>
+                  </a:tcPr>
+                </a:tc>
+              </a:tr>
+              <a:tr h="559594">
+                <a:tc>
+                  <a:txBody>
+                    <a:bodyPr wrap="square">
+                      <a:normAutofit/>
+                    </a:bodyPr>
+                    <a:lstStyle/>
+                    <a:p>
+                      <a:r>
+                        <a:rPr sz="1725" b="0">
+                          <a:solidFill>
+                            <a:srgbClr val="E5EDF7"/>
+                          </a:solidFill>
+                          <a:latin typeface="Hiragino Sans GB"/>
+                          <a:ea typeface="Hiragino Sans GB"/>
+                          <a:cs typeface="Hiragino Sans GB"/>
+                        </a:rPr>
+                        <a:t>确定性 MPC</a:t>
+                      </a:r>
+                    </a:p>
+                  </a:txBody>
+                  <a:tcPr marL="95250" marR="95250" marT="9525" marB="9525" anchor="ctr">
+                    <a:solidFill>
+                      <a:srgbClr val="192D43"/>
+                    </a:solidFill>
+                  </a:tcPr>
+                </a:tc>
+                <a:tc>
+                  <a:txBody>
+                    <a:bodyPr wrap="square">
+                      <a:normAutofit/>
+                    </a:bodyPr>
+                    <a:lstStyle/>
+                    <a:p>
+                      <a:r>
+                        <a:rPr sz="1725" b="0">
+                          <a:solidFill>
+                            <a:srgbClr val="E5EDF7"/>
+                          </a:solidFill>
+                          <a:latin typeface="Hiragino Sans GB"/>
+                          <a:ea typeface="Hiragino Sans GB"/>
+                          <a:cs typeface="Hiragino Sans GB"/>
+                        </a:rPr>
+                        <a:t>108,171.52</a:t>
+                      </a:r>
+                    </a:p>
+                  </a:txBody>
+                  <a:tcPr marL="95250" marR="95250" marT="9525" marB="9525" anchor="ctr">
+                    <a:solidFill>
+                      <a:srgbClr val="192D43"/>
+                    </a:solidFill>
+                  </a:tcPr>
+                </a:tc>
+                <a:tc>
+                  <a:txBody>
+                    <a:bodyPr wrap="square">
+                      <a:normAutofit/>
+                    </a:bodyPr>
+                    <a:lstStyle/>
+                    <a:p>
+                      <a:r>
+                        <a:rPr sz="1725" b="0">
+                          <a:solidFill>
+                            <a:srgbClr val="E5EDF7"/>
+                          </a:solidFill>
+                          <a:latin typeface="Hiragino Sans GB"/>
+                          <a:ea typeface="Hiragino Sans GB"/>
+                          <a:cs typeface="Hiragino Sans GB"/>
+                        </a:rPr>
+                        <a:t>108,172.98</a:t>
+                      </a:r>
+                    </a:p>
+                  </a:txBody>
+                  <a:tcPr marL="95250" marR="95250" marT="9525" marB="9525" anchor="ctr">
+                    <a:solidFill>
+                      <a:srgbClr val="192D43"/>
+                    </a:solidFill>
+                  </a:tcPr>
+                </a:tc>
+                <a:tc>
+                  <a:txBody>
+                    <a:bodyPr wrap="square">
+                      <a:normAutofit/>
+                    </a:bodyPr>
+                    <a:lstStyle/>
+                    <a:p>
+                      <a:r>
+                        <a:rPr sz="1725" b="0">
+                          <a:solidFill>
+                            <a:srgbClr val="E5EDF7"/>
+                          </a:solidFill>
+                          <a:latin typeface="Hiragino Sans GB"/>
+                          <a:ea typeface="Hiragino Sans GB"/>
+                          <a:cs typeface="Hiragino Sans GB"/>
+                        </a:rPr>
+                        <a:t>-1.46</a:t>
+                      </a:r>
+                    </a:p>
+                  </a:txBody>
+                  <a:tcPr marL="95250" marR="95250" marT="9525" marB="9525" anchor="ctr">
+                    <a:solidFill>
+                      <a:srgbClr val="192D43"/>
+                    </a:solidFill>
+                  </a:tcPr>
+                </a:tc>
+                <a:tc>
+                  <a:txBody>
+                    <a:bodyPr wrap="square">
+                      <a:normAutofit/>
+                    </a:bodyPr>
+                    <a:lstStyle/>
+                    <a:p>
+                      <a:r>
+                        <a:rPr sz="1725" b="0">
+                          <a:solidFill>
+                            <a:srgbClr val="E5EDF7"/>
+                          </a:solidFill>
+                          <a:latin typeface="Hiragino Sans GB"/>
+                          <a:ea typeface="Hiragino Sans GB"/>
+                          <a:cs typeface="Hiragino Sans GB"/>
+                        </a:rPr>
+                        <a:t>-0.001%</a:t>
+                      </a:r>
+                    </a:p>
+                  </a:txBody>
+                  <a:tcPr marL="95250" marR="95250" marT="9525" marB="9525" anchor="ctr">
+                    <a:solidFill>
+                      <a:srgbClr val="192D43"/>
+                    </a:solidFill>
+                  </a:tcPr>
+                </a:tc>
+              </a:tr>
+              <a:tr h="559594">
+                <a:tc>
+                  <a:txBody>
+                    <a:bodyPr wrap="square">
+                      <a:normAutofit/>
+                    </a:bodyPr>
+                    <a:lstStyle/>
+                    <a:p>
+                      <a:r>
+                        <a:rPr sz="1725" b="0">
+                          <a:solidFill>
+                            <a:srgbClr val="E5EDF7"/>
+                          </a:solidFill>
+                          <a:latin typeface="Hiragino Sans GB"/>
+                          <a:ea typeface="Hiragino Sans GB"/>
+                          <a:cs typeface="Hiragino Sans GB"/>
+                        </a:rPr>
+                        <a:t>情景 MPC</a:t>
+                      </a:r>
+                    </a:p>
+                  </a:txBody>
+                  <a:tcPr marL="95250" marR="95250" marT="9525" marB="9525" anchor="ctr">
+                    <a:solidFill>
+                      <a:srgbClr val="14273C"/>
+                    </a:solidFill>
+                  </a:tcPr>
+                </a:tc>
+                <a:tc>
+                  <a:txBody>
+                    <a:bodyPr wrap="square">
+                      <a:normAutofit/>
+                    </a:bodyPr>
+                    <a:lstStyle/>
+                    <a:p>
+                      <a:r>
+                        <a:rPr sz="1725" b="0">
+                          <a:solidFill>
+                            <a:srgbClr val="E5EDF7"/>
+                          </a:solidFill>
+                          <a:latin typeface="Hiragino Sans GB"/>
+                          <a:ea typeface="Hiragino Sans GB"/>
+                          <a:cs typeface="Hiragino Sans GB"/>
+                        </a:rPr>
+                        <a:t>108,415.78</a:t>
+                      </a:r>
+                    </a:p>
+                  </a:txBody>
+                  <a:tcPr marL="95250" marR="95250" marT="9525" marB="9525" anchor="ctr">
+                    <a:solidFill>
+                      <a:srgbClr val="14273C"/>
+                    </a:solidFill>
+                  </a:tcPr>
+                </a:tc>
+                <a:tc>
+                  <a:txBody>
+                    <a:bodyPr wrap="square">
+                      <a:normAutofit/>
+                    </a:bodyPr>
+                    <a:lstStyle/>
+                    <a:p>
+                      <a:r>
+                        <a:rPr sz="1725" b="0">
+                          <a:solidFill>
+                            <a:srgbClr val="E5EDF7"/>
+                          </a:solidFill>
+                          <a:latin typeface="Hiragino Sans GB"/>
+                          <a:ea typeface="Hiragino Sans GB"/>
+                          <a:cs typeface="Hiragino Sans GB"/>
+                        </a:rPr>
+                        <a:t>108,261.14</a:t>
+                      </a:r>
+                    </a:p>
+                  </a:txBody>
+                  <a:tcPr marL="95250" marR="95250" marT="9525" marB="9525" anchor="ctr">
+                    <a:solidFill>
+                      <a:srgbClr val="14273C"/>
+                    </a:solidFill>
+                  </a:tcPr>
+                </a:tc>
+                <a:tc>
+                  <a:txBody>
+                    <a:bodyPr wrap="square">
+                      <a:normAutofit/>
+                    </a:bodyPr>
+                    <a:lstStyle/>
+                    <a:p>
+                      <a:r>
+                        <a:rPr sz="1725" b="0">
+                          <a:solidFill>
+                            <a:srgbClr val="E5EDF7"/>
+                          </a:solidFill>
+                          <a:latin typeface="Hiragino Sans GB"/>
+                          <a:ea typeface="Hiragino Sans GB"/>
+                          <a:cs typeface="Hiragino Sans GB"/>
+                        </a:rPr>
+                        <a:t>154.65</a:t>
+                      </a:r>
+                    </a:p>
+                  </a:txBody>
+                  <a:tcPr marL="95250" marR="95250" marT="9525" marB="9525" anchor="ctr">
+                    <a:solidFill>
+                      <a:srgbClr val="14273C"/>
+                    </a:solidFill>
+                  </a:tcPr>
+                </a:tc>
+                <a:tc>
+                  <a:txBody>
+                    <a:bodyPr wrap="square">
+                      <a:normAutofit/>
+                    </a:bodyPr>
+                    <a:lstStyle/>
+                    <a:p>
+                      <a:r>
+                        <a:rPr sz="1725" b="0">
+                          <a:solidFill>
+                            <a:srgbClr val="E5EDF7"/>
+                          </a:solidFill>
+                          <a:latin typeface="Hiragino Sans GB"/>
+                          <a:ea typeface="Hiragino Sans GB"/>
+                          <a:cs typeface="Hiragino Sans GB"/>
+                        </a:rPr>
+                        <a:t>0.143%</a:t>
+                      </a:r>
+                    </a:p>
+                  </a:txBody>
+                  <a:tcPr marL="95250" marR="95250" marT="9525" marB="9525" anchor="ctr">
+                    <a:solidFill>
+                      <a:srgbClr val="14273C"/>
+                    </a:solidFill>
+                  </a:tcPr>
+                </a:tc>
+              </a:tr>
+            </a:tbl>
+          </a:graphicData>
+        </a:graphic>
+      </p:graphicFrame>
+      <p:sp>
+        <p:nvSpPr>
+          <p:cNvPr id="5" name="">
+            <a:extLst xmlns:a="http://schemas.openxmlformats.org/drawingml/2006/main">
+              <a:ext uri="{FF2B5EF4-FFF2-40B4-BE49-F238E27FC236}">
+                <a16:creationId xmlns:a16="http://schemas.microsoft.com/office/drawing/2014/main" id="{78320CE1-16A8-4E94-A2CD-A2D89A9EF7AB}"/>
+              </a:ext>
+            </a:extLst>
+          </p:cNvPr>
+          <p:cNvSpPr>
+            <a:spLocks xmlns:a="http://schemas.openxmlformats.org/drawingml/2006/main" noGrp="1"/>
+          </p:cNvSpPr>
+          <p:nvPr/>
+        </p:nvSpPr>
+        <p:spPr>
+          <a:xfrm xmlns:a="http://schemas.openxmlformats.org/drawingml/2006/main">
+            <a:off x="714375" y="4438650"/>
+            <a:ext cx="10572750" cy="476250"/>
+          </a:xfrm>
+          <a:prstGeom xmlns:a="http://schemas.openxmlformats.org/drawingml/2006/main" prst="rect">
+            <a:avLst/>
+          </a:prstGeom>
+          <a:noFill xmlns:a="http://schemas.openxmlformats.org/drawingml/2006/main"/>
+          <a:ln xmlns:a="http://schemas.openxmlformats.org/drawingml/2006/main" w="0">
+            <a:noFill/>
+          </a:ln>
+        </p:spPr>
+        <p:txBody>
+          <a:bodyPr xmlns:a="http://schemas.openxmlformats.org/drawingml/2006/main" wrap="square" lIns="19050" tIns="19050" rIns="19050" bIns="19050" anchor="ctr">
+            <a:normAutofit fontScale="100000"/>
+          </a:bodyPr>
+          <a:lstStyle xmlns:a="http://schemas.openxmlformats.org/drawingml/2006/main"/>
+          <a:p xmlns:a="http://schemas.openxmlformats.org/drawingml/2006/main">
+            <a:pPr algn="l">
+              <a:defRPr sz="2100" b="1">
+                <a:solidFill>
+                  <a:srgbClr val="75D5C5"/>
+                </a:solidFill>
+                <a:latin typeface="Hiragino Sans GB"/>
+                <a:ea typeface="Hiragino Sans GB"/>
+                <a:cs typeface="Hiragino Sans GB"/>
+              </a:defRPr>
+            </a:pPr>
+            <a:r>
+              <a:rPr sz="2100" b="1">
+                <a:solidFill>
+                  <a:srgbClr val="75D5C5"/>
+                </a:solidFill>
+                <a:latin typeface="Hiragino Sans GB"/>
+                <a:ea typeface="Hiragino Sans GB"/>
+                <a:cs typeface="Hiragino Sans GB"/>
+              </a:rPr>
+              <a:t>同一整月输入、合同与源码，仅改变各方案共享的预测工具</a:t>
+            </a:r>
+          </a:p>
+        </p:txBody>
+      </p:sp>
+      <p:sp>
+        <p:nvSpPr>
+          <p:cNvPr id="6" name="">
+            <a:extLst xmlns:a="http://schemas.openxmlformats.org/drawingml/2006/main">
+              <a:ext uri="{FF2B5EF4-FFF2-40B4-BE49-F238E27FC236}">
+                <a16:creationId xmlns:a16="http://schemas.microsoft.com/office/drawing/2014/main" id="{25464DB8-9A39-4418-A998-41DDBD78E9B1}"/>
+              </a:ext>
+            </a:extLst>
+          </p:cNvPr>
+          <p:cNvSpPr>
+            <a:spLocks xmlns:a="http://schemas.openxmlformats.org/drawingml/2006/main" noGrp="1"/>
+          </p:cNvSpPr>
+          <p:nvPr/>
+        </p:nvSpPr>
+        <p:spPr>
+          <a:xfrm xmlns:a="http://schemas.openxmlformats.org/drawingml/2006/main">
+            <a:off x="714375" y="5048250"/>
+            <a:ext cx="10572750" cy="685800"/>
+          </a:xfrm>
+          <a:prstGeom xmlns:a="http://schemas.openxmlformats.org/drawingml/2006/main" prst="rect">
+            <a:avLst/>
+          </a:prstGeom>
+          <a:noFill xmlns:a="http://schemas.openxmlformats.org/drawingml/2006/main"/>
+          <a:ln xmlns:a="http://schemas.openxmlformats.org/drawingml/2006/main" w="0">
+            <a:noFill/>
+          </a:ln>
+        </p:spPr>
+        <p:txBody>
+          <a:bodyPr xmlns:a="http://schemas.openxmlformats.org/drawingml/2006/main" wrap="square" lIns="19050" tIns="19050" rIns="19050" bIns="19050" anchor="ctr">
+            <a:normAutofit fontScale="100000"/>
+          </a:bodyPr>
+          <a:lstStyle xmlns:a="http://schemas.openxmlformats.org/drawingml/2006/main"/>
+          <a:p xmlns:a="http://schemas.openxmlformats.org/drawingml/2006/main">
+            <a:pPr algn="l">
+              <a:defRPr sz="1875" b="0">
+                <a:solidFill>
+                  <a:srgbClr val="E5EDF7"/>
+                </a:solidFill>
+                <a:latin typeface="Hiragino Sans GB"/>
+                <a:ea typeface="Hiragino Sans GB"/>
+                <a:cs typeface="Hiragino Sans GB"/>
+              </a:defRPr>
+            </a:pPr>
+            <a:r>
+              <a:rPr sz="1875" b="0">
+                <a:solidFill>
+                  <a:srgbClr val="E5EDF7"/>
+                </a:solidFill>
+                <a:latin typeface="Hiragino Sans GB"/>
+                <a:ea typeface="Hiragino Sans GB"/>
+                <a:cs typeface="Hiragino Sans GB"/>
+              </a:rPr>
+              <a:t>校正从本次运行开始参与优化，按发布时间使用已揭示残差。</a:t>
+            </a:r>
+          </a:p>
+          <a:p xmlns:a="http://schemas.openxmlformats.org/drawingml/2006/main">
+            <a:pPr algn="l">
+              <a:defRPr sz="1875" b="0">
+                <a:solidFill>
+                  <a:srgbClr val="E5EDF7"/>
+                </a:solidFill>
+                <a:latin typeface="Hiragino Sans GB"/>
+                <a:ea typeface="Hiragino Sans GB"/>
+                <a:cs typeface="Hiragino Sans GB"/>
+              </a:defRPr>
+            </a:pPr>
+            <a:r>
+              <a:rPr sz="1875" b="0">
+                <a:solidFill>
+                  <a:srgbClr val="E5EDF7"/>
+                </a:solidFill>
+                <a:latin typeface="Hiragino Sans GB"/>
+                <a:ea typeface="Hiragino Sans GB"/>
+                <a:cs typeface="Hiragino Sans GB"/>
+              </a:rPr>
+              <a:t>规则调度不读取未来预测，安全检查保持完整。</a:t>
+            </a:r>
+          </a:p>
+        </p:txBody>
+      </p:sp>
+      <p:sp>
+        <p:nvSpPr>
+          <p:cNvPr id="7" name="">
+            <a:extLst xmlns:a="http://schemas.openxmlformats.org/drawingml/2006/main">
+              <a:ext uri="{FF2B5EF4-FFF2-40B4-BE49-F238E27FC236}">
+                <a16:creationId xmlns:a16="http://schemas.microsoft.com/office/drawing/2014/main" id="{9CA235ED-784E-4497-A1A0-0A1B381FA1E6}"/>
+              </a:ext>
+            </a:extLst>
+          </p:cNvPr>
+          <p:cNvSpPr>
+            <a:spLocks xmlns:a="http://schemas.openxmlformats.org/drawingml/2006/main" noGrp="1"/>
+          </p:cNvSpPr>
+          <p:nvPr/>
+        </p:nvSpPr>
+        <p:spPr>
+          <a:xfrm xmlns:a="http://schemas.openxmlformats.org/drawingml/2006/main">
+            <a:off x="714375" y="5819775"/>
+            <a:ext cx="10572750" cy="314325"/>
+          </a:xfrm>
+          <a:prstGeom xmlns:a="http://schemas.openxmlformats.org/drawingml/2006/main" prst="rect">
+            <a:avLst/>
+          </a:prstGeom>
+          <a:noFill xmlns:a="http://schemas.openxmlformats.org/drawingml/2006/main"/>
+          <a:ln xmlns:a="http://schemas.openxmlformats.org/drawingml/2006/main" w="0">
+            <a:noFill/>
+          </a:ln>
+        </p:spPr>
+        <p:txBody>
+          <a:bodyPr xmlns:a="http://schemas.openxmlformats.org/drawingml/2006/main" wrap="square" lIns="19050" tIns="19050" rIns="19050" bIns="19050" anchor="ctr">
+            <a:normAutofit fontScale="100000"/>
+          </a:bodyPr>
+          <a:lstStyle xmlns:a="http://schemas.openxmlformats.org/drawingml/2006/main"/>
+          <a:p xmlns:a="http://schemas.openxmlformats.org/drawingml/2006/main">
+            <a:pPr algn="l">
+              <a:defRPr sz="1575" b="0">
+                <a:solidFill>
+                  <a:srgbClr val="9BB0C9"/>
+                </a:solidFill>
+                <a:latin typeface="Hiragino Sans GB"/>
+                <a:ea typeface="Hiragino Sans GB"/>
+                <a:cs typeface="Hiragino Sans GB"/>
+              </a:defRPr>
+            </a:pPr>
+            <a:r>
+              <a:rPr sz="1575" b="0">
+                <a:solidFill>
+                  <a:srgbClr val="9BB0C9"/>
+                </a:solidFill>
+                <a:latin typeface="Hiragino Sans GB"/>
+                <a:ea typeface="Hiragino Sans GB"/>
+                <a:cs typeface="Hiragino Sans GB"/>
+              </a:rPr>
+              <a:t>业务账本单列：8645 AC / 1440 MILP，8645 AC / 1440 MILP。模型调用 0。</a:t>
+            </a:r>
+          </a:p>
+        </p:txBody>
+      </p:sp>
+      <p:sp>
+        <p:nvSpPr>
+          <p:cNvPr id="8" name="">
+            <a:extLst xmlns:a="http://schemas.openxmlformats.org/drawingml/2006/main">
+              <a:ext uri="{FF2B5EF4-FFF2-40B4-BE49-F238E27FC236}">
+                <a16:creationId xmlns:a16="http://schemas.microsoft.com/office/drawing/2014/main" id="{8D2BCEB8-24E7-4A65-86C2-02A59481EF4B}"/>
+              </a:ext>
+            </a:extLst>
+          </p:cNvPr>
+          <p:cNvSpPr>
+            <a:spLocks xmlns:a="http://schemas.openxmlformats.org/drawingml/2006/main" noGrp="1"/>
+          </p:cNvSpPr>
+          <p:nvPr/>
+        </p:nvSpPr>
+        <p:spPr>
+          <a:xfrm xmlns:a="http://schemas.openxmlformats.org/drawingml/2006/main">
+            <a:off x="619125" y="6467475"/>
+            <a:ext cx="10096500" cy="190500"/>
+          </a:xfrm>
+          <a:prstGeom xmlns:a="http://schemas.openxmlformats.org/drawingml/2006/main" prst="rect">
+            <a:avLst/>
+          </a:prstGeom>
+          <a:noFill xmlns:a="http://schemas.openxmlformats.org/drawingml/2006/main"/>
+          <a:ln xmlns:a="http://schemas.openxmlformats.org/drawingml/2006/main" w="0">
+            <a:noFill/>
+          </a:ln>
+        </p:spPr>
+        <p:txBody>
+          <a:bodyPr xmlns:a="http://schemas.openxmlformats.org/drawingml/2006/main" wrap="square" lIns="19050" tIns="19050" rIns="19050" bIns="19050" anchor="ctr">
+            <a:normAutofit fontScale="100000"/>
+          </a:bodyPr>
+          <a:lstStyle xmlns:a="http://schemas.openxmlformats.org/drawingml/2006/main"/>
+          <a:p xmlns:a="http://schemas.openxmlformats.org/drawingml/2006/main">
+            <a:pPr algn="l">
+              <a:defRPr sz="975" b="0">
+                <a:solidFill>
+                  <a:srgbClr val="9BB0C9"/>
+                </a:solidFill>
+                <a:latin typeface="Hiragino Sans GB"/>
+                <a:ea typeface="Hiragino Sans GB"/>
+                <a:cs typeface="Hiragino Sans GB"/>
+              </a:defRPr>
+            </a:pPr>
+            <a:r>
+              <a:rPr sz="975" b="0">
+                <a:solidFill>
+                  <a:srgbClr val="9BB0C9"/>
+                </a:solidFill>
+                <a:latin typeface="Hiragino Sans GB"/>
+                <a:ea typeface="Hiragino Sans GB"/>
+                <a:cs typeface="Hiragino Sans GB"/>
+              </a:rPr>
+              <a:t>2026年6月仿真 · v3.2 · 公开基准验证</a:t>
+            </a:r>
+          </a:p>
+        </p:txBody>
+      </p:sp>
+      <p:sp>
+        <p:nvSpPr>
+          <p:cNvPr id="9" name="">
+            <a:extLst xmlns:a="http://schemas.openxmlformats.org/drawingml/2006/main">
+              <a:ext uri="{FF2B5EF4-FFF2-40B4-BE49-F238E27FC236}">
+                <a16:creationId xmlns:a16="http://schemas.microsoft.com/office/drawing/2014/main" id="{B851D7B0-5016-402E-822A-2352A9E00ED3}"/>
+              </a:ext>
+            </a:extLst>
+          </p:cNvPr>
+          <p:cNvSpPr>
+            <a:spLocks xmlns:a="http://schemas.openxmlformats.org/drawingml/2006/main" noGrp="1"/>
+          </p:cNvSpPr>
+          <p:nvPr/>
+        </p:nvSpPr>
+        <p:spPr>
+          <a:xfrm xmlns:a="http://schemas.openxmlformats.org/drawingml/2006/main">
+            <a:off x="11096625" y="6429375"/>
+            <a:ext cx="476250" cy="238125"/>
+          </a:xfrm>
+          <a:prstGeom xmlns:a="http://schemas.openxmlformats.org/drawingml/2006/main" prst="rect">
+            <a:avLst/>
+          </a:prstGeom>
+          <a:noFill xmlns:a="http://schemas.openxmlformats.org/drawingml/2006/main"/>
+          <a:ln xmlns:a="http://schemas.openxmlformats.org/drawingml/2006/main" w="0">
+            <a:noFill/>
+          </a:ln>
+        </p:spPr>
+        <p:txBody>
+          <a:bodyPr xmlns:a="http://schemas.openxmlformats.org/drawingml/2006/main" wrap="square" lIns="19050" tIns="19050" rIns="19050" bIns="19050" anchor="ctr">
+            <a:normAutofit fontScale="100000"/>
+          </a:bodyPr>
+          <a:lstStyle xmlns:a="http://schemas.openxmlformats.org/drawingml/2006/main"/>
+          <a:p xmlns:a="http://schemas.openxmlformats.org/drawingml/2006/main">
+            <a:pPr algn="r">
+              <a:defRPr sz="1125" b="0">
+                <a:solidFill>
+                  <a:srgbClr val="9BB0C9"/>
+                </a:solidFill>
+                <a:latin typeface="Hiragino Sans GB"/>
+                <a:ea typeface="Hiragino Sans GB"/>
+                <a:cs typeface="Hiragino Sans GB"/>
+              </a:defRPr>
+            </a:pPr>
+            <a:r>
+              <a:rPr sz="1125" b="0">
+                <a:solidFill>
+                  <a:srgbClr val="9BB0C9"/>
+                </a:solidFill>
+                <a:latin typeface="Hiragino Sans GB"/>
+                <a:ea typeface="Hiragino Sans GB"/>
+                <a:cs typeface="Hiragino Sans GB"/>
+              </a:rPr>
+              <a:t>11</a:t>
+            </a:r>
+          </a:p>
+        </p:txBody>
+      </p:sp>
+    </p:spTree>
+    <p:extLst>
+      <p:ext uri="{BB962C8B-B14F-4D97-AF65-F5344CB8AC3E}">
+        <p14:creationId xmlns:p14="http://schemas.microsoft.com/office/powerpoint/2010/main" val="1851836663"/>
+      </p:ext>
+    </p:extLst>
+  </p:cSld>
+</p:sld>
+</file>
+
+<file path=ppt/slides/slide12.xml><?xml version="1.0" encoding="utf-8"?>
+<p:sld xmlns:p="http://schemas.openxmlformats.org/presentationml/2006/main">
+  <p:cSld>
+    <p:bg>
+      <p:bgPr>
+        <a:solidFill xmlns:a="http://schemas.openxmlformats.org/drawingml/2006/main">
+          <a:srgbClr val="0D192A"/>
+        </a:solidFill>
+      </p:bgPr>
+    </p:bg>
+    <p:spTree>
+      <p:nvGrpSpPr>
+        <p:cNvPr id="1" name=""/>
+        <p:cNvGrpSpPr/>
+        <p:nvPr/>
+      </p:nvGrpSpPr>
+      <p:grpSpPr>
+        <a:xfrm xmlns:a="http://schemas.openxmlformats.org/drawingml/2006/main"/>
+      </p:grpSpPr>
+      <p:sp>
+        <p:nvSpPr>
+          <p:cNvPr id="8" name="">
+            <a:extLst xmlns:a="http://schemas.openxmlformats.org/drawingml/2006/main">
+              <a:ext uri="{FF2B5EF4-FFF2-40B4-BE49-F238E27FC236}">
+                <a16:creationId xmlns:a16="http://schemas.microsoft.com/office/drawing/2014/main" id="{C6AEA2AD-BC4F-4825-8DD7-7CE7E4562BAC}"/>
+              </a:ext>
+            </a:extLst>
+          </p:cNvPr>
+          <p:cNvSpPr>
+            <a:spLocks xmlns:a="http://schemas.openxmlformats.org/drawingml/2006/main" noGrp="1"/>
+          </p:cNvSpPr>
+          <p:nvPr/>
+        </p:nvSpPr>
+        <p:spPr>
+          <a:xfrm xmlns:a="http://schemas.openxmlformats.org/drawingml/2006/main">
+            <a:off x="619125" y="295275"/>
+            <a:ext cx="10477500" cy="228600"/>
+          </a:xfrm>
+          <a:prstGeom xmlns:a="http://schemas.openxmlformats.org/drawingml/2006/main" prst="rect">
+            <a:avLst/>
+          </a:prstGeom>
+          <a:noFill xmlns:a="http://schemas.openxmlformats.org/drawingml/2006/main"/>
+          <a:ln xmlns:a="http://schemas.openxmlformats.org/drawingml/2006/main" w="0">
+            <a:noFill/>
+          </a:ln>
+        </p:spPr>
+        <p:txBody>
+          <a:bodyPr xmlns:a="http://schemas.openxmlformats.org/drawingml/2006/main" wrap="square" lIns="19050" tIns="19050" rIns="19050" bIns="19050" anchor="ctr">
+            <a:normAutofit fontScale="100000"/>
+          </a:bodyPr>
+          <a:lstStyle xmlns:a="http://schemas.openxmlformats.org/drawingml/2006/main"/>
+          <a:p xmlns:a="http://schemas.openxmlformats.org/drawingml/2006/main">
+            <a:pPr algn="l">
+              <a:defRPr sz="1125" b="0">
+                <a:solidFill>
+                  <a:srgbClr val="75D5C5"/>
+                </a:solidFill>
+                <a:latin typeface="Hiragino Sans GB"/>
+                <a:ea typeface="Hiragino Sans GB"/>
+                <a:cs typeface="Hiragino Sans GB"/>
+              </a:defRPr>
+            </a:pPr>
+            <a:r>
+              <a:rPr sz="1125" b="0">
+                <a:solidFill>
+                  <a:srgbClr val="75D5C5"/>
+                </a:solidFill>
+                <a:latin typeface="Hiragino Sans GB"/>
+                <a:ea typeface="Hiragino Sans GB"/>
+                <a:cs typeface="Hiragino Sans GB"/>
+              </a:rPr>
+              <a:t>交付</a:t>
+            </a:r>
+          </a:p>
+        </p:txBody>
+      </p:sp>
+      <p:sp>
+        <p:nvSpPr>
+          <p:cNvPr id="2" name="">
+            <a:extLst xmlns:a="http://schemas.openxmlformats.org/drawingml/2006/main">
+              <a:ext uri="{FF2B5EF4-FFF2-40B4-BE49-F238E27FC236}">
+                <a16:creationId xmlns:a16="http://schemas.microsoft.com/office/drawing/2014/main" id="{5893BD06-D118-4185-AECA-EEF33CD4167A}"/>
+              </a:ext>
+            </a:extLst>
+          </p:cNvPr>
+          <p:cNvSpPr>
+            <a:spLocks xmlns:a="http://schemas.openxmlformats.org/drawingml/2006/main" noGrp="1"/>
+          </p:cNvSpPr>
+          <p:nvPr/>
+        </p:nvSpPr>
+        <p:spPr>
+          <a:xfrm xmlns:a="http://schemas.openxmlformats.org/drawingml/2006/main">
+            <a:off x="619125" y="685800"/>
+            <a:ext cx="10906125" cy="666750"/>
+          </a:xfrm>
+          <a:prstGeom xmlns:a="http://schemas.openxmlformats.org/drawingml/2006/main" prst="rect">
+            <a:avLst/>
+          </a:prstGeom>
+          <a:noFill xmlns:a="http://schemas.openxmlformats.org/drawingml/2006/main"/>
+          <a:ln xmlns:a="http://schemas.openxmlformats.org/drawingml/2006/main" w="0">
+            <a:noFill/>
+          </a:ln>
+        </p:spPr>
+        <p:txBody>
+          <a:bodyPr xmlns:a="http://schemas.openxmlformats.org/drawingml/2006/main" wrap="square" lIns="19050" tIns="19050" rIns="19050" bIns="19050" anchor="ctr">
+            <a:normAutofit fontScale="100000"/>
+          </a:bodyPr>
+          <a:lstStyle xmlns:a="http://schemas.openxmlformats.org/drawingml/2006/main"/>
+          <a:p xmlns:a="http://schemas.openxmlformats.org/drawingml/2006/main">
+            <a:pPr algn="l">
+              <a:defRPr sz="3150" b="1">
+                <a:solidFill>
+                  <a:srgbClr val="E5EDF7"/>
+                </a:solidFill>
+                <a:latin typeface="Hiragino Sans GB"/>
+                <a:ea typeface="Hiragino Sans GB"/>
+                <a:cs typeface="Hiragino Sans GB"/>
+              </a:defRPr>
+            </a:pPr>
+            <a:r>
+              <a:rPr sz="3150" b="1">
+                <a:solidFill>
+                  <a:srgbClr val="E5EDF7"/>
+                </a:solidFill>
+                <a:latin typeface="Hiragino Sans GB"/>
+                <a:ea typeface="Hiragino Sans GB"/>
+                <a:cs typeface="Hiragino Sans GB"/>
+              </a:rPr>
+              <a:t>在线回放与本机复算</a:t>
+            </a:r>
+          </a:p>
+        </p:txBody>
+      </p:sp>
+      <p:sp>
+        <p:nvSpPr>
+          <p:cNvPr id="3" name="">
+            <a:extLst xmlns:a="http://schemas.openxmlformats.org/drawingml/2006/main">
+              <a:ext uri="{FF2B5EF4-FFF2-40B4-BE49-F238E27FC236}">
+                <a16:creationId xmlns:a16="http://schemas.microsoft.com/office/drawing/2014/main" id="{933A3937-D44B-4254-84E5-03E8BBDE7C31}"/>
+              </a:ext>
+            </a:extLst>
+          </p:cNvPr>
+          <p:cNvSpPr>
+            <a:spLocks xmlns:a="http://schemas.openxmlformats.org/drawingml/2006/main" noGrp="1"/>
+          </p:cNvSpPr>
+          <p:nvPr/>
+        </p:nvSpPr>
+        <p:spPr>
+          <a:xfrm xmlns:a="http://schemas.openxmlformats.org/drawingml/2006/main">
+            <a:off x="619125" y="1419225"/>
+            <a:ext cx="10906125" cy="9525"/>
+          </a:xfrm>
+          <a:prstGeom xmlns:a="http://schemas.openxmlformats.org/drawingml/2006/main" prst="rect">
+            <a:avLst/>
+          </a:prstGeom>
+          <a:solidFill xmlns:a="http://schemas.openxmlformats.org/drawingml/2006/main">
+            <a:srgbClr val="3A526D"/>
+          </a:solidFill>
+          <a:ln xmlns:a="http://schemas.openxmlformats.org/drawingml/2006/main" w="0">
+            <a:noFill/>
+          </a:ln>
+        </p:spPr>
+      </p:sp>
       <p:pic>
         <p:nvPicPr>
           <p:cNvPr id="11" name=""/>
@@ -2613,7 +4709,7 @@
           <p:nvPr/>
         </p:nvPicPr>
         <p:blipFill>
-          <a:blip xmlns:r="http://schemas.openxmlformats.org/officeDocument/2006/relationships" xmlns:a="http://schemas.openxmlformats.org/drawingml/2006/main" r:embed="R1a6c540e70364577"/>
+          <a:blip xmlns:r="http://schemas.openxmlformats.org/officeDocument/2006/relationships" xmlns:a="http://schemas.openxmlformats.org/drawingml/2006/main" r:embed="R400d428c51664935"/>
           <a:stretch xmlns:a="http://schemas.openxmlformats.org/drawingml/2006/main"/>
         </p:blipFill>
         <p:spPr>
@@ -2631,7 +4727,7 @@
           <p:cNvPr id="5" name="">
             <a:extLst xmlns:a="http://schemas.openxmlformats.org/drawingml/2006/main">
               <a:ext uri="{FF2B5EF4-FFF2-40B4-BE49-F238E27FC236}">
-                <a16:creationId xmlns:a16="http://schemas.microsoft.com/office/drawing/2014/main" id="{A4E97DC5-1E73-404E-9614-9CB5ACEB4A36}"/>
+                <a16:creationId xmlns:a16="http://schemas.microsoft.com/office/drawing/2014/main" id="{CB4632C2-4B75-421A-B48E-95059E97265D}"/>
               </a:ext>
             </a:extLst>
           </p:cNvPr>
@@ -2678,7 +4774,7 @@
                 <a:ea typeface="Hiragino Sans GB"/>
                 <a:cs typeface="Hiragino Sans GB"/>
               </a:rPr>
-              <a:t>在线：六月日期、三方案、费用分解与改进记录；本机：完整数据与重算</a:t>
+              <a:t>在线：六月日常和持续偏移、异常证据、实际工具比较；本机：数据与重算</a:t>
             </a:r>
           </a:p>
         </p:txBody>
@@ -2688,7 +4784,7 @@
           <p:cNvPr id="6" name="">
             <a:extLst xmlns:a="http://schemas.openxmlformats.org/drawingml/2006/main">
               <a:ext uri="{FF2B5EF4-FFF2-40B4-BE49-F238E27FC236}">
-                <a16:creationId xmlns:a16="http://schemas.microsoft.com/office/drawing/2014/main" id="{2D700125-ECB7-466F-92DD-8B5BE6B67769}"/>
+                <a16:creationId xmlns:a16="http://schemas.microsoft.com/office/drawing/2014/main" id="{4658A10E-A43B-4C68-87F3-5406E29BB62E}"/>
               </a:ext>
             </a:extLst>
           </p:cNvPr>
@@ -2745,7 +4841,7 @@
           <p:cNvPr id="7" name="">
             <a:extLst xmlns:a="http://schemas.openxmlformats.org/drawingml/2006/main">
               <a:ext uri="{FF2B5EF4-FFF2-40B4-BE49-F238E27FC236}">
-                <a16:creationId xmlns:a16="http://schemas.microsoft.com/office/drawing/2014/main" id="{6A2DA870-3A74-481E-AF60-A38E9F35F875}"/>
+                <a16:creationId xmlns:a16="http://schemas.microsoft.com/office/drawing/2014/main" id="{08E7D02E-BDEA-45B4-8C4D-3A72375918CD}"/>
               </a:ext>
             </a:extLst>
           </p:cNvPr>
@@ -2792,7 +4888,7 @@
                 <a:ea typeface="Hiragino Sans GB"/>
                 <a:cs typeface="Hiragino Sans GB"/>
               </a:rPr>
-              <a:t>10</a:t>
+              <a:t>12</a:t>
             </a:r>
           </a:p>
         </p:txBody>
@@ -2800,7 +4896,7 @@
     </p:spTree>
     <p:extLst>
       <p:ext uri="{BB962C8B-B14F-4D97-AF65-F5344CB8AC3E}">
-        <p14:creationId xmlns:p14="http://schemas.microsoft.com/office/powerpoint/2010/main" val="63532293"/>
+        <p14:creationId xmlns:p14="http://schemas.microsoft.com/office/powerpoint/2010/main" val="1207312645"/>
       </p:ext>
     </p:extLst>
   </p:cSld>
@@ -2831,7 +4927,7 @@
           <p:cNvPr id="8" name="">
             <a:extLst xmlns:a="http://schemas.openxmlformats.org/drawingml/2006/main">
               <a:ext uri="{FF2B5EF4-FFF2-40B4-BE49-F238E27FC236}">
-                <a16:creationId xmlns:a16="http://schemas.microsoft.com/office/drawing/2014/main" id="{E24C8DE7-FF24-4836-91A3-E827F0D2067C}"/>
+                <a16:creationId xmlns:a16="http://schemas.microsoft.com/office/drawing/2014/main" id="{1AEC10BC-B9B3-46E9-A3C1-E0A42C5B5B5F}"/>
               </a:ext>
             </a:extLst>
           </p:cNvPr>
@@ -2888,7 +4984,7 @@
           <p:cNvPr id="2" name="">
             <a:extLst xmlns:a="http://schemas.openxmlformats.org/drawingml/2006/main">
               <a:ext uri="{FF2B5EF4-FFF2-40B4-BE49-F238E27FC236}">
-                <a16:creationId xmlns:a16="http://schemas.microsoft.com/office/drawing/2014/main" id="{FF2E91F5-B43E-40B1-B637-40228B94A389}"/>
+                <a16:creationId xmlns:a16="http://schemas.microsoft.com/office/drawing/2014/main" id="{3AC72CA2-E0E5-4CF7-98E6-F8FE2E7B263F}"/>
               </a:ext>
             </a:extLst>
           </p:cNvPr>
@@ -2945,7 +5041,7 @@
           <p:cNvPr id="3" name="">
             <a:extLst xmlns:a="http://schemas.openxmlformats.org/drawingml/2006/main">
               <a:ext uri="{FF2B5EF4-FFF2-40B4-BE49-F238E27FC236}">
-                <a16:creationId xmlns:a16="http://schemas.microsoft.com/office/drawing/2014/main" id="{83314C91-2D7E-498C-BEB5-56B0C98DDC51}"/>
+                <a16:creationId xmlns:a16="http://schemas.microsoft.com/office/drawing/2014/main" id="{B2C9E131-C929-4F3F-8E61-F15FCC505F48}"/>
               </a:ext>
             </a:extLst>
           </p:cNvPr>
@@ -2979,7 +5075,7 @@
           <p:nvPr/>
         </p:nvPicPr>
         <p:blipFill>
-          <a:blip xmlns:r="http://schemas.openxmlformats.org/officeDocument/2006/relationships" xmlns:a="http://schemas.openxmlformats.org/drawingml/2006/main" r:embed="R2081866906294fed"/>
+          <a:blip xmlns:r="http://schemas.openxmlformats.org/officeDocument/2006/relationships" xmlns:a="http://schemas.openxmlformats.org/drawingml/2006/main" r:embed="R83ccf00fa7264479"/>
           <a:stretch xmlns:a="http://schemas.openxmlformats.org/drawingml/2006/main"/>
         </p:blipFill>
         <p:spPr>
@@ -2997,7 +5093,7 @@
           <p:cNvPr id="5" name="">
             <a:extLst xmlns:a="http://schemas.openxmlformats.org/drawingml/2006/main">
               <a:ext uri="{FF2B5EF4-FFF2-40B4-BE49-F238E27FC236}">
-                <a16:creationId xmlns:a16="http://schemas.microsoft.com/office/drawing/2014/main" id="{2172051E-E332-403B-98C6-E6570C3A853E}"/>
+                <a16:creationId xmlns:a16="http://schemas.microsoft.com/office/drawing/2014/main" id="{7F1E78EB-9B15-42D9-B7FD-ADEDB7F0DB9E}"/>
               </a:ext>
             </a:extLst>
           </p:cNvPr>
@@ -3054,7 +5150,7 @@
           <p:cNvPr id="6" name="">
             <a:extLst xmlns:a="http://schemas.openxmlformats.org/drawingml/2006/main">
               <a:ext uri="{FF2B5EF4-FFF2-40B4-BE49-F238E27FC236}">
-                <a16:creationId xmlns:a16="http://schemas.microsoft.com/office/drawing/2014/main" id="{CFA15197-5FF9-44C6-A2DE-528BAC6061CB}"/>
+                <a16:creationId xmlns:a16="http://schemas.microsoft.com/office/drawing/2014/main" id="{E0DD71AB-522C-4FF8-B444-312C106383F2}"/>
               </a:ext>
             </a:extLst>
           </p:cNvPr>
@@ -3111,7 +5207,7 @@
           <p:cNvPr id="7" name="">
             <a:extLst xmlns:a="http://schemas.openxmlformats.org/drawingml/2006/main">
               <a:ext uri="{FF2B5EF4-FFF2-40B4-BE49-F238E27FC236}">
-                <a16:creationId xmlns:a16="http://schemas.microsoft.com/office/drawing/2014/main" id="{A0538160-CE8C-4C49-8ECD-ADF6D4E27FF4}"/>
+                <a16:creationId xmlns:a16="http://schemas.microsoft.com/office/drawing/2014/main" id="{285BDC33-B259-40C3-9E75-05317CDFCE8E}"/>
               </a:ext>
             </a:extLst>
           </p:cNvPr>
@@ -3166,7 +5262,7 @@
     </p:spTree>
     <p:extLst>
       <p:ext uri="{BB962C8B-B14F-4D97-AF65-F5344CB8AC3E}">
-        <p14:creationId xmlns:p14="http://schemas.microsoft.com/office/powerpoint/2010/main" val="1494143419"/>
+        <p14:creationId xmlns:p14="http://schemas.microsoft.com/office/powerpoint/2010/main" val="807226798"/>
       </p:ext>
     </p:extLst>
   </p:cSld>
@@ -3197,7 +5293,7 @@
           <p:cNvPr id="8" name="">
             <a:extLst xmlns:a="http://schemas.openxmlformats.org/drawingml/2006/main">
               <a:ext uri="{FF2B5EF4-FFF2-40B4-BE49-F238E27FC236}">
-                <a16:creationId xmlns:a16="http://schemas.microsoft.com/office/drawing/2014/main" id="{08B01845-76EF-47BD-8526-5F4A1CE77715}"/>
+                <a16:creationId xmlns:a16="http://schemas.microsoft.com/office/drawing/2014/main" id="{299F57B5-474E-4449-9975-48D31B510637}"/>
               </a:ext>
             </a:extLst>
           </p:cNvPr>
@@ -3254,7 +5350,7 @@
           <p:cNvPr id="2" name="">
             <a:extLst xmlns:a="http://schemas.openxmlformats.org/drawingml/2006/main">
               <a:ext uri="{FF2B5EF4-FFF2-40B4-BE49-F238E27FC236}">
-                <a16:creationId xmlns:a16="http://schemas.microsoft.com/office/drawing/2014/main" id="{3DEC15E0-B232-4617-A946-45002B21B0E7}"/>
+                <a16:creationId xmlns:a16="http://schemas.microsoft.com/office/drawing/2014/main" id="{62DA2D23-AFA3-470B-894F-8B3DC4924DEA}"/>
               </a:ext>
             </a:extLst>
           </p:cNvPr>
@@ -3311,7 +5407,7 @@
           <p:cNvPr id="3" name="">
             <a:extLst xmlns:a="http://schemas.openxmlformats.org/drawingml/2006/main">
               <a:ext uri="{FF2B5EF4-FFF2-40B4-BE49-F238E27FC236}">
-                <a16:creationId xmlns:a16="http://schemas.microsoft.com/office/drawing/2014/main" id="{827853FE-F4CD-44BA-9BD1-3BCB1EE7CC8F}"/>
+                <a16:creationId xmlns:a16="http://schemas.microsoft.com/office/drawing/2014/main" id="{569068A1-1E43-498A-B7DF-1A9B224FE358}"/>
               </a:ext>
             </a:extLst>
           </p:cNvPr>
@@ -3741,7 +5837,7 @@
           <p:cNvPr id="5" name="">
             <a:extLst xmlns:a="http://schemas.openxmlformats.org/drawingml/2006/main">
               <a:ext uri="{FF2B5EF4-FFF2-40B4-BE49-F238E27FC236}">
-                <a16:creationId xmlns:a16="http://schemas.microsoft.com/office/drawing/2014/main" id="{9D4F397D-CA35-4759-A90D-3E7F4113C838}"/>
+                <a16:creationId xmlns:a16="http://schemas.microsoft.com/office/drawing/2014/main" id="{F254906E-5E75-424B-8882-8B14647A601E}"/>
               </a:ext>
             </a:extLst>
           </p:cNvPr>
@@ -3788,7 +5884,7 @@
                 <a:ea typeface="Hiragino Sans GB"/>
                 <a:cs typeface="Hiragino Sans GB"/>
               </a:rPr>
-              <a:t>在线版只回放完整六月结果；本机版负责其他月份与重算</a:t>
+              <a:t>在线版提供六月日常与持续偏移回放，本机版负责参数与导入</a:t>
             </a:r>
           </a:p>
         </p:txBody>
@@ -3798,7 +5894,7 @@
           <p:cNvPr id="6" name="">
             <a:extLst xmlns:a="http://schemas.openxmlformats.org/drawingml/2006/main">
               <a:ext uri="{FF2B5EF4-FFF2-40B4-BE49-F238E27FC236}">
-                <a16:creationId xmlns:a16="http://schemas.microsoft.com/office/drawing/2014/main" id="{C9B49941-EAE1-45D4-ADB5-FD1C3E2A3B3A}"/>
+                <a16:creationId xmlns:a16="http://schemas.microsoft.com/office/drawing/2014/main" id="{A4314B74-F5AC-40C4-B184-54141953DA74}"/>
               </a:ext>
             </a:extLst>
           </p:cNvPr>
@@ -3855,7 +5951,7 @@
           <p:cNvPr id="7" name="">
             <a:extLst xmlns:a="http://schemas.openxmlformats.org/drawingml/2006/main">
               <a:ext uri="{FF2B5EF4-FFF2-40B4-BE49-F238E27FC236}">
-                <a16:creationId xmlns:a16="http://schemas.microsoft.com/office/drawing/2014/main" id="{53E2EAAB-7FF0-4478-9D64-29AF8CCF3193}"/>
+                <a16:creationId xmlns:a16="http://schemas.microsoft.com/office/drawing/2014/main" id="{8A65B8FA-5AE0-4820-8826-F5E2033F7D01}"/>
               </a:ext>
             </a:extLst>
           </p:cNvPr>
@@ -3910,7 +6006,7 @@
     </p:spTree>
     <p:extLst>
       <p:ext uri="{BB962C8B-B14F-4D97-AF65-F5344CB8AC3E}">
-        <p14:creationId xmlns:p14="http://schemas.microsoft.com/office/powerpoint/2010/main" val="965790780"/>
+        <p14:creationId xmlns:p14="http://schemas.microsoft.com/office/powerpoint/2010/main" val="371254609"/>
       </p:ext>
     </p:extLst>
   </p:cSld>
@@ -3941,7 +6037,7 @@
           <p:cNvPr id="10" name="">
             <a:extLst xmlns:a="http://schemas.openxmlformats.org/drawingml/2006/main">
               <a:ext uri="{FF2B5EF4-FFF2-40B4-BE49-F238E27FC236}">
-                <a16:creationId xmlns:a16="http://schemas.microsoft.com/office/drawing/2014/main" id="{D799F32D-20C3-4583-AB3F-6C355E623DC4}"/>
+                <a16:creationId xmlns:a16="http://schemas.microsoft.com/office/drawing/2014/main" id="{8F280B3A-1793-4C78-B87A-DAECE5338644}"/>
               </a:ext>
             </a:extLst>
           </p:cNvPr>
@@ -3998,7 +6094,7 @@
           <p:cNvPr id="2" name="">
             <a:extLst xmlns:a="http://schemas.openxmlformats.org/drawingml/2006/main">
               <a:ext uri="{FF2B5EF4-FFF2-40B4-BE49-F238E27FC236}">
-                <a16:creationId xmlns:a16="http://schemas.microsoft.com/office/drawing/2014/main" id="{341C2809-78DB-48A0-AC5D-1C1C07DD8D5C}"/>
+                <a16:creationId xmlns:a16="http://schemas.microsoft.com/office/drawing/2014/main" id="{3CBB7515-BFAF-4B78-BEBD-34904F22B78F}"/>
               </a:ext>
             </a:extLst>
           </p:cNvPr>
@@ -4055,7 +6151,7 @@
           <p:cNvPr id="3" name="">
             <a:extLst xmlns:a="http://schemas.openxmlformats.org/drawingml/2006/main">
               <a:ext uri="{FF2B5EF4-FFF2-40B4-BE49-F238E27FC236}">
-                <a16:creationId xmlns:a16="http://schemas.microsoft.com/office/drawing/2014/main" id="{C534F623-B3BE-4098-8634-CD44AE4CD0FC}"/>
+                <a16:creationId xmlns:a16="http://schemas.microsoft.com/office/drawing/2014/main" id="{6E4D9BF5-FB15-4278-AD9B-5394240B8D9B}"/>
               </a:ext>
             </a:extLst>
           </p:cNvPr>
@@ -4638,7 +6734,7 @@
           <p:cNvPr id="5" name="">
             <a:extLst xmlns:a="http://schemas.openxmlformats.org/drawingml/2006/main">
               <a:ext uri="{FF2B5EF4-FFF2-40B4-BE49-F238E27FC236}">
-                <a16:creationId xmlns:a16="http://schemas.microsoft.com/office/drawing/2014/main" id="{37162E2E-CDAB-4F09-B406-6C275B85BEC3}"/>
+                <a16:creationId xmlns:a16="http://schemas.microsoft.com/office/drawing/2014/main" id="{72B7373D-6601-4D64-88B3-ED537AA1A10A}"/>
               </a:ext>
             </a:extLst>
           </p:cNvPr>
@@ -4695,7 +6791,7 @@
           <p:cNvPr id="6" name="">
             <a:extLst xmlns:a="http://schemas.openxmlformats.org/drawingml/2006/main">
               <a:ext uri="{FF2B5EF4-FFF2-40B4-BE49-F238E27FC236}">
-                <a16:creationId xmlns:a16="http://schemas.microsoft.com/office/drawing/2014/main" id="{0D10B86B-4BDC-4723-B10F-63FFE6BDAC1C}"/>
+                <a16:creationId xmlns:a16="http://schemas.microsoft.com/office/drawing/2014/main" id="{23FA7DB8-95E8-4E42-AF89-9BDD390FF158}"/>
               </a:ext>
             </a:extLst>
           </p:cNvPr>
@@ -4775,7 +6871,7 @@
           <p:cNvPr id="7" name="">
             <a:extLst xmlns:a="http://schemas.openxmlformats.org/drawingml/2006/main">
               <a:ext uri="{FF2B5EF4-FFF2-40B4-BE49-F238E27FC236}">
-                <a16:creationId xmlns:a16="http://schemas.microsoft.com/office/drawing/2014/main" id="{56E11176-2613-4BCA-9178-C9D5D18D2E9B}"/>
+                <a16:creationId xmlns:a16="http://schemas.microsoft.com/office/drawing/2014/main" id="{E1855766-D7DA-4799-93D2-7B3D1D00F352}"/>
               </a:ext>
             </a:extLst>
           </p:cNvPr>
@@ -4832,7 +6928,7 @@
           <p:cNvPr id="8" name="">
             <a:extLst xmlns:a="http://schemas.openxmlformats.org/drawingml/2006/main">
               <a:ext uri="{FF2B5EF4-FFF2-40B4-BE49-F238E27FC236}">
-                <a16:creationId xmlns:a16="http://schemas.microsoft.com/office/drawing/2014/main" id="{595D7ECF-A001-473B-8CC3-8BDC7C7C81C8}"/>
+                <a16:creationId xmlns:a16="http://schemas.microsoft.com/office/drawing/2014/main" id="{99C963F7-8FCA-4A4D-A6D6-065A9A6E40CF}"/>
               </a:ext>
             </a:extLst>
           </p:cNvPr>
@@ -4889,7 +6985,7 @@
           <p:cNvPr id="9" name="">
             <a:extLst xmlns:a="http://schemas.openxmlformats.org/drawingml/2006/main">
               <a:ext uri="{FF2B5EF4-FFF2-40B4-BE49-F238E27FC236}">
-                <a16:creationId xmlns:a16="http://schemas.microsoft.com/office/drawing/2014/main" id="{8FFB46E6-0F69-4201-AC01-5FFDCE4150DF}"/>
+                <a16:creationId xmlns:a16="http://schemas.microsoft.com/office/drawing/2014/main" id="{31938614-A9BF-4EA6-95BC-5C534C849265}"/>
               </a:ext>
             </a:extLst>
           </p:cNvPr>
@@ -4944,7 +7040,7 @@
     </p:spTree>
     <p:extLst>
       <p:ext uri="{BB962C8B-B14F-4D97-AF65-F5344CB8AC3E}">
-        <p14:creationId xmlns:p14="http://schemas.microsoft.com/office/powerpoint/2010/main" val="409985265"/>
+        <p14:creationId xmlns:p14="http://schemas.microsoft.com/office/powerpoint/2010/main" val="494977399"/>
       </p:ext>
     </p:extLst>
   </p:cSld>
@@ -4975,7 +7071,7 @@
           <p:cNvPr id="9" name="">
             <a:extLst xmlns:a="http://schemas.openxmlformats.org/drawingml/2006/main">
               <a:ext uri="{FF2B5EF4-FFF2-40B4-BE49-F238E27FC236}">
-                <a16:creationId xmlns:a16="http://schemas.microsoft.com/office/drawing/2014/main" id="{AC1377F3-CFE7-4F7F-B66D-55553C193665}"/>
+                <a16:creationId xmlns:a16="http://schemas.microsoft.com/office/drawing/2014/main" id="{550E7529-CB14-4BCF-8B6F-6365E6007C99}"/>
               </a:ext>
             </a:extLst>
           </p:cNvPr>
@@ -5032,7 +7128,7 @@
           <p:cNvPr id="2" name="">
             <a:extLst xmlns:a="http://schemas.openxmlformats.org/drawingml/2006/main">
               <a:ext uri="{FF2B5EF4-FFF2-40B4-BE49-F238E27FC236}">
-                <a16:creationId xmlns:a16="http://schemas.microsoft.com/office/drawing/2014/main" id="{AE2E2720-48EF-424E-BCF6-16EFD51E44B8}"/>
+                <a16:creationId xmlns:a16="http://schemas.microsoft.com/office/drawing/2014/main" id="{E2D40EBF-7A23-48DC-B96A-DCA01C2E2B7B}"/>
               </a:ext>
             </a:extLst>
           </p:cNvPr>
@@ -5089,7 +7185,7 @@
           <p:cNvPr id="3" name="">
             <a:extLst xmlns:a="http://schemas.openxmlformats.org/drawingml/2006/main">
               <a:ext uri="{FF2B5EF4-FFF2-40B4-BE49-F238E27FC236}">
-                <a16:creationId xmlns:a16="http://schemas.microsoft.com/office/drawing/2014/main" id="{A87F2FEF-CF69-4E09-BCBF-51E80A61C85F}"/>
+                <a16:creationId xmlns:a16="http://schemas.microsoft.com/office/drawing/2014/main" id="{E436BA03-E8EE-4803-9187-8E3606194CD9}"/>
               </a:ext>
             </a:extLst>
           </p:cNvPr>
@@ -5567,7 +7663,7 @@
           <p:cNvPr id="5" name="">
             <a:extLst xmlns:a="http://schemas.openxmlformats.org/drawingml/2006/main">
               <a:ext uri="{FF2B5EF4-FFF2-40B4-BE49-F238E27FC236}">
-                <a16:creationId xmlns:a16="http://schemas.microsoft.com/office/drawing/2014/main" id="{CE2F5C3D-E7C2-4A0B-ADB6-05C149CBC3CD}"/>
+                <a16:creationId xmlns:a16="http://schemas.microsoft.com/office/drawing/2014/main" id="{518AC956-06C3-4316-B14A-8D9C41E6FBBE}"/>
               </a:ext>
             </a:extLst>
           </p:cNvPr>
@@ -5624,7 +7720,7 @@
           <p:cNvPr id="6" name="">
             <a:extLst xmlns:a="http://schemas.openxmlformats.org/drawingml/2006/main">
               <a:ext uri="{FF2B5EF4-FFF2-40B4-BE49-F238E27FC236}">
-                <a16:creationId xmlns:a16="http://schemas.microsoft.com/office/drawing/2014/main" id="{26F5BEC3-396D-4465-B1BB-F2308EF465AB}"/>
+                <a16:creationId xmlns:a16="http://schemas.microsoft.com/office/drawing/2014/main" id="{B3116E41-289D-40C5-B1BB-63C6315CB857}"/>
               </a:ext>
             </a:extLst>
           </p:cNvPr>
@@ -5704,7 +7800,7 @@
           <p:cNvPr id="7" name="">
             <a:extLst xmlns:a="http://schemas.openxmlformats.org/drawingml/2006/main">
               <a:ext uri="{FF2B5EF4-FFF2-40B4-BE49-F238E27FC236}">
-                <a16:creationId xmlns:a16="http://schemas.microsoft.com/office/drawing/2014/main" id="{D245423A-CC07-41ED-9DE8-9737A7F7CB5E}"/>
+                <a16:creationId xmlns:a16="http://schemas.microsoft.com/office/drawing/2014/main" id="{9721B48F-DEA7-4550-AE54-BF798C12A648}"/>
               </a:ext>
             </a:extLst>
           </p:cNvPr>
@@ -5761,7 +7857,7 @@
           <p:cNvPr id="8" name="">
             <a:extLst xmlns:a="http://schemas.openxmlformats.org/drawingml/2006/main">
               <a:ext uri="{FF2B5EF4-FFF2-40B4-BE49-F238E27FC236}">
-                <a16:creationId xmlns:a16="http://schemas.microsoft.com/office/drawing/2014/main" id="{BDF2A45F-1898-4099-BE4A-01051806A736}"/>
+                <a16:creationId xmlns:a16="http://schemas.microsoft.com/office/drawing/2014/main" id="{3821D4F0-06C0-451F-A7DC-0E3F01527DEF}"/>
               </a:ext>
             </a:extLst>
           </p:cNvPr>
@@ -5816,7 +7912,7 @@
     </p:spTree>
     <p:extLst>
       <p:ext uri="{BB962C8B-B14F-4D97-AF65-F5344CB8AC3E}">
-        <p14:creationId xmlns:p14="http://schemas.microsoft.com/office/powerpoint/2010/main" val="1352039394"/>
+        <p14:creationId xmlns:p14="http://schemas.microsoft.com/office/powerpoint/2010/main" val="1358217142"/>
       </p:ext>
     </p:extLst>
   </p:cSld>
@@ -5847,7 +7943,7 @@
           <p:cNvPr id="9" name="">
             <a:extLst xmlns:a="http://schemas.openxmlformats.org/drawingml/2006/main">
               <a:ext uri="{FF2B5EF4-FFF2-40B4-BE49-F238E27FC236}">
-                <a16:creationId xmlns:a16="http://schemas.microsoft.com/office/drawing/2014/main" id="{8BE00A22-79E4-430A-A34A-FB544665FD8E}"/>
+                <a16:creationId xmlns:a16="http://schemas.microsoft.com/office/drawing/2014/main" id="{AC575964-83E7-45AB-B7C9-2F005CD11F05}"/>
               </a:ext>
             </a:extLst>
           </p:cNvPr>
@@ -5904,7 +8000,7 @@
           <p:cNvPr id="2" name="">
             <a:extLst xmlns:a="http://schemas.openxmlformats.org/drawingml/2006/main">
               <a:ext uri="{FF2B5EF4-FFF2-40B4-BE49-F238E27FC236}">
-                <a16:creationId xmlns:a16="http://schemas.microsoft.com/office/drawing/2014/main" id="{242085BA-42A6-4B90-BFE3-7FC7CE0A5865}"/>
+                <a16:creationId xmlns:a16="http://schemas.microsoft.com/office/drawing/2014/main" id="{0BA80D2F-60F4-4E8C-A26B-4E661E60C2F8}"/>
               </a:ext>
             </a:extLst>
           </p:cNvPr>
@@ -5961,7 +8057,7 @@
           <p:cNvPr id="3" name="">
             <a:extLst xmlns:a="http://schemas.openxmlformats.org/drawingml/2006/main">
               <a:ext uri="{FF2B5EF4-FFF2-40B4-BE49-F238E27FC236}">
-                <a16:creationId xmlns:a16="http://schemas.microsoft.com/office/drawing/2014/main" id="{BF306949-9E98-4E79-B9B3-2E6B43AEFC8A}"/>
+                <a16:creationId xmlns:a16="http://schemas.microsoft.com/office/drawing/2014/main" id="{F1554B03-1BC7-4BFD-B85C-B708F2552CE2}"/>
               </a:ext>
             </a:extLst>
           </p:cNvPr>
@@ -6154,7 +8250,7 @@
                           <a:ea typeface="Hiragino Sans GB"/>
                           <a:cs typeface="Hiragino Sans GB"/>
                         </a:rPr>
-                        <a:t>各方法共享信息；固定电价为已知合同</a:t>
+                        <a:t>共享预测信息，合同电价已知</a:t>
                       </a:r>
                     </a:p>
                   </a:txBody>
@@ -6314,7 +8410,7 @@
                           <a:ea typeface="Hiragino Sans GB"/>
                           <a:cs typeface="Hiragino Sans GB"/>
                         </a:rPr>
-                        <a:t>受限表达式执行；行为差异检查</a:t>
+                        <a:t>当前在基线后组织试验</a:t>
                       </a:r>
                     </a:p>
                   </a:txBody>
@@ -6394,7 +8490,7 @@
                           <a:ea typeface="Hiragino Sans GB"/>
                           <a:cs typeface="Hiragino Sans GB"/>
                         </a:rPr>
-                        <a:t>下一轮使用；需固定 G 组检验</a:t>
+                        <a:t>继承机制已实现，实际晋升 0</a:t>
                       </a:r>
                     </a:p>
                   </a:txBody>
@@ -6414,7 +8510,7 @@
           <p:cNvPr id="5" name="">
             <a:extLst xmlns:a="http://schemas.openxmlformats.org/drawingml/2006/main">
               <a:ext uri="{FF2B5EF4-FFF2-40B4-BE49-F238E27FC236}">
-                <a16:creationId xmlns:a16="http://schemas.microsoft.com/office/drawing/2014/main" id="{67FABEB7-9348-48EE-B348-BDAD4DB40607}"/>
+                <a16:creationId xmlns:a16="http://schemas.microsoft.com/office/drawing/2014/main" id="{3092F1F9-1DCC-44AB-BE3E-4558292B90FA}"/>
               </a:ext>
             </a:extLst>
           </p:cNvPr>
@@ -6471,7 +8567,7 @@
           <p:cNvPr id="6" name="">
             <a:extLst xmlns:a="http://schemas.openxmlformats.org/drawingml/2006/main">
               <a:ext uri="{FF2B5EF4-FFF2-40B4-BE49-F238E27FC236}">
-                <a16:creationId xmlns:a16="http://schemas.microsoft.com/office/drawing/2014/main" id="{34758C04-7868-45F7-9C64-13AEC9474CCA}"/>
+                <a16:creationId xmlns:a16="http://schemas.microsoft.com/office/drawing/2014/main" id="{DFD0ADA8-D4D1-40E0-ACA9-FA9017BB6F77}"/>
               </a:ext>
             </a:extLst>
           </p:cNvPr>
@@ -6528,7 +8624,7 @@
           <p:cNvPr id="7" name="">
             <a:extLst xmlns:a="http://schemas.openxmlformats.org/drawingml/2006/main">
               <a:ext uri="{FF2B5EF4-FFF2-40B4-BE49-F238E27FC236}">
-                <a16:creationId xmlns:a16="http://schemas.microsoft.com/office/drawing/2014/main" id="{1A16FC0B-3D93-404D-9E63-46736327AEDB}"/>
+                <a16:creationId xmlns:a16="http://schemas.microsoft.com/office/drawing/2014/main" id="{6AC5BB71-A564-48F3-BC41-57D0A2ED7D8B}"/>
               </a:ext>
             </a:extLst>
           </p:cNvPr>
@@ -6585,7 +8681,7 @@
           <p:cNvPr id="8" name="">
             <a:extLst xmlns:a="http://schemas.openxmlformats.org/drawingml/2006/main">
               <a:ext uri="{FF2B5EF4-FFF2-40B4-BE49-F238E27FC236}">
-                <a16:creationId xmlns:a16="http://schemas.microsoft.com/office/drawing/2014/main" id="{8DC801BF-0513-432E-8520-BBAE7D0797AB}"/>
+                <a16:creationId xmlns:a16="http://schemas.microsoft.com/office/drawing/2014/main" id="{6562D4CD-1DE8-4CE5-88E5-553B15B937B2}"/>
               </a:ext>
             </a:extLst>
           </p:cNvPr>
@@ -6640,7 +8736,7 @@
     </p:spTree>
     <p:extLst>
       <p:ext uri="{BB962C8B-B14F-4D97-AF65-F5344CB8AC3E}">
-        <p14:creationId xmlns:p14="http://schemas.microsoft.com/office/powerpoint/2010/main" val="1097204754"/>
+        <p14:creationId xmlns:p14="http://schemas.microsoft.com/office/powerpoint/2010/main" val="325685436"/>
       </p:ext>
     </p:extLst>
   </p:cSld>
@@ -6671,7 +8767,7 @@
           <p:cNvPr id="9" name="">
             <a:extLst xmlns:a="http://schemas.openxmlformats.org/drawingml/2006/main">
               <a:ext uri="{FF2B5EF4-FFF2-40B4-BE49-F238E27FC236}">
-                <a16:creationId xmlns:a16="http://schemas.microsoft.com/office/drawing/2014/main" id="{8325FF98-8831-435F-8B9A-1D952E1B4D28}"/>
+                <a16:creationId xmlns:a16="http://schemas.microsoft.com/office/drawing/2014/main" id="{805B6E8A-34BA-46F8-B20F-24A13FBC3383}"/>
               </a:ext>
             </a:extLst>
           </p:cNvPr>
@@ -6728,7 +8824,7 @@
           <p:cNvPr id="2" name="">
             <a:extLst xmlns:a="http://schemas.openxmlformats.org/drawingml/2006/main">
               <a:ext uri="{FF2B5EF4-FFF2-40B4-BE49-F238E27FC236}">
-                <a16:creationId xmlns:a16="http://schemas.microsoft.com/office/drawing/2014/main" id="{13D11989-B5AF-4872-BE23-4B029BCA236B}"/>
+                <a16:creationId xmlns:a16="http://schemas.microsoft.com/office/drawing/2014/main" id="{22552F6D-AC76-49D4-B45D-87D1EEE93061}"/>
               </a:ext>
             </a:extLst>
           </p:cNvPr>
@@ -6785,7 +8881,7 @@
           <p:cNvPr id="3" name="">
             <a:extLst xmlns:a="http://schemas.openxmlformats.org/drawingml/2006/main">
               <a:ext uri="{FF2B5EF4-FFF2-40B4-BE49-F238E27FC236}">
-                <a16:creationId xmlns:a16="http://schemas.microsoft.com/office/drawing/2014/main" id="{53EF598B-24F7-4B88-BAC9-83FB52863DB4}"/>
+                <a16:creationId xmlns:a16="http://schemas.microsoft.com/office/drawing/2014/main" id="{19EA6BB0-8F1F-4844-A206-384FA8D47169}"/>
               </a:ext>
             </a:extLst>
           </p:cNvPr>
@@ -7318,7 +9414,7 @@
           <p:cNvPr id="5" name="">
             <a:extLst xmlns:a="http://schemas.openxmlformats.org/drawingml/2006/main">
               <a:ext uri="{FF2B5EF4-FFF2-40B4-BE49-F238E27FC236}">
-                <a16:creationId xmlns:a16="http://schemas.microsoft.com/office/drawing/2014/main" id="{84D20E67-C233-4AB7-A11D-DA0D8C318799}"/>
+                <a16:creationId xmlns:a16="http://schemas.microsoft.com/office/drawing/2014/main" id="{59E954F1-CC4B-4ED1-BBF5-72986268B6CB}"/>
               </a:ext>
             </a:extLst>
           </p:cNvPr>
@@ -7375,7 +9471,7 @@
           <p:cNvPr id="6" name="">
             <a:extLst xmlns:a="http://schemas.openxmlformats.org/drawingml/2006/main">
               <a:ext uri="{FF2B5EF4-FFF2-40B4-BE49-F238E27FC236}">
-                <a16:creationId xmlns:a16="http://schemas.microsoft.com/office/drawing/2014/main" id="{1DB8D08E-9A60-40AA-852F-418F4FCF4F25}"/>
+                <a16:creationId xmlns:a16="http://schemas.microsoft.com/office/drawing/2014/main" id="{87D94B27-0248-4313-9181-0E3ED28331A9}"/>
               </a:ext>
             </a:extLst>
           </p:cNvPr>
@@ -7432,7 +9528,7 @@
           <p:cNvPr id="7" name="">
             <a:extLst xmlns:a="http://schemas.openxmlformats.org/drawingml/2006/main">
               <a:ext uri="{FF2B5EF4-FFF2-40B4-BE49-F238E27FC236}">
-                <a16:creationId xmlns:a16="http://schemas.microsoft.com/office/drawing/2014/main" id="{B29B1B20-1937-46B5-B9A5-9AC2F0D9E6D0}"/>
+                <a16:creationId xmlns:a16="http://schemas.microsoft.com/office/drawing/2014/main" id="{4A59E9C6-088B-4A65-B41D-0BCB3E2F967C}"/>
               </a:ext>
             </a:extLst>
           </p:cNvPr>
@@ -7489,7 +9585,7 @@
           <p:cNvPr id="8" name="">
             <a:extLst xmlns:a="http://schemas.openxmlformats.org/drawingml/2006/main">
               <a:ext uri="{FF2B5EF4-FFF2-40B4-BE49-F238E27FC236}">
-                <a16:creationId xmlns:a16="http://schemas.microsoft.com/office/drawing/2014/main" id="{F7FB5CD1-CA6D-4547-9931-3C96CD18046C}"/>
+                <a16:creationId xmlns:a16="http://schemas.microsoft.com/office/drawing/2014/main" id="{EEAF6FAD-67A3-42BA-A780-25F4AAF0AC73}"/>
               </a:ext>
             </a:extLst>
           </p:cNvPr>
@@ -7544,7 +9640,7 @@
     </p:spTree>
     <p:extLst>
       <p:ext uri="{BB962C8B-B14F-4D97-AF65-F5344CB8AC3E}">
-        <p14:creationId xmlns:p14="http://schemas.microsoft.com/office/powerpoint/2010/main" val="850980166"/>
+        <p14:creationId xmlns:p14="http://schemas.microsoft.com/office/powerpoint/2010/main" val="2076785263"/>
       </p:ext>
     </p:extLst>
   </p:cSld>
@@ -7575,7 +9671,7 @@
           <p:cNvPr id="11" name="">
             <a:extLst xmlns:a="http://schemas.openxmlformats.org/drawingml/2006/main">
               <a:ext uri="{FF2B5EF4-FFF2-40B4-BE49-F238E27FC236}">
-                <a16:creationId xmlns:a16="http://schemas.microsoft.com/office/drawing/2014/main" id="{35D1A29A-919D-4088-816E-BD70F044AA2A}"/>
+                <a16:creationId xmlns:a16="http://schemas.microsoft.com/office/drawing/2014/main" id="{78096733-C5D8-4103-8A5F-72B89F68D8D7}"/>
               </a:ext>
             </a:extLst>
           </p:cNvPr>
@@ -7632,7 +9728,7 @@
           <p:cNvPr id="2" name="">
             <a:extLst xmlns:a="http://schemas.openxmlformats.org/drawingml/2006/main">
               <a:ext uri="{FF2B5EF4-FFF2-40B4-BE49-F238E27FC236}">
-                <a16:creationId xmlns:a16="http://schemas.microsoft.com/office/drawing/2014/main" id="{8FEC2326-7025-4B75-8AFC-EACFCADDD640}"/>
+                <a16:creationId xmlns:a16="http://schemas.microsoft.com/office/drawing/2014/main" id="{782D4FED-BDC0-4DE1-BFAD-F7B16B539B3C}"/>
               </a:ext>
             </a:extLst>
           </p:cNvPr>
@@ -7689,7 +9785,7 @@
           <p:cNvPr id="3" name="">
             <a:extLst xmlns:a="http://schemas.openxmlformats.org/drawingml/2006/main">
               <a:ext uri="{FF2B5EF4-FFF2-40B4-BE49-F238E27FC236}">
-                <a16:creationId xmlns:a16="http://schemas.microsoft.com/office/drawing/2014/main" id="{3602E2F9-9DB7-4FDA-9FF3-1C95AA575C96}"/>
+                <a16:creationId xmlns:a16="http://schemas.microsoft.com/office/drawing/2014/main" id="{D833E09E-39CC-4DCB-96E0-E60375924500}"/>
               </a:ext>
             </a:extLst>
           </p:cNvPr>
@@ -7719,7 +9815,7 @@
           <p:cNvPr id="4" name="">
             <a:extLst xmlns:a="http://schemas.openxmlformats.org/drawingml/2006/main">
               <a:ext uri="{FF2B5EF4-FFF2-40B4-BE49-F238E27FC236}">
-                <a16:creationId xmlns:a16="http://schemas.microsoft.com/office/drawing/2014/main" id="{B29AD099-2733-4D3C-AC44-021ABFF87CE8}"/>
+                <a16:creationId xmlns:a16="http://schemas.microsoft.com/office/drawing/2014/main" id="{29671A24-3282-45CB-818A-1E0872772B6D}"/>
               </a:ext>
             </a:extLst>
           </p:cNvPr>
@@ -7776,7 +9872,7 @@
           <p:cNvPr id="5" name="">
             <a:extLst xmlns:a="http://schemas.openxmlformats.org/drawingml/2006/main">
               <a:ext uri="{FF2B5EF4-FFF2-40B4-BE49-F238E27FC236}">
-                <a16:creationId xmlns:a16="http://schemas.microsoft.com/office/drawing/2014/main" id="{AE8291EE-4405-4C8B-917E-F5076A996B6B}"/>
+                <a16:creationId xmlns:a16="http://schemas.microsoft.com/office/drawing/2014/main" id="{6329F7AF-AB1B-4D38-A990-08AAB58183D6}"/>
               </a:ext>
             </a:extLst>
           </p:cNvPr>
@@ -7833,7 +9929,7 @@
           <p:cNvPr id="6" name="">
             <a:extLst xmlns:a="http://schemas.openxmlformats.org/drawingml/2006/main">
               <a:ext uri="{FF2B5EF4-FFF2-40B4-BE49-F238E27FC236}">
-                <a16:creationId xmlns:a16="http://schemas.microsoft.com/office/drawing/2014/main" id="{ED9F6553-A0DE-4383-963B-906AB33BDD57}"/>
+                <a16:creationId xmlns:a16="http://schemas.microsoft.com/office/drawing/2014/main" id="{35D58C83-805B-4A86-980A-E82FFF1808C9}"/>
               </a:ext>
             </a:extLst>
           </p:cNvPr>
@@ -7863,7 +9959,7 @@
           <p:cNvPr id="7" name="">
             <a:extLst xmlns:a="http://schemas.openxmlformats.org/drawingml/2006/main">
               <a:ext uri="{FF2B5EF4-FFF2-40B4-BE49-F238E27FC236}">
-                <a16:creationId xmlns:a16="http://schemas.microsoft.com/office/drawing/2014/main" id="{4D8AE52C-B5B1-4708-B5B7-8BC33D026F5E}"/>
+                <a16:creationId xmlns:a16="http://schemas.microsoft.com/office/drawing/2014/main" id="{E666F0FA-5F1A-4602-9057-47D1BA4BE07A}"/>
               </a:ext>
             </a:extLst>
           </p:cNvPr>
@@ -7920,7 +10016,7 @@
           <p:cNvPr id="8" name="">
             <a:extLst xmlns:a="http://schemas.openxmlformats.org/drawingml/2006/main">
               <a:ext uri="{FF2B5EF4-FFF2-40B4-BE49-F238E27FC236}">
-                <a16:creationId xmlns:a16="http://schemas.microsoft.com/office/drawing/2014/main" id="{B1DED99A-9474-407F-9EA4-C4E03CAA8E61}"/>
+                <a16:creationId xmlns:a16="http://schemas.microsoft.com/office/drawing/2014/main" id="{8E5BC3AE-6021-46F0-A580-97187A7BA211}"/>
               </a:ext>
             </a:extLst>
           </p:cNvPr>
@@ -8000,7 +10096,7 @@
           <p:cNvPr id="9" name="">
             <a:extLst xmlns:a="http://schemas.openxmlformats.org/drawingml/2006/main">
               <a:ext uri="{FF2B5EF4-FFF2-40B4-BE49-F238E27FC236}">
-                <a16:creationId xmlns:a16="http://schemas.microsoft.com/office/drawing/2014/main" id="{34B88E22-6D78-495C-8186-BCD446B2ACE9}"/>
+                <a16:creationId xmlns:a16="http://schemas.microsoft.com/office/drawing/2014/main" id="{E2D0C9D7-603E-4093-BFF5-2B14D4DEDFE9}"/>
               </a:ext>
             </a:extLst>
           </p:cNvPr>
@@ -8057,7 +10153,7 @@
           <p:cNvPr id="10" name="">
             <a:extLst xmlns:a="http://schemas.openxmlformats.org/drawingml/2006/main">
               <a:ext uri="{FF2B5EF4-FFF2-40B4-BE49-F238E27FC236}">
-                <a16:creationId xmlns:a16="http://schemas.microsoft.com/office/drawing/2014/main" id="{517AECE2-16BD-4080-A17A-9C3CDB316D14}"/>
+                <a16:creationId xmlns:a16="http://schemas.microsoft.com/office/drawing/2014/main" id="{321B88F5-C022-46A7-B7DD-7F654955A267}"/>
               </a:ext>
             </a:extLst>
           </p:cNvPr>
@@ -8112,7 +10208,7 @@
     </p:spTree>
     <p:extLst>
       <p:ext uri="{BB962C8B-B14F-4D97-AF65-F5344CB8AC3E}">
-        <p14:creationId xmlns:p14="http://schemas.microsoft.com/office/powerpoint/2010/main" val="712163763"/>
+        <p14:creationId xmlns:p14="http://schemas.microsoft.com/office/powerpoint/2010/main" val="2058143011"/>
       </p:ext>
     </p:extLst>
   </p:cSld>
@@ -8143,7 +10239,7 @@
           <p:cNvPr id="9" name="">
             <a:extLst xmlns:a="http://schemas.openxmlformats.org/drawingml/2006/main">
               <a:ext uri="{FF2B5EF4-FFF2-40B4-BE49-F238E27FC236}">
-                <a16:creationId xmlns:a16="http://schemas.microsoft.com/office/drawing/2014/main" id="{FF275000-A233-4849-BF32-F8CBDCAAEC05}"/>
+                <a16:creationId xmlns:a16="http://schemas.microsoft.com/office/drawing/2014/main" id="{39B27741-2A90-485B-8D1E-15F207F186FA}"/>
               </a:ext>
             </a:extLst>
           </p:cNvPr>
@@ -8200,7 +10296,7 @@
           <p:cNvPr id="2" name="">
             <a:extLst xmlns:a="http://schemas.openxmlformats.org/drawingml/2006/main">
               <a:ext uri="{FF2B5EF4-FFF2-40B4-BE49-F238E27FC236}">
-                <a16:creationId xmlns:a16="http://schemas.microsoft.com/office/drawing/2014/main" id="{741D2FE3-1BB1-4A13-983E-0C1038EDD1AB}"/>
+                <a16:creationId xmlns:a16="http://schemas.microsoft.com/office/drawing/2014/main" id="{E25AE1C7-78B1-4F32-9D0C-E5D72B2A062D}"/>
               </a:ext>
             </a:extLst>
           </p:cNvPr>
@@ -8257,7 +10353,7 @@
           <p:cNvPr id="3" name="">
             <a:extLst xmlns:a="http://schemas.openxmlformats.org/drawingml/2006/main">
               <a:ext uri="{FF2B5EF4-FFF2-40B4-BE49-F238E27FC236}">
-                <a16:creationId xmlns:a16="http://schemas.microsoft.com/office/drawing/2014/main" id="{EBC4E112-A703-40BB-B21A-3AD1E48BFB36}"/>
+                <a16:creationId xmlns:a16="http://schemas.microsoft.com/office/drawing/2014/main" id="{922B6715-E1BF-4213-ACFD-94926660302B}"/>
               </a:ext>
             </a:extLst>
           </p:cNvPr>
@@ -8947,7 +11043,7 @@
           <p:cNvPr id="5" name="">
             <a:extLst xmlns:a="http://schemas.openxmlformats.org/drawingml/2006/main">
               <a:ext uri="{FF2B5EF4-FFF2-40B4-BE49-F238E27FC236}">
-                <a16:creationId xmlns:a16="http://schemas.microsoft.com/office/drawing/2014/main" id="{A0C26634-BBC2-4E71-A4C2-50E34DFF330E}"/>
+                <a16:creationId xmlns:a16="http://schemas.microsoft.com/office/drawing/2014/main" id="{ED12631D-D378-43E9-B131-1018C3938156}"/>
               </a:ext>
             </a:extLst>
           </p:cNvPr>
@@ -9004,7 +11100,7 @@
           <p:cNvPr id="6" name="">
             <a:extLst xmlns:a="http://schemas.openxmlformats.org/drawingml/2006/main">
               <a:ext uri="{FF2B5EF4-FFF2-40B4-BE49-F238E27FC236}">
-                <a16:creationId xmlns:a16="http://schemas.microsoft.com/office/drawing/2014/main" id="{4D9BC7AE-AE67-4C0D-A2AD-72A24F7FD61F}"/>
+                <a16:creationId xmlns:a16="http://schemas.microsoft.com/office/drawing/2014/main" id="{266B3C5F-795F-4E05-8D33-7C6839FDC2AF}"/>
               </a:ext>
             </a:extLst>
           </p:cNvPr>
@@ -9084,7 +11180,7 @@
           <p:cNvPr id="7" name="">
             <a:extLst xmlns:a="http://schemas.openxmlformats.org/drawingml/2006/main">
               <a:ext uri="{FF2B5EF4-FFF2-40B4-BE49-F238E27FC236}">
-                <a16:creationId xmlns:a16="http://schemas.microsoft.com/office/drawing/2014/main" id="{03416080-3F68-477B-8FB9-2CE016482A67}"/>
+                <a16:creationId xmlns:a16="http://schemas.microsoft.com/office/drawing/2014/main" id="{2E4D51F2-4BD7-4DF5-8207-EFCF1C6445FD}"/>
               </a:ext>
             </a:extLst>
           </p:cNvPr>
@@ -9141,7 +11237,7 @@
           <p:cNvPr id="8" name="">
             <a:extLst xmlns:a="http://schemas.openxmlformats.org/drawingml/2006/main">
               <a:ext uri="{FF2B5EF4-FFF2-40B4-BE49-F238E27FC236}">
-                <a16:creationId xmlns:a16="http://schemas.microsoft.com/office/drawing/2014/main" id="{88712F42-5320-468C-AB52-CFAB9D77FA43}"/>
+                <a16:creationId xmlns:a16="http://schemas.microsoft.com/office/drawing/2014/main" id="{127A27FA-01FD-464A-B157-3AAD98278640}"/>
               </a:ext>
             </a:extLst>
           </p:cNvPr>
@@ -9196,7 +11292,7 @@
     </p:spTree>
     <p:extLst>
       <p:ext uri="{BB962C8B-B14F-4D97-AF65-F5344CB8AC3E}">
-        <p14:creationId xmlns:p14="http://schemas.microsoft.com/office/powerpoint/2010/main" val="729240935"/>
+        <p14:creationId xmlns:p14="http://schemas.microsoft.com/office/powerpoint/2010/main" val="956094066"/>
       </p:ext>
     </p:extLst>
   </p:cSld>

</xml_diff>

<commit_message>
Preserve interrupted replay position and refine campus construction
</commit_message>
<xml_diff>
--- a/downloads/energy-campus-v3.2.pptx
+++ b/downloads/energy-campus-v3.2.pptx
@@ -2,24 +2,24 @@
 <file path=ppt/presentation.xml><?xml version="1.0" encoding="utf-8"?>
 <p:presentation xmlns:p="http://schemas.openxmlformats.org/presentationml/2006/main">
   <p:sldMasterIdLst>
-    <p:sldMasterId xmlns:r="http://schemas.openxmlformats.org/officeDocument/2006/relationships" id="2147483648" r:id="R237280c3b5cd4a60"/>
+    <p:sldMasterId xmlns:r="http://schemas.openxmlformats.org/officeDocument/2006/relationships" id="2147483648" r:id="R1bc19c15a1d8461d"/>
   </p:sldMasterIdLst>
   <p:notesMasterIdLst>
-    <p:notesMasterId xmlns:r="http://schemas.openxmlformats.org/officeDocument/2006/relationships" r:id="R99325263fbe341b0"/>
+    <p:notesMasterId xmlns:r="http://schemas.openxmlformats.org/officeDocument/2006/relationships" r:id="R32350082cec34897"/>
   </p:notesMasterIdLst>
   <p:sldIdLst>
-    <p:sldId xmlns:r="http://schemas.openxmlformats.org/officeDocument/2006/relationships" id="256" r:id="R738b9d631faf49d4"/>
-    <p:sldId xmlns:r="http://schemas.openxmlformats.org/officeDocument/2006/relationships" id="257" r:id="R6532a3d8a00847d6"/>
-    <p:sldId xmlns:r="http://schemas.openxmlformats.org/officeDocument/2006/relationships" id="258" r:id="Re8d7d4ad1c4a48d5"/>
-    <p:sldId xmlns:r="http://schemas.openxmlformats.org/officeDocument/2006/relationships" id="259" r:id="Ra90c56c4b2c940f9"/>
-    <p:sldId xmlns:r="http://schemas.openxmlformats.org/officeDocument/2006/relationships" id="260" r:id="R4ea356e576bb4abc"/>
-    <p:sldId xmlns:r="http://schemas.openxmlformats.org/officeDocument/2006/relationships" id="261" r:id="R2650ae6b93c545f1"/>
-    <p:sldId xmlns:r="http://schemas.openxmlformats.org/officeDocument/2006/relationships" id="262" r:id="R745522b112d840b9"/>
-    <p:sldId xmlns:r="http://schemas.openxmlformats.org/officeDocument/2006/relationships" id="263" r:id="R34bf5b91d14a40f0"/>
-    <p:sldId xmlns:r="http://schemas.openxmlformats.org/officeDocument/2006/relationships" id="264" r:id="Ra4e03142ff3745b1"/>
-    <p:sldId xmlns:r="http://schemas.openxmlformats.org/officeDocument/2006/relationships" id="265" r:id="R6506680e0f324c22"/>
-    <p:sldId xmlns:r="http://schemas.openxmlformats.org/officeDocument/2006/relationships" id="266" r:id="R536b7328967f4e20"/>
-    <p:sldId xmlns:r="http://schemas.openxmlformats.org/officeDocument/2006/relationships" id="267" r:id="Rdb6ea84bd6ef4d27"/>
+    <p:sldId xmlns:r="http://schemas.openxmlformats.org/officeDocument/2006/relationships" id="256" r:id="R85bd6676771d4bfb"/>
+    <p:sldId xmlns:r="http://schemas.openxmlformats.org/officeDocument/2006/relationships" id="257" r:id="R4e55cbf3fc7e4be6"/>
+    <p:sldId xmlns:r="http://schemas.openxmlformats.org/officeDocument/2006/relationships" id="258" r:id="R6a17c84776534ee9"/>
+    <p:sldId xmlns:r="http://schemas.openxmlformats.org/officeDocument/2006/relationships" id="259" r:id="Ree753a7185814788"/>
+    <p:sldId xmlns:r="http://schemas.openxmlformats.org/officeDocument/2006/relationships" id="260" r:id="R3c63f40bcd324ead"/>
+    <p:sldId xmlns:r="http://schemas.openxmlformats.org/officeDocument/2006/relationships" id="261" r:id="R7df4c2dd30984645"/>
+    <p:sldId xmlns:r="http://schemas.openxmlformats.org/officeDocument/2006/relationships" id="262" r:id="R2e2df69fd7ef49e6"/>
+    <p:sldId xmlns:r="http://schemas.openxmlformats.org/officeDocument/2006/relationships" id="263" r:id="Rf26adbe5da684e0c"/>
+    <p:sldId xmlns:r="http://schemas.openxmlformats.org/officeDocument/2006/relationships" id="264" r:id="Rf633fadbb9664223"/>
+    <p:sldId xmlns:r="http://schemas.openxmlformats.org/officeDocument/2006/relationships" id="265" r:id="Rd5bbb83a342e4d60"/>
+    <p:sldId xmlns:r="http://schemas.openxmlformats.org/officeDocument/2006/relationships" id="266" r:id="R8a69254038474559"/>
+    <p:sldId xmlns:r="http://schemas.openxmlformats.org/officeDocument/2006/relationships" id="267" r:id="R476704f16cc7420e"/>
   </p:sldIdLst>
   <p:sldSz cx="12192000" cy="6858000"/>
   <p:notesSz cx="6858000" cy="9144000"/>
@@ -768,42 +768,7 @@
           <a:lstStyle xmlns:a="http://schemas.openxmlformats.org/drawingml/2006/main"/>
           <a:p xmlns:a="http://schemas.openxmlformats.org/drawingml/2006/main">
             <a:r>
-              <a:t>证据字段：public replay manifest / offline package</a:t>
-            </a:r>
-          </a:p>
-          <a:p xmlns:a="http://schemas.openxmlformats.org/drawingml/2006/main">
-            <a:r>
-              <a:t>下一步研究需有明确工程难题和新的未揭示评价任务；本轮不宣称RSI优势。</a:t>
-            </a:r>
-          </a:p>
-          <a:p xmlns:a="http://schemas.openxmlformats.org/drawingml/2006/main">
-            <a:r>
-              <a:t>results/v32/jobs/310912a4ad924de6-summary.json SHA256 7274d16c5508057ac956a9056930a3b4b4e9fab4f664c1c707be827a50ca8ac1</a:t>
-            </a:r>
-          </a:p>
-          <a:p xmlns:a="http://schemas.openxmlformats.org/drawingml/2006/main">
-            <a:r>
-              <a:t>results/v32/improvements/4de87f7924b021d8/result.json SHA256 3d7e1bfbabeb55fd41f0c0696eaaca947950262e877b83d133505920d06671f3</a:t>
-            </a:r>
-          </a:p>
-          <a:p xmlns:a="http://schemas.openxmlformats.org/drawingml/2006/main">
-            <a:r>
-              <a:t>results/v32/opportunity/7a6aa4e97c225bc8/result.json SHA256 1af53221b4745a51325ccf8e66133f1253ae2db7cd50b9ea681c18658d39c008</a:t>
-            </a:r>
-          </a:p>
-          <a:p xmlns:a="http://schemas.openxmlformats.org/drawingml/2006/main">
-            <a:r>
-              <a:t>validation/persistent-shift-2026-06/comparison.json SHA256 d0355b0a660d75381dff7411a389b5181e8db3cfeabf30041909fd2981934048</a:t>
-            </a:r>
-          </a:p>
-          <a:p xmlns:a="http://schemas.openxmlformats.org/drawingml/2006/main">
-            <a:r>
-              <a:t>validation/persistent-shift-2026-06/acceptance.json SHA256 15705a3d9d58348b60a50a314c33c90e3e76f6416449d81d72aa157e10b8535a</a:t>
-            </a:r>
-          </a:p>
-          <a:p xmlns:a="http://schemas.openxmlformats.org/drawingml/2006/main">
-            <a:r>
-              <a:t>SimBench https://simbench.de/en/download/datasets/ ODbL1.0 / DbCL1.0。德国原始2016曲线按连续时段映射到中国时区2026仿真场景，非中国园区实测。公开回放 https://jinyh.github.io/energy-campus/ 。月度示范与72小时RSI研究分别记账。</a:t>
+              <a:t>当前界面截图：validation/visual-recovery-2026-10-07/comparison-1366-final.png SHA256 9317ce9ab73feebc55d04a6ed0eb5971e77c36477ebd99840e5f5f202ffff878。仅更新界面截图；原有真实成本与研究停止结论保持。视觉仍未达到参考站标准。SimBench 德国历史来源，非中国园区实测。</a:t>
             </a:r>
           </a:p>
         </p:txBody>
@@ -873,42 +838,7 @@
           <a:lstStyle xmlns:a="http://schemas.openxmlformats.org/drawingml/2006/main"/>
           <a:p xmlns:a="http://schemas.openxmlformats.org/drawingml/2006/main">
             <a:r>
-              <a:t>证据字段：June scene screenshot</a:t>
-            </a:r>
-          </a:p>
-          <a:p xmlns:a="http://schemas.openxmlformats.org/drawingml/2006/main">
-            <a:r>
-              <a:t>示意建筑布局；当前视觉与参考站仍有差距，保留视觉验收记录。</a:t>
-            </a:r>
-          </a:p>
-          <a:p xmlns:a="http://schemas.openxmlformats.org/drawingml/2006/main">
-            <a:r>
-              <a:t>results/v32/jobs/310912a4ad924de6-summary.json SHA256 7274d16c5508057ac956a9056930a3b4b4e9fab4f664c1c707be827a50ca8ac1</a:t>
-            </a:r>
-          </a:p>
-          <a:p xmlns:a="http://schemas.openxmlformats.org/drawingml/2006/main">
-            <a:r>
-              <a:t>results/v32/improvements/4de87f7924b021d8/result.json SHA256 3d7e1bfbabeb55fd41f0c0696eaaca947950262e877b83d133505920d06671f3</a:t>
-            </a:r>
-          </a:p>
-          <a:p xmlns:a="http://schemas.openxmlformats.org/drawingml/2006/main">
-            <a:r>
-              <a:t>results/v32/opportunity/7a6aa4e97c225bc8/result.json SHA256 1af53221b4745a51325ccf8e66133f1253ae2db7cd50b9ea681c18658d39c008</a:t>
-            </a:r>
-          </a:p>
-          <a:p xmlns:a="http://schemas.openxmlformats.org/drawingml/2006/main">
-            <a:r>
-              <a:t>validation/persistent-shift-2026-06/comparison.json SHA256 d0355b0a660d75381dff7411a389b5181e8db3cfeabf30041909fd2981934048</a:t>
-            </a:r>
-          </a:p>
-          <a:p xmlns:a="http://schemas.openxmlformats.org/drawingml/2006/main">
-            <a:r>
-              <a:t>validation/persistent-shift-2026-06/acceptance.json SHA256 15705a3d9d58348b60a50a314c33c90e3e76f6416449d81d72aa157e10b8535a</a:t>
-            </a:r>
-          </a:p>
-          <a:p xmlns:a="http://schemas.openxmlformats.org/drawingml/2006/main">
-            <a:r>
-              <a:t>SimBench https://simbench.de/en/download/datasets/ ODbL1.0 / DbCL1.0。德国原始2016曲线按连续时段映射到中国时区2026仿真场景，非中国园区实测。公开回放 https://jinyh.github.io/energy-campus/ 。月度示范与72小时RSI研究分别记账。</a:t>
+              <a:t>当前界面截图：validation/visual-recovery-2026-10-07/day-overview-1366-final.png SHA256 12786192507f120fd156691ecd4f11441c974e036ae3d51a042ada3cd171e8bf。仅更新界面截图；原有真实成本与研究停止结论保持。视觉仍未达到参考站标准。SimBench 德国历史来源，非中国园区实测。</a:t>
             </a:r>
           </a:p>
         </p:txBody>
@@ -1711,7 +1641,7 @@
   </p:cSld>
   <p:clrMap bg1="lt1" tx1="dk1" bg2="lt2" tx2="dk2" accent1="accent1" accent2="accent2" accent3="accent3" accent4="accent4" accent5="accent5" accent6="accent6" hlink="hlink" folHlink="folHlink"/>
   <p:sldLayoutIdLst>
-    <p:sldLayoutId xmlns:r="http://schemas.openxmlformats.org/officeDocument/2006/relationships" id="2147483649" r:id="R125a502dfd704d19"/>
+    <p:sldLayoutId xmlns:r="http://schemas.openxmlformats.org/officeDocument/2006/relationships" id="2147483649" r:id="R1bc4450b69704f4b"/>
   </p:sldLayoutIdLst>
   <p:txStyles>
     <p:titleStyle>
@@ -2291,6 +2221,7 @@
           <a:lstStyle xmlns:a="http://schemas.openxmlformats.org/drawingml/2006/main"/>
           <a:p xmlns:a="http://schemas.openxmlformats.org/drawingml/2006/main">
             <a:pPr algn="l">
+              <a:buNone/>
               <a:defRPr sz="1125" b="0">
                 <a:solidFill>
                   <a:srgbClr val="75D5C5"/>
@@ -2348,6 +2279,7 @@
           <a:lstStyle xmlns:a="http://schemas.openxmlformats.org/drawingml/2006/main"/>
           <a:p xmlns:a="http://schemas.openxmlformats.org/drawingml/2006/main">
             <a:pPr algn="l">
+              <a:buNone/>
               <a:defRPr sz="3150" b="1">
                 <a:solidFill>
                   <a:srgbClr val="E5EDF7"/>
@@ -2435,6 +2367,7 @@
           <a:lstStyle xmlns:a="http://schemas.openxmlformats.org/drawingml/2006/main"/>
           <a:p xmlns:a="http://schemas.openxmlformats.org/drawingml/2006/main">
             <a:pPr algn="l">
+              <a:buNone/>
               <a:defRPr sz="4125" b="1">
                 <a:solidFill>
                   <a:srgbClr val="75D5C5"/>
@@ -2492,6 +2425,7 @@
           <a:lstStyle xmlns:a="http://schemas.openxmlformats.org/drawingml/2006/main"/>
           <a:p xmlns:a="http://schemas.openxmlformats.org/drawingml/2006/main">
             <a:pPr algn="l">
+              <a:buNone/>
               <a:defRPr sz="2325" b="0">
                 <a:solidFill>
                   <a:srgbClr val="E5EDF7"/>
@@ -2549,6 +2483,7 @@
           <a:lstStyle xmlns:a="http://schemas.openxmlformats.org/drawingml/2006/main"/>
           <a:p xmlns:a="http://schemas.openxmlformats.org/drawingml/2006/main">
             <a:pPr algn="l">
+              <a:buNone/>
               <a:defRPr sz="2250" b="0">
                 <a:solidFill>
                   <a:srgbClr val="75D5C5"/>
@@ -2606,6 +2541,7 @@
           <a:lstStyle xmlns:a="http://schemas.openxmlformats.org/drawingml/2006/main"/>
           <a:p xmlns:a="http://schemas.openxmlformats.org/drawingml/2006/main">
             <a:pPr algn="l">
+              <a:buNone/>
               <a:defRPr sz="1875" b="0">
                 <a:solidFill>
                   <a:srgbClr val="9BB0C9"/>
@@ -2663,6 +2599,7 @@
           <a:lstStyle xmlns:a="http://schemas.openxmlformats.org/drawingml/2006/main"/>
           <a:p xmlns:a="http://schemas.openxmlformats.org/drawingml/2006/main">
             <a:pPr algn="l">
+              <a:buNone/>
               <a:defRPr sz="975" b="0">
                 <a:solidFill>
                   <a:srgbClr val="9BB0C9"/>
@@ -2720,6 +2657,7 @@
           <a:lstStyle xmlns:a="http://schemas.openxmlformats.org/drawingml/2006/main"/>
           <a:p xmlns:a="http://schemas.openxmlformats.org/drawingml/2006/main">
             <a:pPr algn="r">
+              <a:buNone/>
               <a:defRPr sz="1125" b="0">
                 <a:solidFill>
                   <a:srgbClr val="9BB0C9"/>
@@ -2806,6 +2744,7 @@
           <a:lstStyle xmlns:a="http://schemas.openxmlformats.org/drawingml/2006/main"/>
           <a:p xmlns:a="http://schemas.openxmlformats.org/drawingml/2006/main">
             <a:pPr algn="l">
+              <a:buNone/>
               <a:defRPr sz="1125" b="0">
                 <a:solidFill>
                   <a:srgbClr val="75D5C5"/>
@@ -2863,6 +2802,7 @@
           <a:lstStyle xmlns:a="http://schemas.openxmlformats.org/drawingml/2006/main"/>
           <a:p xmlns:a="http://schemas.openxmlformats.org/drawingml/2006/main">
             <a:pPr algn="l">
+              <a:buNone/>
               <a:defRPr sz="3150" b="1">
                 <a:solidFill>
                   <a:srgbClr val="E5EDF7"/>
@@ -2950,6 +2890,7 @@
           <a:lstStyle xmlns:a="http://schemas.openxmlformats.org/drawingml/2006/main"/>
           <a:p xmlns:a="http://schemas.openxmlformats.org/drawingml/2006/main">
             <a:pPr algn="l">
+              <a:buNone/>
               <a:defRPr sz="2100" b="1">
                 <a:solidFill>
                   <a:srgbClr val="75D5C5"/>
@@ -2975,7 +2916,7 @@
       </p:sp>
       <p:graphicFrame>
         <p:nvGraphicFramePr>
-          <p:cNvPr id="14" name=""/>
+          <p:cNvPr id="16" name=""/>
           <p:cNvGraphicFramePr/>
           <p:nvPr/>
         </p:nvGraphicFramePr>
@@ -3299,6 +3240,7 @@
           <a:lstStyle xmlns:a="http://schemas.openxmlformats.org/drawingml/2006/main"/>
           <a:p xmlns:a="http://schemas.openxmlformats.org/drawingml/2006/main">
             <a:pPr algn="l">
+              <a:buNone/>
               <a:defRPr sz="2100" b="1">
                 <a:solidFill>
                   <a:srgbClr val="E9B675"/>
@@ -3356,6 +3298,7 @@
           <a:lstStyle xmlns:a="http://schemas.openxmlformats.org/drawingml/2006/main"/>
           <a:p xmlns:a="http://schemas.openxmlformats.org/drawingml/2006/main">
             <a:pPr algn="l">
+              <a:buNone/>
               <a:defRPr sz="1725" b="0">
                 <a:solidFill>
                   <a:srgbClr val="9BB0C9"/>
@@ -3413,6 +3356,7 @@
           <a:lstStyle xmlns:a="http://schemas.openxmlformats.org/drawingml/2006/main"/>
           <a:p xmlns:a="http://schemas.openxmlformats.org/drawingml/2006/main">
             <a:pPr algn="l">
+              <a:buNone/>
               <a:defRPr sz="975" b="0">
                 <a:solidFill>
                   <a:srgbClr val="9BB0C9"/>
@@ -3470,6 +3414,7 @@
           <a:lstStyle xmlns:a="http://schemas.openxmlformats.org/drawingml/2006/main"/>
           <a:p xmlns:a="http://schemas.openxmlformats.org/drawingml/2006/main">
             <a:pPr algn="r">
+              <a:buNone/>
               <a:defRPr sz="1125" b="0">
                 <a:solidFill>
                   <a:srgbClr val="9BB0C9"/>
@@ -3556,6 +3501,7 @@
           <a:lstStyle xmlns:a="http://schemas.openxmlformats.org/drawingml/2006/main"/>
           <a:p xmlns:a="http://schemas.openxmlformats.org/drawingml/2006/main">
             <a:pPr algn="l">
+              <a:buNone/>
               <a:defRPr sz="1125" b="0">
                 <a:solidFill>
                   <a:srgbClr val="75D5C5"/>
@@ -3613,6 +3559,7 @@
           <a:lstStyle xmlns:a="http://schemas.openxmlformats.org/drawingml/2006/main"/>
           <a:p xmlns:a="http://schemas.openxmlformats.org/drawingml/2006/main">
             <a:pPr algn="l">
+              <a:buNone/>
               <a:defRPr sz="3150" b="1">
                 <a:solidFill>
                   <a:srgbClr val="E5EDF7"/>
@@ -3668,7 +3615,7 @@
       </p:sp>
       <p:graphicFrame>
         <p:nvGraphicFramePr>
-          <p:cNvPr id="13" name=""/>
+          <p:cNvPr id="15" name=""/>
           <p:cNvGraphicFramePr/>
           <p:nvPr/>
         </p:nvGraphicFramePr>
@@ -4253,6 +4200,7 @@
           <a:lstStyle xmlns:a="http://schemas.openxmlformats.org/drawingml/2006/main"/>
           <a:p xmlns:a="http://schemas.openxmlformats.org/drawingml/2006/main">
             <a:pPr algn="l">
+              <a:buNone/>
               <a:defRPr sz="2100" b="1">
                 <a:solidFill>
                   <a:srgbClr val="75D5C5"/>
@@ -4310,6 +4258,7 @@
           <a:lstStyle xmlns:a="http://schemas.openxmlformats.org/drawingml/2006/main"/>
           <a:p xmlns:a="http://schemas.openxmlformats.org/drawingml/2006/main">
             <a:pPr algn="l">
+              <a:buNone/>
               <a:defRPr sz="1875" b="0">
                 <a:solidFill>
                   <a:srgbClr val="E5EDF7"/>
@@ -4333,6 +4282,7 @@
           </a:p>
           <a:p xmlns:a="http://schemas.openxmlformats.org/drawingml/2006/main">
             <a:pPr algn="l">
+              <a:buNone/>
               <a:defRPr sz="1875" b="0">
                 <a:solidFill>
                   <a:srgbClr val="E5EDF7"/>
@@ -4390,6 +4340,7 @@
           <a:lstStyle xmlns:a="http://schemas.openxmlformats.org/drawingml/2006/main"/>
           <a:p xmlns:a="http://schemas.openxmlformats.org/drawingml/2006/main">
             <a:pPr algn="l">
+              <a:buNone/>
               <a:defRPr sz="1575" b="0">
                 <a:solidFill>
                   <a:srgbClr val="9BB0C9"/>
@@ -4447,6 +4398,7 @@
           <a:lstStyle xmlns:a="http://schemas.openxmlformats.org/drawingml/2006/main"/>
           <a:p xmlns:a="http://schemas.openxmlformats.org/drawingml/2006/main">
             <a:pPr algn="l">
+              <a:buNone/>
               <a:defRPr sz="975" b="0">
                 <a:solidFill>
                   <a:srgbClr val="9BB0C9"/>
@@ -4504,6 +4456,7 @@
           <a:lstStyle xmlns:a="http://schemas.openxmlformats.org/drawingml/2006/main"/>
           <a:p xmlns:a="http://schemas.openxmlformats.org/drawingml/2006/main">
             <a:pPr algn="r">
+              <a:buNone/>
               <a:defRPr sz="1125" b="0">
                 <a:solidFill>
                   <a:srgbClr val="9BB0C9"/>
@@ -4590,6 +4543,7 @@
           <a:lstStyle xmlns:a="http://schemas.openxmlformats.org/drawingml/2006/main"/>
           <a:p xmlns:a="http://schemas.openxmlformats.org/drawingml/2006/main">
             <a:pPr algn="l">
+              <a:buNone/>
               <a:defRPr sz="1125" b="0">
                 <a:solidFill>
                   <a:srgbClr val="75D5C5"/>
@@ -4647,6 +4601,7 @@
           <a:lstStyle xmlns:a="http://schemas.openxmlformats.org/drawingml/2006/main"/>
           <a:p xmlns:a="http://schemas.openxmlformats.org/drawingml/2006/main">
             <a:pPr algn="l">
+              <a:buNone/>
               <a:defRPr sz="3150" b="1">
                 <a:solidFill>
                   <a:srgbClr val="E5EDF7"/>
@@ -4702,15 +4657,18 @@
       </p:sp>
       <p:pic>
         <p:nvPicPr>
-          <p:cNvPr id="11" name=""/>
+          <p:cNvPr id="13" name=""/>
           <p:cNvPicPr>
             <a:picLocks xmlns:a="http://schemas.openxmlformats.org/drawingml/2006/main" noChangeAspect="1"/>
           </p:cNvPicPr>
           <p:nvPr/>
         </p:nvPicPr>
         <p:blipFill>
-          <a:blip xmlns:r="http://schemas.openxmlformats.org/officeDocument/2006/relationships" xmlns:a="http://schemas.openxmlformats.org/drawingml/2006/main" r:embed="R400d428c51664935"/>
-          <a:stretch xmlns:a="http://schemas.openxmlformats.org/drawingml/2006/main"/>
+          <a:blip xmlns:r="http://schemas.openxmlformats.org/officeDocument/2006/relationships" xmlns:a="http://schemas.openxmlformats.org/drawingml/2006/main" r:embed="Rc6115de304ac444c"/>
+          <a:srcRect xmlns:a="http://schemas.openxmlformats.org/drawingml/2006/main" l="0" t="0" r="0" b="0"/>
+          <a:stretch xmlns:a="http://schemas.openxmlformats.org/drawingml/2006/main">
+            <a:fillRect l="0" t="0" r="0" b="0"/>
+          </a:stretch>
         </p:blipFill>
         <p:spPr>
           <a:xfrm xmlns:a="http://schemas.openxmlformats.org/drawingml/2006/main">
@@ -4756,6 +4714,7 @@
           <a:lstStyle xmlns:a="http://schemas.openxmlformats.org/drawingml/2006/main"/>
           <a:p xmlns:a="http://schemas.openxmlformats.org/drawingml/2006/main">
             <a:pPr algn="l">
+              <a:buNone/>
               <a:defRPr sz="1800" b="0">
                 <a:solidFill>
                   <a:srgbClr val="75D5C5"/>
@@ -4813,6 +4772,7 @@
           <a:lstStyle xmlns:a="http://schemas.openxmlformats.org/drawingml/2006/main"/>
           <a:p xmlns:a="http://schemas.openxmlformats.org/drawingml/2006/main">
             <a:pPr algn="l">
+              <a:buNone/>
               <a:defRPr sz="975" b="0">
                 <a:solidFill>
                   <a:srgbClr val="9BB0C9"/>
@@ -4870,6 +4830,7 @@
           <a:lstStyle xmlns:a="http://schemas.openxmlformats.org/drawingml/2006/main"/>
           <a:p xmlns:a="http://schemas.openxmlformats.org/drawingml/2006/main">
             <a:pPr algn="r">
+              <a:buNone/>
               <a:defRPr sz="1125" b="0">
                 <a:solidFill>
                   <a:srgbClr val="9BB0C9"/>
@@ -4956,6 +4917,7 @@
           <a:lstStyle xmlns:a="http://schemas.openxmlformats.org/drawingml/2006/main"/>
           <a:p xmlns:a="http://schemas.openxmlformats.org/drawingml/2006/main">
             <a:pPr algn="l">
+              <a:buNone/>
               <a:defRPr sz="1125" b="0">
                 <a:solidFill>
                   <a:srgbClr val="75D5C5"/>
@@ -5013,6 +4975,7 @@
           <a:lstStyle xmlns:a="http://schemas.openxmlformats.org/drawingml/2006/main"/>
           <a:p xmlns:a="http://schemas.openxmlformats.org/drawingml/2006/main">
             <a:pPr algn="l">
+              <a:buNone/>
               <a:defRPr sz="3150" b="1">
                 <a:solidFill>
                   <a:srgbClr val="E5EDF7"/>
@@ -5068,15 +5031,18 @@
       </p:sp>
       <p:pic>
         <p:nvPicPr>
-          <p:cNvPr id="11" name=""/>
+          <p:cNvPr id="13" name=""/>
           <p:cNvPicPr>
             <a:picLocks xmlns:a="http://schemas.openxmlformats.org/drawingml/2006/main" noChangeAspect="1"/>
           </p:cNvPicPr>
           <p:nvPr/>
         </p:nvPicPr>
         <p:blipFill>
-          <a:blip xmlns:r="http://schemas.openxmlformats.org/officeDocument/2006/relationships" xmlns:a="http://schemas.openxmlformats.org/drawingml/2006/main" r:embed="R83ccf00fa7264479"/>
-          <a:stretch xmlns:a="http://schemas.openxmlformats.org/drawingml/2006/main"/>
+          <a:blip xmlns:r="http://schemas.openxmlformats.org/officeDocument/2006/relationships" xmlns:a="http://schemas.openxmlformats.org/drawingml/2006/main" r:embed="Rfacc722decc346e6"/>
+          <a:srcRect xmlns:a="http://schemas.openxmlformats.org/drawingml/2006/main" l="0" t="2306" r="0" b="2306"/>
+          <a:stretch xmlns:a="http://schemas.openxmlformats.org/drawingml/2006/main">
+            <a:fillRect l="0" t="0" r="0" b="0"/>
+          </a:stretch>
         </p:blipFill>
         <p:spPr>
           <a:xfrm xmlns:a="http://schemas.openxmlformats.org/drawingml/2006/main">
@@ -5122,6 +5088,7 @@
           <a:lstStyle xmlns:a="http://schemas.openxmlformats.org/drawingml/2006/main"/>
           <a:p xmlns:a="http://schemas.openxmlformats.org/drawingml/2006/main">
             <a:pPr algn="l">
+              <a:buNone/>
               <a:defRPr sz="1875" b="0">
                 <a:solidFill>
                   <a:srgbClr val="75D5C5"/>
@@ -5179,6 +5146,7 @@
           <a:lstStyle xmlns:a="http://schemas.openxmlformats.org/drawingml/2006/main"/>
           <a:p xmlns:a="http://schemas.openxmlformats.org/drawingml/2006/main">
             <a:pPr algn="l">
+              <a:buNone/>
               <a:defRPr sz="975" b="0">
                 <a:solidFill>
                   <a:srgbClr val="9BB0C9"/>
@@ -5236,6 +5204,7 @@
           <a:lstStyle xmlns:a="http://schemas.openxmlformats.org/drawingml/2006/main"/>
           <a:p xmlns:a="http://schemas.openxmlformats.org/drawingml/2006/main">
             <a:pPr algn="r">
+              <a:buNone/>
               <a:defRPr sz="1125" b="0">
                 <a:solidFill>
                   <a:srgbClr val="9BB0C9"/>
@@ -5322,6 +5291,7 @@
           <a:lstStyle xmlns:a="http://schemas.openxmlformats.org/drawingml/2006/main"/>
           <a:p xmlns:a="http://schemas.openxmlformats.org/drawingml/2006/main">
             <a:pPr algn="l">
+              <a:buNone/>
               <a:defRPr sz="1125" b="0">
                 <a:solidFill>
                   <a:srgbClr val="75D5C5"/>
@@ -5379,6 +5349,7 @@
           <a:lstStyle xmlns:a="http://schemas.openxmlformats.org/drawingml/2006/main"/>
           <a:p xmlns:a="http://schemas.openxmlformats.org/drawingml/2006/main">
             <a:pPr algn="l">
+              <a:buNone/>
               <a:defRPr sz="3150" b="1">
                 <a:solidFill>
                   <a:srgbClr val="E5EDF7"/>
@@ -5434,7 +5405,7 @@
       </p:sp>
       <p:graphicFrame>
         <p:nvGraphicFramePr>
-          <p:cNvPr id="11" name=""/>
+          <p:cNvPr id="13" name=""/>
           <p:cNvGraphicFramePr/>
           <p:nvPr/>
         </p:nvGraphicFramePr>
@@ -5866,6 +5837,7 @@
           <a:lstStyle xmlns:a="http://schemas.openxmlformats.org/drawingml/2006/main"/>
           <a:p xmlns:a="http://schemas.openxmlformats.org/drawingml/2006/main">
             <a:pPr algn="l">
+              <a:buNone/>
               <a:defRPr sz="1875" b="0">
                 <a:solidFill>
                   <a:srgbClr val="75D5C5"/>
@@ -5923,6 +5895,7 @@
           <a:lstStyle xmlns:a="http://schemas.openxmlformats.org/drawingml/2006/main"/>
           <a:p xmlns:a="http://schemas.openxmlformats.org/drawingml/2006/main">
             <a:pPr algn="l">
+              <a:buNone/>
               <a:defRPr sz="975" b="0">
                 <a:solidFill>
                   <a:srgbClr val="9BB0C9"/>
@@ -5980,6 +5953,7 @@
           <a:lstStyle xmlns:a="http://schemas.openxmlformats.org/drawingml/2006/main"/>
           <a:p xmlns:a="http://schemas.openxmlformats.org/drawingml/2006/main">
             <a:pPr algn="r">
+              <a:buNone/>
               <a:defRPr sz="1125" b="0">
                 <a:solidFill>
                   <a:srgbClr val="9BB0C9"/>
@@ -6066,6 +6040,7 @@
           <a:lstStyle xmlns:a="http://schemas.openxmlformats.org/drawingml/2006/main"/>
           <a:p xmlns:a="http://schemas.openxmlformats.org/drawingml/2006/main">
             <a:pPr algn="l">
+              <a:buNone/>
               <a:defRPr sz="1125" b="0">
                 <a:solidFill>
                   <a:srgbClr val="75D5C5"/>
@@ -6123,6 +6098,7 @@
           <a:lstStyle xmlns:a="http://schemas.openxmlformats.org/drawingml/2006/main"/>
           <a:p xmlns:a="http://schemas.openxmlformats.org/drawingml/2006/main">
             <a:pPr algn="l">
+              <a:buNone/>
               <a:defRPr sz="3150" b="1">
                 <a:solidFill>
                   <a:srgbClr val="E5EDF7"/>
@@ -6178,7 +6154,7 @@
       </p:sp>
       <p:graphicFrame>
         <p:nvGraphicFramePr>
-          <p:cNvPr id="13" name=""/>
+          <p:cNvPr id="15" name=""/>
           <p:cNvGraphicFramePr/>
           <p:nvPr/>
         </p:nvGraphicFramePr>
@@ -6763,6 +6739,7 @@
           <a:lstStyle xmlns:a="http://schemas.openxmlformats.org/drawingml/2006/main"/>
           <a:p xmlns:a="http://schemas.openxmlformats.org/drawingml/2006/main">
             <a:pPr algn="l">
+              <a:buNone/>
               <a:defRPr sz="2100" b="1">
                 <a:solidFill>
                   <a:srgbClr val="75D5C5"/>
@@ -6820,6 +6797,7 @@
           <a:lstStyle xmlns:a="http://schemas.openxmlformats.org/drawingml/2006/main"/>
           <a:p xmlns:a="http://schemas.openxmlformats.org/drawingml/2006/main">
             <a:pPr algn="l">
+              <a:buNone/>
               <a:defRPr sz="2100" b="0">
                 <a:solidFill>
                   <a:srgbClr val="E5EDF7"/>
@@ -6843,6 +6821,7 @@
           </a:p>
           <a:p xmlns:a="http://schemas.openxmlformats.org/drawingml/2006/main">
             <a:pPr algn="l">
+              <a:buNone/>
               <a:defRPr sz="2100" b="0">
                 <a:solidFill>
                   <a:srgbClr val="E5EDF7"/>
@@ -6900,6 +6879,7 @@
           <a:lstStyle xmlns:a="http://schemas.openxmlformats.org/drawingml/2006/main"/>
           <a:p xmlns:a="http://schemas.openxmlformats.org/drawingml/2006/main">
             <a:pPr algn="l">
+              <a:buNone/>
               <a:defRPr sz="1725" b="0">
                 <a:solidFill>
                   <a:srgbClr val="9BB0C9"/>
@@ -6957,6 +6937,7 @@
           <a:lstStyle xmlns:a="http://schemas.openxmlformats.org/drawingml/2006/main"/>
           <a:p xmlns:a="http://schemas.openxmlformats.org/drawingml/2006/main">
             <a:pPr algn="l">
+              <a:buNone/>
               <a:defRPr sz="975" b="0">
                 <a:solidFill>
                   <a:srgbClr val="9BB0C9"/>
@@ -7014,6 +6995,7 @@
           <a:lstStyle xmlns:a="http://schemas.openxmlformats.org/drawingml/2006/main"/>
           <a:p xmlns:a="http://schemas.openxmlformats.org/drawingml/2006/main">
             <a:pPr algn="r">
+              <a:buNone/>
               <a:defRPr sz="1125" b="0">
                 <a:solidFill>
                   <a:srgbClr val="9BB0C9"/>
@@ -7100,6 +7082,7 @@
           <a:lstStyle xmlns:a="http://schemas.openxmlformats.org/drawingml/2006/main"/>
           <a:p xmlns:a="http://schemas.openxmlformats.org/drawingml/2006/main">
             <a:pPr algn="l">
+              <a:buNone/>
               <a:defRPr sz="1125" b="0">
                 <a:solidFill>
                   <a:srgbClr val="75D5C5"/>
@@ -7157,6 +7140,7 @@
           <a:lstStyle xmlns:a="http://schemas.openxmlformats.org/drawingml/2006/main"/>
           <a:p xmlns:a="http://schemas.openxmlformats.org/drawingml/2006/main">
             <a:pPr algn="l">
+              <a:buNone/>
               <a:defRPr sz="3150" b="1">
                 <a:solidFill>
                   <a:srgbClr val="E5EDF7"/>
@@ -7212,7 +7196,7 @@
       </p:sp>
       <p:graphicFrame>
         <p:nvGraphicFramePr>
-          <p:cNvPr id="12" name=""/>
+          <p:cNvPr id="14" name=""/>
           <p:cNvGraphicFramePr/>
           <p:nvPr/>
         </p:nvGraphicFramePr>
@@ -7692,6 +7676,7 @@
           <a:lstStyle xmlns:a="http://schemas.openxmlformats.org/drawingml/2006/main"/>
           <a:p xmlns:a="http://schemas.openxmlformats.org/drawingml/2006/main">
             <a:pPr algn="l">
+              <a:buNone/>
               <a:defRPr sz="2100" b="1">
                 <a:solidFill>
                   <a:srgbClr val="75D5C5"/>
@@ -7749,6 +7734,7 @@
           <a:lstStyle xmlns:a="http://schemas.openxmlformats.org/drawingml/2006/main"/>
           <a:p xmlns:a="http://schemas.openxmlformats.org/drawingml/2006/main">
             <a:pPr algn="l">
+              <a:buNone/>
               <a:defRPr sz="2025" b="0">
                 <a:solidFill>
                   <a:srgbClr val="E5EDF7"/>
@@ -7772,6 +7758,7 @@
           </a:p>
           <a:p xmlns:a="http://schemas.openxmlformats.org/drawingml/2006/main">
             <a:pPr algn="l">
+              <a:buNone/>
               <a:defRPr sz="2025" b="0">
                 <a:solidFill>
                   <a:srgbClr val="E5EDF7"/>
@@ -7829,6 +7816,7 @@
           <a:lstStyle xmlns:a="http://schemas.openxmlformats.org/drawingml/2006/main"/>
           <a:p xmlns:a="http://schemas.openxmlformats.org/drawingml/2006/main">
             <a:pPr algn="l">
+              <a:buNone/>
               <a:defRPr sz="975" b="0">
                 <a:solidFill>
                   <a:srgbClr val="9BB0C9"/>
@@ -7886,6 +7874,7 @@
           <a:lstStyle xmlns:a="http://schemas.openxmlformats.org/drawingml/2006/main"/>
           <a:p xmlns:a="http://schemas.openxmlformats.org/drawingml/2006/main">
             <a:pPr algn="r">
+              <a:buNone/>
               <a:defRPr sz="1125" b="0">
                 <a:solidFill>
                   <a:srgbClr val="9BB0C9"/>
@@ -7972,6 +7961,7 @@
           <a:lstStyle xmlns:a="http://schemas.openxmlformats.org/drawingml/2006/main"/>
           <a:p xmlns:a="http://schemas.openxmlformats.org/drawingml/2006/main">
             <a:pPr algn="l">
+              <a:buNone/>
               <a:defRPr sz="1125" b="0">
                 <a:solidFill>
                   <a:srgbClr val="75D5C5"/>
@@ -8029,6 +8019,7 @@
           <a:lstStyle xmlns:a="http://schemas.openxmlformats.org/drawingml/2006/main"/>
           <a:p xmlns:a="http://schemas.openxmlformats.org/drawingml/2006/main">
             <a:pPr algn="l">
+              <a:buNone/>
               <a:defRPr sz="3150" b="1">
                 <a:solidFill>
                   <a:srgbClr val="E5EDF7"/>
@@ -8084,7 +8075,7 @@
       </p:sp>
       <p:graphicFrame>
         <p:nvGraphicFramePr>
-          <p:cNvPr id="12" name=""/>
+          <p:cNvPr id="14" name=""/>
           <p:cNvGraphicFramePr/>
           <p:nvPr/>
         </p:nvGraphicFramePr>
@@ -8539,6 +8530,7 @@
           <a:lstStyle xmlns:a="http://schemas.openxmlformats.org/drawingml/2006/main"/>
           <a:p xmlns:a="http://schemas.openxmlformats.org/drawingml/2006/main">
             <a:pPr algn="l">
+              <a:buNone/>
               <a:defRPr sz="2175" b="1">
                 <a:solidFill>
                   <a:srgbClr val="75D5C5"/>
@@ -8596,6 +8588,7 @@
           <a:lstStyle xmlns:a="http://schemas.openxmlformats.org/drawingml/2006/main"/>
           <a:p xmlns:a="http://schemas.openxmlformats.org/drawingml/2006/main">
             <a:pPr algn="l">
+              <a:buNone/>
               <a:defRPr sz="1725" b="0">
                 <a:solidFill>
                   <a:srgbClr val="9BB0C9"/>
@@ -8653,6 +8646,7 @@
           <a:lstStyle xmlns:a="http://schemas.openxmlformats.org/drawingml/2006/main"/>
           <a:p xmlns:a="http://schemas.openxmlformats.org/drawingml/2006/main">
             <a:pPr algn="l">
+              <a:buNone/>
               <a:defRPr sz="975" b="0">
                 <a:solidFill>
                   <a:srgbClr val="9BB0C9"/>
@@ -8710,6 +8704,7 @@
           <a:lstStyle xmlns:a="http://schemas.openxmlformats.org/drawingml/2006/main"/>
           <a:p xmlns:a="http://schemas.openxmlformats.org/drawingml/2006/main">
             <a:pPr algn="r">
+              <a:buNone/>
               <a:defRPr sz="1125" b="0">
                 <a:solidFill>
                   <a:srgbClr val="9BB0C9"/>
@@ -8796,6 +8791,7 @@
           <a:lstStyle xmlns:a="http://schemas.openxmlformats.org/drawingml/2006/main"/>
           <a:p xmlns:a="http://schemas.openxmlformats.org/drawingml/2006/main">
             <a:pPr algn="l">
+              <a:buNone/>
               <a:defRPr sz="1125" b="0">
                 <a:solidFill>
                   <a:srgbClr val="75D5C5"/>
@@ -8853,6 +8849,7 @@
           <a:lstStyle xmlns:a="http://schemas.openxmlformats.org/drawingml/2006/main"/>
           <a:p xmlns:a="http://schemas.openxmlformats.org/drawingml/2006/main">
             <a:pPr algn="l">
+              <a:buNone/>
               <a:defRPr sz="3150" b="1">
                 <a:solidFill>
                   <a:srgbClr val="E5EDF7"/>
@@ -8908,7 +8905,7 @@
       </p:sp>
       <p:graphicFrame>
         <p:nvGraphicFramePr>
-          <p:cNvPr id="12" name=""/>
+          <p:cNvPr id="14" name=""/>
           <p:cNvGraphicFramePr/>
           <p:nvPr/>
         </p:nvGraphicFramePr>
@@ -9443,6 +9440,7 @@
           <a:lstStyle xmlns:a="http://schemas.openxmlformats.org/drawingml/2006/main"/>
           <a:p xmlns:a="http://schemas.openxmlformats.org/drawingml/2006/main">
             <a:pPr algn="l">
+              <a:buNone/>
               <a:defRPr sz="1875" b="0">
                 <a:solidFill>
                   <a:srgbClr val="75D5C5"/>
@@ -9500,6 +9498,7 @@
           <a:lstStyle xmlns:a="http://schemas.openxmlformats.org/drawingml/2006/main"/>
           <a:p xmlns:a="http://schemas.openxmlformats.org/drawingml/2006/main">
             <a:pPr algn="l">
+              <a:buNone/>
               <a:defRPr sz="1800" b="0">
                 <a:solidFill>
                   <a:srgbClr val="9BB0C9"/>
@@ -9557,6 +9556,7 @@
           <a:lstStyle xmlns:a="http://schemas.openxmlformats.org/drawingml/2006/main"/>
           <a:p xmlns:a="http://schemas.openxmlformats.org/drawingml/2006/main">
             <a:pPr algn="l">
+              <a:buNone/>
               <a:defRPr sz="975" b="0">
                 <a:solidFill>
                   <a:srgbClr val="9BB0C9"/>
@@ -9614,6 +9614,7 @@
           <a:lstStyle xmlns:a="http://schemas.openxmlformats.org/drawingml/2006/main"/>
           <a:p xmlns:a="http://schemas.openxmlformats.org/drawingml/2006/main">
             <a:pPr algn="r">
+              <a:buNone/>
               <a:defRPr sz="1125" b="0">
                 <a:solidFill>
                   <a:srgbClr val="9BB0C9"/>
@@ -9700,6 +9701,7 @@
           <a:lstStyle xmlns:a="http://schemas.openxmlformats.org/drawingml/2006/main"/>
           <a:p xmlns:a="http://schemas.openxmlformats.org/drawingml/2006/main">
             <a:pPr algn="l">
+              <a:buNone/>
               <a:defRPr sz="1125" b="0">
                 <a:solidFill>
                   <a:srgbClr val="75D5C5"/>
@@ -9757,6 +9759,7 @@
           <a:lstStyle xmlns:a="http://schemas.openxmlformats.org/drawingml/2006/main"/>
           <a:p xmlns:a="http://schemas.openxmlformats.org/drawingml/2006/main">
             <a:pPr algn="l">
+              <a:buNone/>
               <a:defRPr sz="3150" b="1">
                 <a:solidFill>
                   <a:srgbClr val="E5EDF7"/>
@@ -9844,6 +9847,7 @@
           <a:lstStyle xmlns:a="http://schemas.openxmlformats.org/drawingml/2006/main"/>
           <a:p xmlns:a="http://schemas.openxmlformats.org/drawingml/2006/main">
             <a:pPr algn="l">
+              <a:buNone/>
               <a:defRPr sz="2625" b="1">
                 <a:solidFill>
                   <a:srgbClr val="75D5C5"/>
@@ -9901,6 +9905,7 @@
           <a:lstStyle xmlns:a="http://schemas.openxmlformats.org/drawingml/2006/main"/>
           <a:p xmlns:a="http://schemas.openxmlformats.org/drawingml/2006/main">
             <a:pPr algn="l">
+              <a:buNone/>
               <a:defRPr sz="2100" b="0">
                 <a:solidFill>
                   <a:srgbClr val="E5EDF7"/>
@@ -9988,6 +9993,7 @@
           <a:lstStyle xmlns:a="http://schemas.openxmlformats.org/drawingml/2006/main"/>
           <a:p xmlns:a="http://schemas.openxmlformats.org/drawingml/2006/main">
             <a:pPr algn="l">
+              <a:buNone/>
               <a:defRPr sz="2400" b="1">
                 <a:solidFill>
                   <a:srgbClr val="E9B675"/>
@@ -10045,6 +10051,7 @@
           <a:lstStyle xmlns:a="http://schemas.openxmlformats.org/drawingml/2006/main"/>
           <a:p xmlns:a="http://schemas.openxmlformats.org/drawingml/2006/main">
             <a:pPr algn="l">
+              <a:buNone/>
               <a:defRPr sz="2025" b="0">
                 <a:solidFill>
                   <a:srgbClr val="E5EDF7"/>
@@ -10068,6 +10075,7 @@
           </a:p>
           <a:p xmlns:a="http://schemas.openxmlformats.org/drawingml/2006/main">
             <a:pPr algn="l">
+              <a:buNone/>
               <a:defRPr sz="2025" b="0">
                 <a:solidFill>
                   <a:srgbClr val="E5EDF7"/>
@@ -10125,6 +10133,7 @@
           <a:lstStyle xmlns:a="http://schemas.openxmlformats.org/drawingml/2006/main"/>
           <a:p xmlns:a="http://schemas.openxmlformats.org/drawingml/2006/main">
             <a:pPr algn="l">
+              <a:buNone/>
               <a:defRPr sz="975" b="0">
                 <a:solidFill>
                   <a:srgbClr val="9BB0C9"/>
@@ -10182,6 +10191,7 @@
           <a:lstStyle xmlns:a="http://schemas.openxmlformats.org/drawingml/2006/main"/>
           <a:p xmlns:a="http://schemas.openxmlformats.org/drawingml/2006/main">
             <a:pPr algn="r">
+              <a:buNone/>
               <a:defRPr sz="1125" b="0">
                 <a:solidFill>
                   <a:srgbClr val="9BB0C9"/>
@@ -10268,6 +10278,7 @@
           <a:lstStyle xmlns:a="http://schemas.openxmlformats.org/drawingml/2006/main"/>
           <a:p xmlns:a="http://schemas.openxmlformats.org/drawingml/2006/main">
             <a:pPr algn="l">
+              <a:buNone/>
               <a:defRPr sz="1125" b="0">
                 <a:solidFill>
                   <a:srgbClr val="75D5C5"/>
@@ -10325,6 +10336,7 @@
           <a:lstStyle xmlns:a="http://schemas.openxmlformats.org/drawingml/2006/main"/>
           <a:p xmlns:a="http://schemas.openxmlformats.org/drawingml/2006/main">
             <a:pPr algn="l">
+              <a:buNone/>
               <a:defRPr sz="3150" b="1">
                 <a:solidFill>
                   <a:srgbClr val="E5EDF7"/>
@@ -10380,7 +10392,7 @@
       </p:sp>
       <p:graphicFrame>
         <p:nvGraphicFramePr>
-          <p:cNvPr id="12" name=""/>
+          <p:cNvPr id="14" name=""/>
           <p:cNvGraphicFramePr/>
           <p:nvPr/>
         </p:nvGraphicFramePr>
@@ -11072,6 +11084,7 @@
           <a:lstStyle xmlns:a="http://schemas.openxmlformats.org/drawingml/2006/main"/>
           <a:p xmlns:a="http://schemas.openxmlformats.org/drawingml/2006/main">
             <a:pPr algn="l">
+              <a:buNone/>
               <a:defRPr sz="1875" b="0">
                 <a:solidFill>
                   <a:srgbClr val="75D5C5"/>
@@ -11129,6 +11142,7 @@
           <a:lstStyle xmlns:a="http://schemas.openxmlformats.org/drawingml/2006/main"/>
           <a:p xmlns:a="http://schemas.openxmlformats.org/drawingml/2006/main">
             <a:pPr algn="l">
+              <a:buNone/>
               <a:defRPr sz="1650" b="0">
                 <a:solidFill>
                   <a:srgbClr val="9BB0C9"/>
@@ -11152,6 +11166,7 @@
           </a:p>
           <a:p xmlns:a="http://schemas.openxmlformats.org/drawingml/2006/main">
             <a:pPr algn="l">
+              <a:buNone/>
               <a:defRPr sz="1650" b="0">
                 <a:solidFill>
                   <a:srgbClr val="9BB0C9"/>
@@ -11209,6 +11224,7 @@
           <a:lstStyle xmlns:a="http://schemas.openxmlformats.org/drawingml/2006/main"/>
           <a:p xmlns:a="http://schemas.openxmlformats.org/drawingml/2006/main">
             <a:pPr algn="l">
+              <a:buNone/>
               <a:defRPr sz="975" b="0">
                 <a:solidFill>
                   <a:srgbClr val="9BB0C9"/>
@@ -11266,6 +11282,7 @@
           <a:lstStyle xmlns:a="http://schemas.openxmlformats.org/drawingml/2006/main"/>
           <a:p xmlns:a="http://schemas.openxmlformats.org/drawingml/2006/main">
             <a:pPr algn="r">
+              <a:buNone/>
               <a:defRPr sz="1125" b="0">
                 <a:solidFill>
                   <a:srgbClr val="9BB0C9"/>

</xml_diff>

<commit_message>
Add causal live engineering F replay and updated mechanism slides
</commit_message>
<xml_diff>
--- a/downloads/energy-campus-v3.2.pptx
+++ b/downloads/energy-campus-v3.2.pptx
@@ -2,24 +2,24 @@
 <file path=ppt/presentation.xml><?xml version="1.0" encoding="utf-8"?>
 <p:presentation xmlns:p="http://schemas.openxmlformats.org/presentationml/2006/main">
   <p:sldMasterIdLst>
-    <p:sldMasterId xmlns:r="http://schemas.openxmlformats.org/officeDocument/2006/relationships" id="2147483648" r:id="R1bc19c15a1d8461d"/>
+    <p:sldMasterId xmlns:r="http://schemas.openxmlformats.org/officeDocument/2006/relationships" id="2147483648" r:id="R7f342cf0a5bc48bb"/>
   </p:sldMasterIdLst>
   <p:notesMasterIdLst>
-    <p:notesMasterId xmlns:r="http://schemas.openxmlformats.org/officeDocument/2006/relationships" r:id="R32350082cec34897"/>
+    <p:notesMasterId xmlns:r="http://schemas.openxmlformats.org/officeDocument/2006/relationships" r:id="Racaa9c0c0cb74519"/>
   </p:notesMasterIdLst>
   <p:sldIdLst>
-    <p:sldId xmlns:r="http://schemas.openxmlformats.org/officeDocument/2006/relationships" id="256" r:id="R85bd6676771d4bfb"/>
-    <p:sldId xmlns:r="http://schemas.openxmlformats.org/officeDocument/2006/relationships" id="257" r:id="R4e55cbf3fc7e4be6"/>
-    <p:sldId xmlns:r="http://schemas.openxmlformats.org/officeDocument/2006/relationships" id="258" r:id="R6a17c84776534ee9"/>
-    <p:sldId xmlns:r="http://schemas.openxmlformats.org/officeDocument/2006/relationships" id="259" r:id="Ree753a7185814788"/>
-    <p:sldId xmlns:r="http://schemas.openxmlformats.org/officeDocument/2006/relationships" id="260" r:id="R3c63f40bcd324ead"/>
-    <p:sldId xmlns:r="http://schemas.openxmlformats.org/officeDocument/2006/relationships" id="261" r:id="R7df4c2dd30984645"/>
-    <p:sldId xmlns:r="http://schemas.openxmlformats.org/officeDocument/2006/relationships" id="262" r:id="R2e2df69fd7ef49e6"/>
-    <p:sldId xmlns:r="http://schemas.openxmlformats.org/officeDocument/2006/relationships" id="263" r:id="Rf26adbe5da684e0c"/>
-    <p:sldId xmlns:r="http://schemas.openxmlformats.org/officeDocument/2006/relationships" id="264" r:id="Rf633fadbb9664223"/>
-    <p:sldId xmlns:r="http://schemas.openxmlformats.org/officeDocument/2006/relationships" id="265" r:id="Rd5bbb83a342e4d60"/>
-    <p:sldId xmlns:r="http://schemas.openxmlformats.org/officeDocument/2006/relationships" id="266" r:id="R8a69254038474559"/>
-    <p:sldId xmlns:r="http://schemas.openxmlformats.org/officeDocument/2006/relationships" id="267" r:id="R476704f16cc7420e"/>
+    <p:sldId xmlns:r="http://schemas.openxmlformats.org/officeDocument/2006/relationships" id="256" r:id="Redd6db1e3cf1426a"/>
+    <p:sldId xmlns:r="http://schemas.openxmlformats.org/officeDocument/2006/relationships" id="257" r:id="Re7652c63331542dd"/>
+    <p:sldId xmlns:r="http://schemas.openxmlformats.org/officeDocument/2006/relationships" id="258" r:id="Rbbbe05cc1f454e3d"/>
+    <p:sldId xmlns:r="http://schemas.openxmlformats.org/officeDocument/2006/relationships" id="259" r:id="R5e451add9f394896"/>
+    <p:sldId xmlns:r="http://schemas.openxmlformats.org/officeDocument/2006/relationships" id="260" r:id="R89f0e9bb598e4cd7"/>
+    <p:sldId xmlns:r="http://schemas.openxmlformats.org/officeDocument/2006/relationships" id="261" r:id="R3e7b7d9a380a481a"/>
+    <p:sldId xmlns:r="http://schemas.openxmlformats.org/officeDocument/2006/relationships" id="262" r:id="R1f773828df474dbc"/>
+    <p:sldId xmlns:r="http://schemas.openxmlformats.org/officeDocument/2006/relationships" id="263" r:id="R3cc3d4f65fe44899"/>
+    <p:sldId xmlns:r="http://schemas.openxmlformats.org/officeDocument/2006/relationships" id="264" r:id="R1b5b841986d640af"/>
+    <p:sldId xmlns:r="http://schemas.openxmlformats.org/officeDocument/2006/relationships" id="265" r:id="R0f33a47c48cd4168"/>
+    <p:sldId xmlns:r="http://schemas.openxmlformats.org/officeDocument/2006/relationships" id="266" r:id="R5e76d5c0de744bb1"/>
+    <p:sldId xmlns:r="http://schemas.openxmlformats.org/officeDocument/2006/relationships" id="267" r:id="R26b4db0936084406"/>
   </p:sldIdLst>
   <p:sldSz cx="12192000" cy="6858000"/>
   <p:notesSz cx="6858000" cy="9144000"/>
@@ -596,6 +596,11 @@
               <a:t>SimBench https://simbench.de/en/download/datasets/ ODbL1.0 / DbCL1.0。德国原始2016曲线按连续时段映射到中国时区2026仿真场景，非中国园区实测。公开回放 https://jinyh.github.io/energy-campus/ 。月度示范与72小时RSI研究分别记账。</a:t>
             </a:r>
           </a:p>
+          <a:p xmlns:a="http://schemas.openxmlformats.org/drawingml/2006/main">
+            <a:r>
+              <a:t>当前固定在线工程 F：cf6c589c3f461ec4，触发时刻 2026-06-02 08:00 Asia/Shanghai。MPC 108174.15 元；情景 MPC 108295.91 元，均合格。每方法 2880 AC / 2784 MILP。该程序由人工固定，不包含候选晋升、G 演化或继承优势。原研究停止与原工具对照不变；不能将不同程序与情景工具的费用差归因为 RSI。证据 validation/live-f-2026-10-08/acceptance.json SHA256 a026156041af5b7b22663b18c9fd58e4979a2cef80c6ef4113bba78f2376b8cb</a:t>
+            </a:r>
+          </a:p>
         </p:txBody>
       </p:sp>
       <p:sp>
@@ -768,7 +773,7 @@
           <a:lstStyle xmlns:a="http://schemas.openxmlformats.org/drawingml/2006/main"/>
           <a:p xmlns:a="http://schemas.openxmlformats.org/drawingml/2006/main">
             <a:r>
-              <a:t>当前界面截图：validation/visual-recovery-2026-10-07/comparison-1366-final.png SHA256 9317ce9ab73feebc55d04a6ed0eb5971e77c36477ebd99840e5f5f202ffff878。仅更新界面截图；原有真实成本与研究停止结论保持。视觉仍未达到参考站标准。SimBench 德国历史来源，非中国园区实测。</a:t>
+              <a:t>当前界面截图：validation/live-f-2026-10-08/charging-eight-chart-1366-final.png SHA256 a60ded41a7dd178a363df0b0cb2d72ec1b1ba007897f6f5bfa6a6e4c050e53d9。在线工程 F 月度核验已完成；原有真实成本与研究停止结论保持。视觉仍未达到参考站标准。SimBench 德国历史来源，非中国园区实测。</a:t>
             </a:r>
           </a:p>
         </p:txBody>
@@ -1259,6 +1264,11 @@
           <a:p xmlns:a="http://schemas.openxmlformats.org/drawingml/2006/main">
             <a:r>
               <a:t>SimBench https://simbench.de/en/download/datasets/ ODbL1.0 / DbCL1.0。德国原始2016曲线按连续时段映射到中国时区2026仿真场景，非中国园区实测。公开回放 https://jinyh.github.io/energy-campus/ 。月度示范与72小时RSI研究分别记账。</a:t>
+            </a:r>
+          </a:p>
+          <a:p xmlns:a="http://schemas.openxmlformats.org/drawingml/2006/main">
+            <a:r>
+              <a:t>当前固定在线工程 F：cf6c589c3f461ec4，触发时刻 2026-06-02 08:00 Asia/Shanghai。MPC 108174.15 元；情景 MPC 108295.91 元，均合格。每方法 2880 AC / 2784 MILP。该程序由人工固定，不包含候选晋升、G 演化或继承优势。原研究停止与原工具对照不变；不能将不同程序与情景工具的费用差归因为 RSI。证据 validation/live-f-2026-10-08/acceptance.json SHA256 a026156041af5b7b22663b18c9fd58e4979a2cef80c6ef4113bba78f2376b8cb</a:t>
             </a:r>
           </a:p>
         </p:txBody>
@@ -1641,7 +1651,7 @@
   </p:cSld>
   <p:clrMap bg1="lt1" tx1="dk1" bg2="lt2" tx2="dk2" accent1="accent1" accent2="accent2" accent3="accent3" accent4="accent4" accent5="accent5" accent6="accent6" hlink="hlink" folHlink="folHlink"/>
   <p:sldLayoutIdLst>
-    <p:sldLayoutId xmlns:r="http://schemas.openxmlformats.org/officeDocument/2006/relationships" id="2147483649" r:id="R1bc4450b69704f4b"/>
+    <p:sldLayoutId xmlns:r="http://schemas.openxmlformats.org/officeDocument/2006/relationships" id="2147483649" r:id="Re26d2e01fd474203"/>
   </p:sldLayoutIdLst>
   <p:txStyles>
     <p:titleStyle>
@@ -2444,7 +2454,7 @@
                 <a:ea typeface="Hiragino Sans GB"/>
                 <a:cs typeface="Hiragino Sans GB"/>
               </a:rPr>
-              <a:t>连续整月回放、同口径方案比较、可追溯程序记录</a:t>
+              <a:t>连续整月回放、在线工程修复、可追溯程序记录</a:t>
             </a:r>
           </a:p>
         </p:txBody>
@@ -2916,7 +2926,13 @@
       </p:sp>
       <p:graphicFrame>
         <p:nvGraphicFramePr>
-          <p:cNvPr id="16" name=""/>
+          <p:cNvPr id="16" name="">
+            <a:extLst xmlns:a="http://schemas.openxmlformats.org/drawingml/2006/main">
+              <a:ext uri="{FF2B5EF4-FFF2-40B4-BE49-F238E27FC236}">
+                <a16:creationId xmlns:a16="http://schemas.microsoft.com/office/drawing/2014/main" id="{8E4F639D-3BA2-40B5-B21C-6843C19DF5A4}"/>
+              </a:ext>
+            </a:extLst>
+          </p:cNvPr>
           <p:cNvGraphicFramePr/>
           <p:nvPr/>
         </p:nvGraphicFramePr>
@@ -3317,7 +3333,7 @@
                 <a:ea typeface="Hiragino Sans GB"/>
                 <a:cs typeface="Hiragino Sans GB"/>
               </a:rPr>
-              <a:t>偏差门槛描述预测误差，不能直接判断设备故障。当前场景不含动态降额。</a:t>
+              <a:t>在线 F 在同一时刻切换校正并加密重排；动态降额未实现</a:t>
             </a:r>
           </a:p>
         </p:txBody>
@@ -3615,7 +3631,13 @@
       </p:sp>
       <p:graphicFrame>
         <p:nvGraphicFramePr>
-          <p:cNvPr id="15" name=""/>
+          <p:cNvPr id="15" name="">
+            <a:extLst xmlns:a="http://schemas.openxmlformats.org/drawingml/2006/main">
+              <a:ext uri="{FF2B5EF4-FFF2-40B4-BE49-F238E27FC236}">
+                <a16:creationId xmlns:a16="http://schemas.microsoft.com/office/drawing/2014/main" id="{3EF3547E-6A5B-4307-A46C-E9C97198596A}"/>
+              </a:ext>
+            </a:extLst>
+          </p:cNvPr>
           <p:cNvGraphicFramePr/>
           <p:nvPr/>
         </p:nvGraphicFramePr>
@@ -4657,14 +4679,20 @@
       </p:sp>
       <p:pic>
         <p:nvPicPr>
-          <p:cNvPr id="13" name=""/>
+          <p:cNvPr id="13" name="">
+            <a:extLst xmlns:a="http://schemas.openxmlformats.org/drawingml/2006/main">
+              <a:ext uri="{FF2B5EF4-FFF2-40B4-BE49-F238E27FC236}">
+                <a16:creationId xmlns:a16="http://schemas.microsoft.com/office/drawing/2014/main" id="{186E3259-ECD1-4BDC-AF2E-BE91D6FAD5D5}"/>
+              </a:ext>
+            </a:extLst>
+          </p:cNvPr>
           <p:cNvPicPr>
             <a:picLocks xmlns:a="http://schemas.openxmlformats.org/drawingml/2006/main" noChangeAspect="1"/>
           </p:cNvPicPr>
           <p:nvPr/>
         </p:nvPicPr>
         <p:blipFill>
-          <a:blip xmlns:r="http://schemas.openxmlformats.org/officeDocument/2006/relationships" xmlns:a="http://schemas.openxmlformats.org/drawingml/2006/main" r:embed="Rc6115de304ac444c"/>
+          <a:blip xmlns:r="http://schemas.openxmlformats.org/officeDocument/2006/relationships" xmlns:a="http://schemas.openxmlformats.org/drawingml/2006/main" r:embed="Rb0d9d23d746d4287"/>
           <a:srcRect xmlns:a="http://schemas.openxmlformats.org/drawingml/2006/main" l="0" t="0" r="0" b="0"/>
           <a:stretch xmlns:a="http://schemas.openxmlformats.org/drawingml/2006/main">
             <a:fillRect l="0" t="0" r="0" b="0"/>
@@ -4733,7 +4761,7 @@
                 <a:ea typeface="Hiragino Sans GB"/>
                 <a:cs typeface="Hiragino Sans GB"/>
               </a:rPr>
-              <a:t>在线：六月日常和持续偏移、异常证据、实际工具比较；本机：数据与重算</a:t>
+              <a:t>在线：六月回放、逐时工程 F 与异常证据；本机：参数、导入与复算</a:t>
             </a:r>
           </a:p>
         </p:txBody>
@@ -5031,14 +5059,20 @@
       </p:sp>
       <p:pic>
         <p:nvPicPr>
-          <p:cNvPr id="13" name=""/>
+          <p:cNvPr id="13" name="">
+            <a:extLst xmlns:a="http://schemas.openxmlformats.org/drawingml/2006/main">
+              <a:ext uri="{FF2B5EF4-FFF2-40B4-BE49-F238E27FC236}">
+                <a16:creationId xmlns:a16="http://schemas.microsoft.com/office/drawing/2014/main" id="{A507D5F3-FC6D-4D11-97B2-81D124802A11}"/>
+              </a:ext>
+            </a:extLst>
+          </p:cNvPr>
           <p:cNvPicPr>
             <a:picLocks xmlns:a="http://schemas.openxmlformats.org/drawingml/2006/main" noChangeAspect="1"/>
           </p:cNvPicPr>
           <p:nvPr/>
         </p:nvPicPr>
         <p:blipFill>
-          <a:blip xmlns:r="http://schemas.openxmlformats.org/officeDocument/2006/relationships" xmlns:a="http://schemas.openxmlformats.org/drawingml/2006/main" r:embed="Rfacc722decc346e6"/>
+          <a:blip xmlns:r="http://schemas.openxmlformats.org/officeDocument/2006/relationships" xmlns:a="http://schemas.openxmlformats.org/drawingml/2006/main" r:embed="R089688ecdd4844a8"/>
           <a:srcRect xmlns:a="http://schemas.openxmlformats.org/drawingml/2006/main" l="0" t="2306" r="0" b="2306"/>
           <a:stretch xmlns:a="http://schemas.openxmlformats.org/drawingml/2006/main">
             <a:fillRect l="0" t="0" r="0" b="0"/>
@@ -5405,7 +5439,13 @@
       </p:sp>
       <p:graphicFrame>
         <p:nvGraphicFramePr>
-          <p:cNvPr id="13" name=""/>
+          <p:cNvPr id="13" name="">
+            <a:extLst xmlns:a="http://schemas.openxmlformats.org/drawingml/2006/main">
+              <a:ext uri="{FF2B5EF4-FFF2-40B4-BE49-F238E27FC236}">
+                <a16:creationId xmlns:a16="http://schemas.microsoft.com/office/drawing/2014/main" id="{6C1F0EF7-D9B6-406F-BA4C-4EFF488AC487}"/>
+              </a:ext>
+            </a:extLst>
+          </p:cNvPr>
           <p:cNvGraphicFramePr/>
           <p:nvPr/>
         </p:nvGraphicFramePr>
@@ -6154,7 +6194,13 @@
       </p:sp>
       <p:graphicFrame>
         <p:nvGraphicFramePr>
-          <p:cNvPr id="15" name=""/>
+          <p:cNvPr id="15" name="">
+            <a:extLst xmlns:a="http://schemas.openxmlformats.org/drawingml/2006/main">
+              <a:ext uri="{FF2B5EF4-FFF2-40B4-BE49-F238E27FC236}">
+                <a16:creationId xmlns:a16="http://schemas.microsoft.com/office/drawing/2014/main" id="{04FD8593-AAE5-4AF9-A54D-8AD97A509992}"/>
+              </a:ext>
+            </a:extLst>
+          </p:cNvPr>
           <p:cNvGraphicFramePr/>
           <p:nvPr/>
         </p:nvGraphicFramePr>
@@ -7196,7 +7242,13 @@
       </p:sp>
       <p:graphicFrame>
         <p:nvGraphicFramePr>
-          <p:cNvPr id="14" name=""/>
+          <p:cNvPr id="14" name="">
+            <a:extLst xmlns:a="http://schemas.openxmlformats.org/drawingml/2006/main">
+              <a:ext uri="{FF2B5EF4-FFF2-40B4-BE49-F238E27FC236}">
+                <a16:creationId xmlns:a16="http://schemas.microsoft.com/office/drawing/2014/main" id="{C322D375-6B8E-4659-80C7-A539B805D743}"/>
+              </a:ext>
+            </a:extLst>
+          </p:cNvPr>
           <p:cNvGraphicFramePr/>
           <p:nvPr/>
         </p:nvGraphicFramePr>
@@ -8075,7 +8127,13 @@
       </p:sp>
       <p:graphicFrame>
         <p:nvGraphicFramePr>
-          <p:cNvPr id="14" name=""/>
+          <p:cNvPr id="14" name="">
+            <a:extLst xmlns:a="http://schemas.openxmlformats.org/drawingml/2006/main">
+              <a:ext uri="{FF2B5EF4-FFF2-40B4-BE49-F238E27FC236}">
+                <a16:creationId xmlns:a16="http://schemas.microsoft.com/office/drawing/2014/main" id="{26B85A44-64DC-4541-9788-06AA837E3008}"/>
+              </a:ext>
+            </a:extLst>
+          </p:cNvPr>
           <p:cNvGraphicFramePr/>
           <p:nvPr/>
         </p:nvGraphicFramePr>
@@ -8401,7 +8459,7 @@
                           <a:ea typeface="Hiragino Sans GB"/>
                           <a:cs typeface="Hiragino Sans GB"/>
                         </a:rPr>
-                        <a:t>当前在基线后组织试验</a:t>
+                        <a:t>在线工程 F 已执行；程序固定</a:t>
                       </a:r>
                     </a:p>
                   </a:txBody>
@@ -8905,7 +8963,13 @@
       </p:sp>
       <p:graphicFrame>
         <p:nvGraphicFramePr>
-          <p:cNvPr id="14" name=""/>
+          <p:cNvPr id="14" name="">
+            <a:extLst xmlns:a="http://schemas.openxmlformats.org/drawingml/2006/main">
+              <a:ext uri="{FF2B5EF4-FFF2-40B4-BE49-F238E27FC236}">
+                <a16:creationId xmlns:a16="http://schemas.microsoft.com/office/drawing/2014/main" id="{55619B90-3ED5-413E-B84B-395EF07CCC9D}"/>
+              </a:ext>
+            </a:extLst>
+          </p:cNvPr>
           <p:cNvGraphicFramePr/>
           <p:nvPr/>
         </p:nvGraphicFramePr>
@@ -10392,7 +10456,13 @@
       </p:sp>
       <p:graphicFrame>
         <p:nvGraphicFramePr>
-          <p:cNvPr id="14" name=""/>
+          <p:cNvPr id="14" name="">
+            <a:extLst xmlns:a="http://schemas.openxmlformats.org/drawingml/2006/main">
+              <a:ext uri="{FF2B5EF4-FFF2-40B4-BE49-F238E27FC236}">
+                <a16:creationId xmlns:a16="http://schemas.microsoft.com/office/drawing/2014/main" id="{F82D058B-B5BB-4EF4-8E01-46B1BD460E04}"/>
+              </a:ext>
+            </a:extLst>
+          </p:cNvPr>
           <p:cNvGraphicFramePr/>
           <p:nvPr/>
         </p:nvGraphicFramePr>

</xml_diff>

<commit_message>
Refine campus equipment and building assets; refresh presentation screenshots
</commit_message>
<xml_diff>
--- a/downloads/energy-campus-v3.2.pptx
+++ b/downloads/energy-campus-v3.2.pptx
@@ -2,24 +2,24 @@
 <file path=ppt/presentation.xml><?xml version="1.0" encoding="utf-8"?>
 <p:presentation xmlns:p="http://schemas.openxmlformats.org/presentationml/2006/main">
   <p:sldMasterIdLst>
-    <p:sldMasterId xmlns:r="http://schemas.openxmlformats.org/officeDocument/2006/relationships" id="2147483648" r:id="R7f342cf0a5bc48bb"/>
+    <p:sldMasterId xmlns:r="http://schemas.openxmlformats.org/officeDocument/2006/relationships" id="2147483648" r:id="Rc8ce06397c5e44d1"/>
   </p:sldMasterIdLst>
   <p:notesMasterIdLst>
-    <p:notesMasterId xmlns:r="http://schemas.openxmlformats.org/officeDocument/2006/relationships" r:id="Racaa9c0c0cb74519"/>
+    <p:notesMasterId xmlns:r="http://schemas.openxmlformats.org/officeDocument/2006/relationships" r:id="R51b98a70e84444ed"/>
   </p:notesMasterIdLst>
   <p:sldIdLst>
-    <p:sldId xmlns:r="http://schemas.openxmlformats.org/officeDocument/2006/relationships" id="256" r:id="Redd6db1e3cf1426a"/>
-    <p:sldId xmlns:r="http://schemas.openxmlformats.org/officeDocument/2006/relationships" id="257" r:id="Re7652c63331542dd"/>
-    <p:sldId xmlns:r="http://schemas.openxmlformats.org/officeDocument/2006/relationships" id="258" r:id="Rbbbe05cc1f454e3d"/>
-    <p:sldId xmlns:r="http://schemas.openxmlformats.org/officeDocument/2006/relationships" id="259" r:id="R5e451add9f394896"/>
-    <p:sldId xmlns:r="http://schemas.openxmlformats.org/officeDocument/2006/relationships" id="260" r:id="R89f0e9bb598e4cd7"/>
-    <p:sldId xmlns:r="http://schemas.openxmlformats.org/officeDocument/2006/relationships" id="261" r:id="R3e7b7d9a380a481a"/>
-    <p:sldId xmlns:r="http://schemas.openxmlformats.org/officeDocument/2006/relationships" id="262" r:id="R1f773828df474dbc"/>
-    <p:sldId xmlns:r="http://schemas.openxmlformats.org/officeDocument/2006/relationships" id="263" r:id="R3cc3d4f65fe44899"/>
-    <p:sldId xmlns:r="http://schemas.openxmlformats.org/officeDocument/2006/relationships" id="264" r:id="R1b5b841986d640af"/>
-    <p:sldId xmlns:r="http://schemas.openxmlformats.org/officeDocument/2006/relationships" id="265" r:id="R0f33a47c48cd4168"/>
-    <p:sldId xmlns:r="http://schemas.openxmlformats.org/officeDocument/2006/relationships" id="266" r:id="R5e76d5c0de744bb1"/>
-    <p:sldId xmlns:r="http://schemas.openxmlformats.org/officeDocument/2006/relationships" id="267" r:id="R26b4db0936084406"/>
+    <p:sldId xmlns:r="http://schemas.openxmlformats.org/officeDocument/2006/relationships" id="256" r:id="R196234dc87ed4f23"/>
+    <p:sldId xmlns:r="http://schemas.openxmlformats.org/officeDocument/2006/relationships" id="257" r:id="Re925a38428d249f1"/>
+    <p:sldId xmlns:r="http://schemas.openxmlformats.org/officeDocument/2006/relationships" id="258" r:id="R396cadd5e0eb4698"/>
+    <p:sldId xmlns:r="http://schemas.openxmlformats.org/officeDocument/2006/relationships" id="259" r:id="Rc04b00c4cc684bda"/>
+    <p:sldId xmlns:r="http://schemas.openxmlformats.org/officeDocument/2006/relationships" id="260" r:id="Ra6179f84bc6246af"/>
+    <p:sldId xmlns:r="http://schemas.openxmlformats.org/officeDocument/2006/relationships" id="261" r:id="Rd52ba8ce87224daf"/>
+    <p:sldId xmlns:r="http://schemas.openxmlformats.org/officeDocument/2006/relationships" id="262" r:id="R536d132b983442b9"/>
+    <p:sldId xmlns:r="http://schemas.openxmlformats.org/officeDocument/2006/relationships" id="263" r:id="Rabf95570187a46f9"/>
+    <p:sldId xmlns:r="http://schemas.openxmlformats.org/officeDocument/2006/relationships" id="264" r:id="R1ffa9284acc04f40"/>
+    <p:sldId xmlns:r="http://schemas.openxmlformats.org/officeDocument/2006/relationships" id="265" r:id="Re852fd5ddb174e8f"/>
+    <p:sldId xmlns:r="http://schemas.openxmlformats.org/officeDocument/2006/relationships" id="266" r:id="R504308d9f3d14cdd"/>
+    <p:sldId xmlns:r="http://schemas.openxmlformats.org/officeDocument/2006/relationships" id="267" r:id="R1c4bc5b528e34be3"/>
   </p:sldIdLst>
   <p:sldSz cx="12192000" cy="6858000"/>
   <p:notesSz cx="6858000" cy="9144000"/>
@@ -773,7 +773,7 @@
           <a:lstStyle xmlns:a="http://schemas.openxmlformats.org/drawingml/2006/main"/>
           <a:p xmlns:a="http://schemas.openxmlformats.org/drawingml/2006/main">
             <a:r>
-              <a:t>当前界面截图：validation/live-f-2026-10-08/charging-eight-chart-1366-final.png SHA256 a60ded41a7dd178a363df0b0cb2d72ec1b1ba007897f6f5bfa6a6e4c050e53d9。在线工程 F 月度核验已完成；原有真实成本与研究停止结论保持。视觉仍未达到参考站标准。SimBench 德国历史来源，非中国园区实测。</a:t>
+              <a:t>当前界面截图：validation/facade-assets-2026-10-08/energy-clean-1366.jpg SHA256 10391d953ca7c49965fe733c9dac45d981ea8b2f0f89aca50bcf56257b3f6d78。在线工程 F 月度核验已完成；原有真实成本与研究停止结论保持。视觉仍未达到参考站标准。SimBench 德国历史来源，非中国园区实测。</a:t>
             </a:r>
           </a:p>
         </p:txBody>
@@ -843,7 +843,7 @@
           <a:lstStyle xmlns:a="http://schemas.openxmlformats.org/drawingml/2006/main"/>
           <a:p xmlns:a="http://schemas.openxmlformats.org/drawingml/2006/main">
             <a:r>
-              <a:t>当前界面截图：validation/visual-recovery-2026-10-07/day-overview-1366-final.png SHA256 12786192507f120fd156691ecd4f11441c974e036ae3d51a042ada3cd171e8bf。仅更新界面截图；原有真实成本与研究停止结论保持。视觉仍未达到参考站标准。SimBench 德国历史来源，非中国园区实测。</a:t>
+              <a:t>当前界面截图：validation/facade-assets-2026-10-08/overview-clean-1366.jpg SHA256 7d5ccc29b1cc42dceec041c1cf8d405de4f2bc702e6090feddf3911781c93718。在线工程 F 月度核验已完成；原有真实成本与研究停止结论保持。视觉仍未达到参考站标准。SimBench 德国历史来源，非中国园区实测。</a:t>
             </a:r>
           </a:p>
         </p:txBody>
@@ -1651,7 +1651,7 @@
   </p:cSld>
   <p:clrMap bg1="lt1" tx1="dk1" bg2="lt2" tx2="dk2" accent1="accent1" accent2="accent2" accent3="accent3" accent4="accent4" accent5="accent5" accent6="accent6" hlink="hlink" folHlink="folHlink"/>
   <p:sldLayoutIdLst>
-    <p:sldLayoutId xmlns:r="http://schemas.openxmlformats.org/officeDocument/2006/relationships" id="2147483649" r:id="Re26d2e01fd474203"/>
+    <p:sldLayoutId xmlns:r="http://schemas.openxmlformats.org/officeDocument/2006/relationships" id="2147483649" r:id="R4fefc6ddc5974889"/>
   </p:sldLayoutIdLst>
   <p:txStyles>
     <p:titleStyle>
@@ -2929,7 +2929,7 @@
           <p:cNvPr id="16" name="">
             <a:extLst xmlns:a="http://schemas.openxmlformats.org/drawingml/2006/main">
               <a:ext uri="{FF2B5EF4-FFF2-40B4-BE49-F238E27FC236}">
-                <a16:creationId xmlns:a16="http://schemas.microsoft.com/office/drawing/2014/main" id="{8E4F639D-3BA2-40B5-B21C-6843C19DF5A4}"/>
+                <a16:creationId xmlns:a16="http://schemas.microsoft.com/office/drawing/2014/main" id="{A9033E12-C946-40E9-90FF-A317BF3461E4}"/>
               </a:ext>
             </a:extLst>
           </p:cNvPr>
@@ -3634,7 +3634,7 @@
           <p:cNvPr id="15" name="">
             <a:extLst xmlns:a="http://schemas.openxmlformats.org/drawingml/2006/main">
               <a:ext uri="{FF2B5EF4-FFF2-40B4-BE49-F238E27FC236}">
-                <a16:creationId xmlns:a16="http://schemas.microsoft.com/office/drawing/2014/main" id="{3EF3547E-6A5B-4307-A46C-E9C97198596A}"/>
+                <a16:creationId xmlns:a16="http://schemas.microsoft.com/office/drawing/2014/main" id="{72BD6881-27FA-4B88-B944-BC66BA98178D}"/>
               </a:ext>
             </a:extLst>
           </p:cNvPr>
@@ -4682,7 +4682,7 @@
           <p:cNvPr id="13" name="">
             <a:extLst xmlns:a="http://schemas.openxmlformats.org/drawingml/2006/main">
               <a:ext uri="{FF2B5EF4-FFF2-40B4-BE49-F238E27FC236}">
-                <a16:creationId xmlns:a16="http://schemas.microsoft.com/office/drawing/2014/main" id="{186E3259-ECD1-4BDC-AF2E-BE91D6FAD5D5}"/>
+                <a16:creationId xmlns:a16="http://schemas.microsoft.com/office/drawing/2014/main" id="{5B17732E-4449-420A-977B-166522322070}"/>
               </a:ext>
             </a:extLst>
           </p:cNvPr>
@@ -4692,7 +4692,7 @@
           <p:nvPr/>
         </p:nvPicPr>
         <p:blipFill>
-          <a:blip xmlns:r="http://schemas.openxmlformats.org/officeDocument/2006/relationships" xmlns:a="http://schemas.openxmlformats.org/drawingml/2006/main" r:embed="Rb0d9d23d746d4287"/>
+          <a:blip xmlns:r="http://schemas.openxmlformats.org/officeDocument/2006/relationships" xmlns:a="http://schemas.openxmlformats.org/drawingml/2006/main" r:embed="Rdf5f7ad2a56d4263"/>
           <a:srcRect xmlns:a="http://schemas.openxmlformats.org/drawingml/2006/main" l="0" t="0" r="0" b="0"/>
           <a:stretch xmlns:a="http://schemas.openxmlformats.org/drawingml/2006/main">
             <a:fillRect l="0" t="0" r="0" b="0"/>
@@ -5062,7 +5062,7 @@
           <p:cNvPr id="13" name="">
             <a:extLst xmlns:a="http://schemas.openxmlformats.org/drawingml/2006/main">
               <a:ext uri="{FF2B5EF4-FFF2-40B4-BE49-F238E27FC236}">
-                <a16:creationId xmlns:a16="http://schemas.microsoft.com/office/drawing/2014/main" id="{A507D5F3-FC6D-4D11-97B2-81D124802A11}"/>
+                <a16:creationId xmlns:a16="http://schemas.microsoft.com/office/drawing/2014/main" id="{ABF2E947-846A-44D9-BA50-9BA245B9A7E7}"/>
               </a:ext>
             </a:extLst>
           </p:cNvPr>
@@ -5072,7 +5072,7 @@
           <p:nvPr/>
         </p:nvPicPr>
         <p:blipFill>
-          <a:blip xmlns:r="http://schemas.openxmlformats.org/officeDocument/2006/relationships" xmlns:a="http://schemas.openxmlformats.org/drawingml/2006/main" r:embed="R089688ecdd4844a8"/>
+          <a:blip xmlns:r="http://schemas.openxmlformats.org/officeDocument/2006/relationships" xmlns:a="http://schemas.openxmlformats.org/drawingml/2006/main" r:embed="R2f44af7f9f33404f"/>
           <a:srcRect xmlns:a="http://schemas.openxmlformats.org/drawingml/2006/main" l="0" t="2306" r="0" b="2306"/>
           <a:stretch xmlns:a="http://schemas.openxmlformats.org/drawingml/2006/main">
             <a:fillRect l="0" t="0" r="0" b="0"/>
@@ -5442,7 +5442,7 @@
           <p:cNvPr id="13" name="">
             <a:extLst xmlns:a="http://schemas.openxmlformats.org/drawingml/2006/main">
               <a:ext uri="{FF2B5EF4-FFF2-40B4-BE49-F238E27FC236}">
-                <a16:creationId xmlns:a16="http://schemas.microsoft.com/office/drawing/2014/main" id="{6C1F0EF7-D9B6-406F-BA4C-4EFF488AC487}"/>
+                <a16:creationId xmlns:a16="http://schemas.microsoft.com/office/drawing/2014/main" id="{E76DE528-5C38-404B-AD8C-F916234CB57C}"/>
               </a:ext>
             </a:extLst>
           </p:cNvPr>
@@ -6197,7 +6197,7 @@
           <p:cNvPr id="15" name="">
             <a:extLst xmlns:a="http://schemas.openxmlformats.org/drawingml/2006/main">
               <a:ext uri="{FF2B5EF4-FFF2-40B4-BE49-F238E27FC236}">
-                <a16:creationId xmlns:a16="http://schemas.microsoft.com/office/drawing/2014/main" id="{04FD8593-AAE5-4AF9-A54D-8AD97A509992}"/>
+                <a16:creationId xmlns:a16="http://schemas.microsoft.com/office/drawing/2014/main" id="{4300D48C-D1A0-4E59-997C-5A8242E1BF9A}"/>
               </a:ext>
             </a:extLst>
           </p:cNvPr>
@@ -7245,7 +7245,7 @@
           <p:cNvPr id="14" name="">
             <a:extLst xmlns:a="http://schemas.openxmlformats.org/drawingml/2006/main">
               <a:ext uri="{FF2B5EF4-FFF2-40B4-BE49-F238E27FC236}">
-                <a16:creationId xmlns:a16="http://schemas.microsoft.com/office/drawing/2014/main" id="{C322D375-6B8E-4659-80C7-A539B805D743}"/>
+                <a16:creationId xmlns:a16="http://schemas.microsoft.com/office/drawing/2014/main" id="{D9DEC26E-D9B9-424C-AEEA-75B04EF856C1}"/>
               </a:ext>
             </a:extLst>
           </p:cNvPr>
@@ -8130,7 +8130,7 @@
           <p:cNvPr id="14" name="">
             <a:extLst xmlns:a="http://schemas.openxmlformats.org/drawingml/2006/main">
               <a:ext uri="{FF2B5EF4-FFF2-40B4-BE49-F238E27FC236}">
-                <a16:creationId xmlns:a16="http://schemas.microsoft.com/office/drawing/2014/main" id="{26B85A44-64DC-4541-9788-06AA837E3008}"/>
+                <a16:creationId xmlns:a16="http://schemas.microsoft.com/office/drawing/2014/main" id="{CC646358-0793-4BB7-8097-1986981AAEE3}"/>
               </a:ext>
             </a:extLst>
           </p:cNvPr>
@@ -8966,7 +8966,7 @@
           <p:cNvPr id="14" name="">
             <a:extLst xmlns:a="http://schemas.openxmlformats.org/drawingml/2006/main">
               <a:ext uri="{FF2B5EF4-FFF2-40B4-BE49-F238E27FC236}">
-                <a16:creationId xmlns:a16="http://schemas.microsoft.com/office/drawing/2014/main" id="{55619B90-3ED5-413E-B84B-395EF07CCC9D}"/>
+                <a16:creationId xmlns:a16="http://schemas.microsoft.com/office/drawing/2014/main" id="{C948E008-3E84-47D5-A0E2-F3261E417073}"/>
               </a:ext>
             </a:extLst>
           </p:cNvPr>
@@ -10459,7 +10459,7 @@
           <p:cNvPr id="14" name="">
             <a:extLst xmlns:a="http://schemas.openxmlformats.org/drawingml/2006/main">
               <a:ext uri="{FF2B5EF4-FFF2-40B4-BE49-F238E27FC236}">
-                <a16:creationId xmlns:a16="http://schemas.microsoft.com/office/drawing/2014/main" id="{F82D058B-B5BB-4EF4-8E01-46B1BD460E04}"/>
+                <a16:creationId xmlns:a16="http://schemas.microsoft.com/office/drawing/2014/main" id="{5B6ED71D-7686-4B5D-8A13-3D2B2862E7F3}"/>
               </a:ext>
             </a:extLst>
           </p:cNvPr>

</xml_diff>

<commit_message>
Add recorded cooperation tour and actual 3D line flows; clarify program evidence
</commit_message>
<xml_diff>
--- a/downloads/energy-campus-v3.2.pptx
+++ b/downloads/energy-campus-v3.2.pptx
@@ -2,24 +2,24 @@
 <file path=ppt/presentation.xml><?xml version="1.0" encoding="utf-8"?>
 <p:presentation xmlns:p="http://schemas.openxmlformats.org/presentationml/2006/main">
   <p:sldMasterIdLst>
-    <p:sldMasterId xmlns:r="http://schemas.openxmlformats.org/officeDocument/2006/relationships" id="2147483648" r:id="Rc8ce06397c5e44d1"/>
+    <p:sldMasterId xmlns:r="http://schemas.openxmlformats.org/officeDocument/2006/relationships" id="2147483648" r:id="R948facc9048145d6"/>
   </p:sldMasterIdLst>
   <p:notesMasterIdLst>
-    <p:notesMasterId xmlns:r="http://schemas.openxmlformats.org/officeDocument/2006/relationships" r:id="R51b98a70e84444ed"/>
+    <p:notesMasterId xmlns:r="http://schemas.openxmlformats.org/officeDocument/2006/relationships" r:id="Rd7332f1a2bee4c7d"/>
   </p:notesMasterIdLst>
   <p:sldIdLst>
-    <p:sldId xmlns:r="http://schemas.openxmlformats.org/officeDocument/2006/relationships" id="256" r:id="R196234dc87ed4f23"/>
-    <p:sldId xmlns:r="http://schemas.openxmlformats.org/officeDocument/2006/relationships" id="257" r:id="Re925a38428d249f1"/>
-    <p:sldId xmlns:r="http://schemas.openxmlformats.org/officeDocument/2006/relationships" id="258" r:id="R396cadd5e0eb4698"/>
-    <p:sldId xmlns:r="http://schemas.openxmlformats.org/officeDocument/2006/relationships" id="259" r:id="Rc04b00c4cc684bda"/>
-    <p:sldId xmlns:r="http://schemas.openxmlformats.org/officeDocument/2006/relationships" id="260" r:id="Ra6179f84bc6246af"/>
-    <p:sldId xmlns:r="http://schemas.openxmlformats.org/officeDocument/2006/relationships" id="261" r:id="Rd52ba8ce87224daf"/>
-    <p:sldId xmlns:r="http://schemas.openxmlformats.org/officeDocument/2006/relationships" id="262" r:id="R536d132b983442b9"/>
-    <p:sldId xmlns:r="http://schemas.openxmlformats.org/officeDocument/2006/relationships" id="263" r:id="Rabf95570187a46f9"/>
-    <p:sldId xmlns:r="http://schemas.openxmlformats.org/officeDocument/2006/relationships" id="264" r:id="R1ffa9284acc04f40"/>
-    <p:sldId xmlns:r="http://schemas.openxmlformats.org/officeDocument/2006/relationships" id="265" r:id="Re852fd5ddb174e8f"/>
-    <p:sldId xmlns:r="http://schemas.openxmlformats.org/officeDocument/2006/relationships" id="266" r:id="R504308d9f3d14cdd"/>
-    <p:sldId xmlns:r="http://schemas.openxmlformats.org/officeDocument/2006/relationships" id="267" r:id="R1c4bc5b528e34be3"/>
+    <p:sldId xmlns:r="http://schemas.openxmlformats.org/officeDocument/2006/relationships" id="256" r:id="R826f92aef4fb41c2"/>
+    <p:sldId xmlns:r="http://schemas.openxmlformats.org/officeDocument/2006/relationships" id="257" r:id="R241f24a80ac54166"/>
+    <p:sldId xmlns:r="http://schemas.openxmlformats.org/officeDocument/2006/relationships" id="258" r:id="Rebb08b99fd064453"/>
+    <p:sldId xmlns:r="http://schemas.openxmlformats.org/officeDocument/2006/relationships" id="259" r:id="R0e8abf4599f044ae"/>
+    <p:sldId xmlns:r="http://schemas.openxmlformats.org/officeDocument/2006/relationships" id="260" r:id="R6b8fc3afeeb24c0f"/>
+    <p:sldId xmlns:r="http://schemas.openxmlformats.org/officeDocument/2006/relationships" id="261" r:id="Rec3e23f916d24d6b"/>
+    <p:sldId xmlns:r="http://schemas.openxmlformats.org/officeDocument/2006/relationships" id="262" r:id="R65cb064c16b84793"/>
+    <p:sldId xmlns:r="http://schemas.openxmlformats.org/officeDocument/2006/relationships" id="263" r:id="R13021e70dc714145"/>
+    <p:sldId xmlns:r="http://schemas.openxmlformats.org/officeDocument/2006/relationships" id="264" r:id="R7c991619fdbc4606"/>
+    <p:sldId xmlns:r="http://schemas.openxmlformats.org/officeDocument/2006/relationships" id="265" r:id="R2d00137ff0e04dd7"/>
+    <p:sldId xmlns:r="http://schemas.openxmlformats.org/officeDocument/2006/relationships" id="266" r:id="R0dda07b63a8d46e0"/>
+    <p:sldId xmlns:r="http://schemas.openxmlformats.org/officeDocument/2006/relationships" id="267" r:id="R8216b6fae3c6406b"/>
   </p:sldIdLst>
   <p:sldSz cx="12192000" cy="6858000"/>
   <p:notesSz cx="6858000" cy="9144000"/>
@@ -773,7 +773,7 @@
           <a:lstStyle xmlns:a="http://schemas.openxmlformats.org/drawingml/2006/main"/>
           <a:p xmlns:a="http://schemas.openxmlformats.org/drawingml/2006/main">
             <a:r>
-              <a:t>当前界面截图：validation/facade-assets-2026-10-08/energy-clean-1366.jpg SHA256 10391d953ca7c49965fe733c9dac45d981ea8b2f0f89aca50bcf56257b3f6d78。在线工程 F 月度核验已完成；原有真实成本与研究停止结论保持。视觉仍未达到参考站标准。SimBench 德国历史来源，非中国园区实测。</a:t>
+              <a:t>当前界面截图：validation/process-story-2026-10-08/story-1366.jpg SHA256 1ca1bc8af218beab3eaff05cc8b1c48bb824a0a778d4f6fbfdf323368b8a012c。在线工程 F 月度核验已完成；原有真实成本与研究停止结论保持。视觉仍未达到参考站标准。SimBench 德国历史来源，非中国园区实测。</a:t>
             </a:r>
           </a:p>
         </p:txBody>
@@ -843,7 +843,7 @@
           <a:lstStyle xmlns:a="http://schemas.openxmlformats.org/drawingml/2006/main"/>
           <a:p xmlns:a="http://schemas.openxmlformats.org/drawingml/2006/main">
             <a:r>
-              <a:t>当前界面截图：validation/facade-assets-2026-10-08/overview-clean-1366.jpg SHA256 7d5ccc29b1cc42dceec041c1cf8d405de4f2bc702e6090feddf3911781c93718。在线工程 F 月度核验已完成；原有真实成本与研究停止结论保持。视觉仍未达到参考站标准。SimBench 德国历史来源，非中国园区实测。</a:t>
+              <a:t>当前界面截图：validation/process-story-2026-10-08/overview-1366.jpg SHA256 f70994d15c1c6c87a89b7301f54a5cc91ef83becaf1ca369a3dc151b09abf595。在线工程 F 月度核验已完成；原有真实成本与研究停止结论保持。视觉仍未达到参考站标准。SimBench 德国历史来源，非中国园区实测。</a:t>
             </a:r>
           </a:p>
         </p:txBody>
@@ -1269,6 +1269,11 @@
           <a:p xmlns:a="http://schemas.openxmlformats.org/drawingml/2006/main">
             <a:r>
               <a:t>当前固定在线工程 F：cf6c589c3f461ec4，触发时刻 2026-06-02 08:00 Asia/Shanghai。MPC 108174.15 元；情景 MPC 108295.91 元，均合格。每方法 2880 AC / 2784 MILP。该程序由人工固定，不包含候选晋升、G 演化或继承优势。原研究停止与原工具对照不变；不能将不同程序与情景工具的费用差归因为 RSI。证据 validation/live-f-2026-10-08/acceptance.json SHA256 a026156041af5b7b22663b18c9fd58e4979a2cef80c6ef4113bba78f2376b8cb</a:t>
+            </a:r>
+          </a:p>
+          <a:p xmlns:a="http://schemas.openxmlformats.org/drawingml/2006/main">
+            <a:r>
+              <a:t>新协议仅准备，尚未准入或执行目标数据。严格表达式拒绝缺失观测，G共同总额度分配和已验证F版本加载/执行/中断恢复均仅合成软件核验。真实晋升仍0。原研究与已揭示留出保持；协议 validation/rsi-next-protocol-2026-10-08/protocol.json SHA256 2e695233909c261626f024667ff024d8d3563102e5eeb2a670e1c802729cec24</a:t>
             </a:r>
           </a:p>
         </p:txBody>
@@ -1651,7 +1656,7 @@
   </p:cSld>
   <p:clrMap bg1="lt1" tx1="dk1" bg2="lt2" tx2="dk2" accent1="accent1" accent2="accent2" accent3="accent3" accent4="accent4" accent5="accent5" accent6="accent6" hlink="hlink" folHlink="folHlink"/>
   <p:sldLayoutIdLst>
-    <p:sldLayoutId xmlns:r="http://schemas.openxmlformats.org/officeDocument/2006/relationships" id="2147483649" r:id="R4fefc6ddc5974889"/>
+    <p:sldLayoutId xmlns:r="http://schemas.openxmlformats.org/officeDocument/2006/relationships" id="2147483649" r:id="R3e2d02fadf5b4cb1"/>
   </p:sldLayoutIdLst>
   <p:txStyles>
     <p:titleStyle>
@@ -2929,7 +2934,7 @@
           <p:cNvPr id="16" name="">
             <a:extLst xmlns:a="http://schemas.openxmlformats.org/drawingml/2006/main">
               <a:ext uri="{FF2B5EF4-FFF2-40B4-BE49-F238E27FC236}">
-                <a16:creationId xmlns:a16="http://schemas.microsoft.com/office/drawing/2014/main" id="{A9033E12-C946-40E9-90FF-A317BF3461E4}"/>
+                <a16:creationId xmlns:a16="http://schemas.microsoft.com/office/drawing/2014/main" id="{8CE88E28-494D-4B11-A9C2-92F79A64E05E}"/>
               </a:ext>
             </a:extLst>
           </p:cNvPr>
@@ -3634,7 +3639,7 @@
           <p:cNvPr id="15" name="">
             <a:extLst xmlns:a="http://schemas.openxmlformats.org/drawingml/2006/main">
               <a:ext uri="{FF2B5EF4-FFF2-40B4-BE49-F238E27FC236}">
-                <a16:creationId xmlns:a16="http://schemas.microsoft.com/office/drawing/2014/main" id="{72BD6881-27FA-4B88-B944-BC66BA98178D}"/>
+                <a16:creationId xmlns:a16="http://schemas.microsoft.com/office/drawing/2014/main" id="{E7091325-C12C-4B0D-9E5E-371EFAD6B643}"/>
               </a:ext>
             </a:extLst>
           </p:cNvPr>
@@ -4682,7 +4687,7 @@
           <p:cNvPr id="13" name="">
             <a:extLst xmlns:a="http://schemas.openxmlformats.org/drawingml/2006/main">
               <a:ext uri="{FF2B5EF4-FFF2-40B4-BE49-F238E27FC236}">
-                <a16:creationId xmlns:a16="http://schemas.microsoft.com/office/drawing/2014/main" id="{5B17732E-4449-420A-977B-166522322070}"/>
+                <a16:creationId xmlns:a16="http://schemas.microsoft.com/office/drawing/2014/main" id="{5A39673A-4F5C-4BDC-BA1E-300C238572F2}"/>
               </a:ext>
             </a:extLst>
           </p:cNvPr>
@@ -4692,7 +4697,7 @@
           <p:nvPr/>
         </p:nvPicPr>
         <p:blipFill>
-          <a:blip xmlns:r="http://schemas.openxmlformats.org/officeDocument/2006/relationships" xmlns:a="http://schemas.openxmlformats.org/drawingml/2006/main" r:embed="Rdf5f7ad2a56d4263"/>
+          <a:blip xmlns:r="http://schemas.openxmlformats.org/officeDocument/2006/relationships" xmlns:a="http://schemas.openxmlformats.org/drawingml/2006/main" r:embed="R544ba316b87e4d93"/>
           <a:srcRect xmlns:a="http://schemas.openxmlformats.org/drawingml/2006/main" l="0" t="0" r="0" b="0"/>
           <a:stretch xmlns:a="http://schemas.openxmlformats.org/drawingml/2006/main">
             <a:fillRect l="0" t="0" r="0" b="0"/>
@@ -4761,7 +4766,7 @@
                 <a:ea typeface="Hiragino Sans GB"/>
                 <a:cs typeface="Hiragino Sans GB"/>
               </a:rPr>
-              <a:t>在线：六月回放、逐时工程 F 与异常证据；本机：参数、导入与复算</a:t>
+              <a:t>在线：六月协同导览与真实线路潮流；本机：工程 F、导入与复算</a:t>
             </a:r>
           </a:p>
         </p:txBody>
@@ -5062,7 +5067,7 @@
           <p:cNvPr id="13" name="">
             <a:extLst xmlns:a="http://schemas.openxmlformats.org/drawingml/2006/main">
               <a:ext uri="{FF2B5EF4-FFF2-40B4-BE49-F238E27FC236}">
-                <a16:creationId xmlns:a16="http://schemas.microsoft.com/office/drawing/2014/main" id="{ABF2E947-846A-44D9-BA50-9BA245B9A7E7}"/>
+                <a16:creationId xmlns:a16="http://schemas.microsoft.com/office/drawing/2014/main" id="{ED3D2314-626A-459A-BBD7-A719B117ECC6}"/>
               </a:ext>
             </a:extLst>
           </p:cNvPr>
@@ -5072,7 +5077,7 @@
           <p:nvPr/>
         </p:nvPicPr>
         <p:blipFill>
-          <a:blip xmlns:r="http://schemas.openxmlformats.org/officeDocument/2006/relationships" xmlns:a="http://schemas.openxmlformats.org/drawingml/2006/main" r:embed="R2f44af7f9f33404f"/>
+          <a:blip xmlns:r="http://schemas.openxmlformats.org/officeDocument/2006/relationships" xmlns:a="http://schemas.openxmlformats.org/drawingml/2006/main" r:embed="Rae98bbc0cffb47cf"/>
           <a:srcRect xmlns:a="http://schemas.openxmlformats.org/drawingml/2006/main" l="0" t="2306" r="0" b="2306"/>
           <a:stretch xmlns:a="http://schemas.openxmlformats.org/drawingml/2006/main">
             <a:fillRect l="0" t="0" r="0" b="0"/>
@@ -5141,7 +5146,7 @@
                 <a:ea typeface="Hiragino Sans GB"/>
                 <a:cs typeface="Hiragino Sans GB"/>
               </a:rPr>
-              <a:t>日期与方案共用播放时钟；日景、夜景、设备近景与线路图</a:t>
+              <a:t>45秒真实会话导览；三维线路潮流与设备状态共用播放时钟</a:t>
             </a:r>
           </a:p>
         </p:txBody>
@@ -5442,7 +5447,7 @@
           <p:cNvPr id="13" name="">
             <a:extLst xmlns:a="http://schemas.openxmlformats.org/drawingml/2006/main">
               <a:ext uri="{FF2B5EF4-FFF2-40B4-BE49-F238E27FC236}">
-                <a16:creationId xmlns:a16="http://schemas.microsoft.com/office/drawing/2014/main" id="{E76DE528-5C38-404B-AD8C-F916234CB57C}"/>
+                <a16:creationId xmlns:a16="http://schemas.microsoft.com/office/drawing/2014/main" id="{1115A6AF-E2CC-47C3-B18B-53C58785F8A2}"/>
               </a:ext>
             </a:extLst>
           </p:cNvPr>
@@ -6197,7 +6202,7 @@
           <p:cNvPr id="15" name="">
             <a:extLst xmlns:a="http://schemas.openxmlformats.org/drawingml/2006/main">
               <a:ext uri="{FF2B5EF4-FFF2-40B4-BE49-F238E27FC236}">
-                <a16:creationId xmlns:a16="http://schemas.microsoft.com/office/drawing/2014/main" id="{4300D48C-D1A0-4E59-997C-5A8242E1BF9A}"/>
+                <a16:creationId xmlns:a16="http://schemas.microsoft.com/office/drawing/2014/main" id="{41AB7ECA-9594-44E0-B6F2-A7F9267C4ABA}"/>
               </a:ext>
             </a:extLst>
           </p:cNvPr>
@@ -7245,7 +7250,7 @@
           <p:cNvPr id="14" name="">
             <a:extLst xmlns:a="http://schemas.openxmlformats.org/drawingml/2006/main">
               <a:ext uri="{FF2B5EF4-FFF2-40B4-BE49-F238E27FC236}">
-                <a16:creationId xmlns:a16="http://schemas.microsoft.com/office/drawing/2014/main" id="{D9DEC26E-D9B9-424C-AEEA-75B04EF856C1}"/>
+                <a16:creationId xmlns:a16="http://schemas.microsoft.com/office/drawing/2014/main" id="{6A49FD72-20DD-4BA3-9AF6-204F81315D87}"/>
               </a:ext>
             </a:extLst>
           </p:cNvPr>
@@ -8130,7 +8135,7 @@
           <p:cNvPr id="14" name="">
             <a:extLst xmlns:a="http://schemas.openxmlformats.org/drawingml/2006/main">
               <a:ext uri="{FF2B5EF4-FFF2-40B4-BE49-F238E27FC236}">
-                <a16:creationId xmlns:a16="http://schemas.microsoft.com/office/drawing/2014/main" id="{CC646358-0793-4BB7-8097-1986981AAEE3}"/>
+                <a16:creationId xmlns:a16="http://schemas.microsoft.com/office/drawing/2014/main" id="{FC8DC74E-8225-4681-BE55-64240E2D0D84}"/>
               </a:ext>
             </a:extLst>
           </p:cNvPr>
@@ -8459,7 +8464,7 @@
                           <a:ea typeface="Hiragino Sans GB"/>
                           <a:cs typeface="Hiragino Sans GB"/>
                         </a:rPr>
-                        <a:t>在线工程 F 已执行；程序固定</a:t>
+                        <a:t>固定 F 在线；版本执行仅合成核验</a:t>
                       </a:r>
                     </a:p>
                   </a:txBody>
@@ -8539,7 +8544,7 @@
                           <a:ea typeface="Hiragino Sans GB"/>
                           <a:cs typeface="Hiragino Sans GB"/>
                         </a:rPr>
-                        <a:t>继承机制已实现，实际晋升 0</a:t>
+                        <a:t>统一总预算核验；真实晋升 0</a:t>
                       </a:r>
                     </a:p>
                   </a:txBody>
@@ -8966,7 +8971,7 @@
           <p:cNvPr id="14" name="">
             <a:extLst xmlns:a="http://schemas.openxmlformats.org/drawingml/2006/main">
               <a:ext uri="{FF2B5EF4-FFF2-40B4-BE49-F238E27FC236}">
-                <a16:creationId xmlns:a16="http://schemas.microsoft.com/office/drawing/2014/main" id="{C948E008-3E84-47D5-A0E2-F3261E417073}"/>
+                <a16:creationId xmlns:a16="http://schemas.microsoft.com/office/drawing/2014/main" id="{C03D11EE-9E53-4CBE-97E4-8FEEBA3D3F18}"/>
               </a:ext>
             </a:extLst>
           </p:cNvPr>
@@ -10459,7 +10464,7 @@
           <p:cNvPr id="14" name="">
             <a:extLst xmlns:a="http://schemas.openxmlformats.org/drawingml/2006/main">
               <a:ext uri="{FF2B5EF4-FFF2-40B4-BE49-F238E27FC236}">
-                <a16:creationId xmlns:a16="http://schemas.microsoft.com/office/drawing/2014/main" id="{5B6ED71D-7686-4B5D-8A13-3D2B2862E7F3}"/>
+                <a16:creationId xmlns:a16="http://schemas.microsoft.com/office/drawing/2014/main" id="{B377FC10-5B52-474A-B063-4EF5F9D75AC1}"/>
               </a:ext>
             </a:extLst>
           </p:cNvPr>

</xml_diff>